<commit_message>
CAMBIOS POR IMPORTACION DE PIELES 15032021
</commit_message>
<xml_diff>
--- a/Scripts_R100_Materiales/Folios_Transaccion/Docs/IT_DEV_FOLIOS_22102020.pptx
+++ b/Scripts_R100_Materiales/Folios_Transaccion/Docs/IT_DEV_FOLIOS_22102020.pptx
@@ -5,11 +5,13 @@
     <p:sldMasterId id="2147483648" r:id="rId1"/>
   </p:sldMasterIdLst>
   <p:notesMasterIdLst>
-    <p:notesMasterId r:id="rId4"/>
+    <p:notesMasterId r:id="rId6"/>
   </p:notesMasterIdLst>
   <p:sldIdLst>
-    <p:sldId id="344" r:id="rId2"/>
-    <p:sldId id="396" r:id="rId3"/>
+    <p:sldId id="398" r:id="rId2"/>
+    <p:sldId id="397" r:id="rId3"/>
+    <p:sldId id="344" r:id="rId4"/>
+    <p:sldId id="396" r:id="rId5"/>
   </p:sldIdLst>
   <p:sldSz cx="9144000" cy="6858000" type="screen4x3"/>
   <p:notesSz cx="6858000" cy="9144000"/>
@@ -209,7 +211,7 @@
           <a:p>
             <a:fld id="{A17B1792-3256-4E77-8442-3E205CD69EF5}" type="datetimeFigureOut">
               <a:rPr lang="en-US" smtClean="0"/>
-              <a:t>10/22/2020</a:t>
+              <a:t>3/13/2021</a:t>
             </a:fld>
             <a:endParaRPr lang="en-US"/>
           </a:p>
@@ -655,7 +657,7 @@
           <a:p>
             <a:fld id="{07558649-2619-44F9-8F30-2D6466E57529}" type="datetimeFigureOut">
               <a:rPr lang="en-US" smtClean="0"/>
-              <a:t>10/22/2020</a:t>
+              <a:t>3/13/2021</a:t>
             </a:fld>
             <a:endParaRPr lang="en-US"/>
           </a:p>
@@ -823,7 +825,7 @@
           <a:p>
             <a:fld id="{07558649-2619-44F9-8F30-2D6466E57529}" type="datetimeFigureOut">
               <a:rPr lang="en-US" smtClean="0"/>
-              <a:t>10/22/2020</a:t>
+              <a:t>3/13/2021</a:t>
             </a:fld>
             <a:endParaRPr lang="en-US"/>
           </a:p>
@@ -1001,7 +1003,7 @@
           <a:p>
             <a:fld id="{07558649-2619-44F9-8F30-2D6466E57529}" type="datetimeFigureOut">
               <a:rPr lang="en-US" smtClean="0"/>
-              <a:t>10/22/2020</a:t>
+              <a:t>3/13/2021</a:t>
             </a:fld>
             <a:endParaRPr lang="en-US"/>
           </a:p>
@@ -1169,7 +1171,7 @@
           <a:p>
             <a:fld id="{07558649-2619-44F9-8F30-2D6466E57529}" type="datetimeFigureOut">
               <a:rPr lang="en-US" smtClean="0"/>
-              <a:t>10/22/2020</a:t>
+              <a:t>3/13/2021</a:t>
             </a:fld>
             <a:endParaRPr lang="en-US"/>
           </a:p>
@@ -1414,7 +1416,7 @@
           <a:p>
             <a:fld id="{07558649-2619-44F9-8F30-2D6466E57529}" type="datetimeFigureOut">
               <a:rPr lang="en-US" smtClean="0"/>
-              <a:t>10/22/2020</a:t>
+              <a:t>3/13/2021</a:t>
             </a:fld>
             <a:endParaRPr lang="en-US"/>
           </a:p>
@@ -1699,7 +1701,7 @@
           <a:p>
             <a:fld id="{07558649-2619-44F9-8F30-2D6466E57529}" type="datetimeFigureOut">
               <a:rPr lang="en-US" smtClean="0"/>
-              <a:t>10/22/2020</a:t>
+              <a:t>3/13/2021</a:t>
             </a:fld>
             <a:endParaRPr lang="en-US"/>
           </a:p>
@@ -2118,7 +2120,7 @@
           <a:p>
             <a:fld id="{07558649-2619-44F9-8F30-2D6466E57529}" type="datetimeFigureOut">
               <a:rPr lang="en-US" smtClean="0"/>
-              <a:t>10/22/2020</a:t>
+              <a:t>3/13/2021</a:t>
             </a:fld>
             <a:endParaRPr lang="en-US"/>
           </a:p>
@@ -2235,7 +2237,7 @@
           <a:p>
             <a:fld id="{07558649-2619-44F9-8F30-2D6466E57529}" type="datetimeFigureOut">
               <a:rPr lang="en-US" smtClean="0"/>
-              <a:t>10/22/2020</a:t>
+              <a:t>3/13/2021</a:t>
             </a:fld>
             <a:endParaRPr lang="en-US"/>
           </a:p>
@@ -2330,7 +2332,7 @@
           <a:p>
             <a:fld id="{07558649-2619-44F9-8F30-2D6466E57529}" type="datetimeFigureOut">
               <a:rPr lang="en-US" smtClean="0"/>
-              <a:t>10/22/2020</a:t>
+              <a:t>3/13/2021</a:t>
             </a:fld>
             <a:endParaRPr lang="en-US"/>
           </a:p>
@@ -2605,7 +2607,7 @@
           <a:p>
             <a:fld id="{07558649-2619-44F9-8F30-2D6466E57529}" type="datetimeFigureOut">
               <a:rPr lang="en-US" smtClean="0"/>
-              <a:t>10/22/2020</a:t>
+              <a:t>3/13/2021</a:t>
             </a:fld>
             <a:endParaRPr lang="en-US"/>
           </a:p>
@@ -2857,7 +2859,7 @@
           <a:p>
             <a:fld id="{07558649-2619-44F9-8F30-2D6466E57529}" type="datetimeFigureOut">
               <a:rPr lang="en-US" smtClean="0"/>
-              <a:t>10/22/2020</a:t>
+              <a:t>3/13/2021</a:t>
             </a:fld>
             <a:endParaRPr lang="en-US"/>
           </a:p>
@@ -3077,7 +3079,7 @@
           <a:p>
             <a:fld id="{07558649-2619-44F9-8F30-2D6466E57529}" type="datetimeFigureOut">
               <a:rPr lang="en-US" smtClean="0"/>
-              <a:t>10/22/2020</a:t>
+              <a:t>3/13/2021</a:t>
             </a:fld>
             <a:endParaRPr lang="en-US"/>
           </a:p>
@@ -3494,6 +3496,452 @@
               <a:rPr lang="es-MX" b="1" dirty="0">
                 <a:latin typeface="Century Gothic" panose="020B0502020202020204" pitchFamily="34" charset="0"/>
               </a:rPr>
+              <a:t>06/03/2021 – 13/03/2021</a:t>
+            </a:r>
+            <a:endParaRPr lang="es-MX" dirty="0">
+              <a:latin typeface="Century Gothic" panose="020B0502020202020204" pitchFamily="34" charset="0"/>
+            </a:endParaRPr>
+          </a:p>
+        </p:txBody>
+      </p:sp>
+    </p:spTree>
+    <p:extLst>
+      <p:ext uri="{BB962C8B-B14F-4D97-AF65-F5344CB8AC3E}">
+        <p14:creationId xmlns:p14="http://schemas.microsoft.com/office/powerpoint/2010/main" val="985878630"/>
+      </p:ext>
+    </p:extLst>
+  </p:cSld>
+  <p:clrMapOvr>
+    <a:masterClrMapping/>
+  </p:clrMapOvr>
+</p:sld>
+</file>
+
+<file path=ppt/slides/slide2.xml><?xml version="1.0" encoding="utf-8"?>
+<p:sld xmlns:a="http://schemas.openxmlformats.org/drawingml/2006/main" xmlns:r="http://schemas.openxmlformats.org/officeDocument/2006/relationships" xmlns:p="http://schemas.openxmlformats.org/presentationml/2006/main">
+  <p:cSld>
+    <p:spTree>
+      <p:nvGrpSpPr>
+        <p:cNvPr id="1" name=""/>
+        <p:cNvGrpSpPr/>
+        <p:nvPr/>
+      </p:nvGrpSpPr>
+      <p:grpSpPr>
+        <a:xfrm>
+          <a:off x="0" y="0"/>
+          <a:ext cx="0" cy="0"/>
+          <a:chOff x="0" y="0"/>
+          <a:chExt cx="0" cy="0"/>
+        </a:xfrm>
+      </p:grpSpPr>
+      <p:sp>
+        <p:nvSpPr>
+          <p:cNvPr id="8" name="Title 1"/>
+          <p:cNvSpPr txBox="1">
+            <a:spLocks/>
+          </p:cNvSpPr>
+          <p:nvPr/>
+        </p:nvSpPr>
+        <p:spPr>
+          <a:xfrm>
+            <a:off x="1087408" y="274638"/>
+            <a:ext cx="7229008" cy="634082"/>
+          </a:xfrm>
+          <a:prstGeom prst="rect">
+            <a:avLst/>
+          </a:prstGeom>
+        </p:spPr>
+        <p:txBody>
+          <a:bodyPr/>
+          <a:lstStyle>
+            <a:lvl1pPr algn="ctr" defTabSz="914400" rtl="0" eaLnBrk="1" latinLnBrk="0" hangingPunct="1">
+              <a:spcBef>
+                <a:spcPct val="0"/>
+              </a:spcBef>
+              <a:buNone/>
+              <a:defRPr sz="4400" kern="1200">
+                <a:solidFill>
+                  <a:schemeClr val="tx1"/>
+                </a:solidFill>
+                <a:latin typeface="+mj-lt"/>
+                <a:ea typeface="+mj-ea"/>
+                <a:cs typeface="+mj-cs"/>
+              </a:defRPr>
+            </a:lvl1pPr>
+          </a:lstStyle>
+          <a:p>
+            <a:pPr algn="l"/>
+            <a:r>
+              <a:rPr lang="es-ES" sz="2000" dirty="0">
+                <a:solidFill>
+                  <a:srgbClr val="3F1900"/>
+                </a:solidFill>
+              </a:rPr>
+              <a:t>TRANSFERENCIA DE FOLIOS.</a:t>
+            </a:r>
+            <a:endParaRPr lang="en-US" sz="2000" dirty="0">
+              <a:solidFill>
+                <a:srgbClr val="3F1900"/>
+              </a:solidFill>
+            </a:endParaRPr>
+          </a:p>
+        </p:txBody>
+      </p:sp>
+      <p:sp>
+        <p:nvSpPr>
+          <p:cNvPr id="4" name="Content Placeholder 3"/>
+          <p:cNvSpPr txBox="1">
+            <a:spLocks/>
+          </p:cNvSpPr>
+          <p:nvPr/>
+        </p:nvSpPr>
+        <p:spPr>
+          <a:xfrm>
+            <a:off x="1331640" y="1196753"/>
+            <a:ext cx="7488832" cy="5137780"/>
+          </a:xfrm>
+          <a:prstGeom prst="rect">
+            <a:avLst/>
+          </a:prstGeom>
+        </p:spPr>
+        <p:txBody>
+          <a:bodyPr>
+            <a:normAutofit/>
+          </a:bodyPr>
+          <a:lstStyle>
+            <a:lvl1pPr marL="342900" indent="-342900" algn="l" defTabSz="914400" rtl="0" eaLnBrk="1" latinLnBrk="0" hangingPunct="1">
+              <a:spcBef>
+                <a:spcPct val="20000"/>
+              </a:spcBef>
+              <a:buFont typeface="Arial" panose="020B0604020202020204" pitchFamily="34" charset="0"/>
+              <a:buChar char="•"/>
+              <a:defRPr sz="3200" kern="1200">
+                <a:solidFill>
+                  <a:schemeClr val="tx1"/>
+                </a:solidFill>
+                <a:latin typeface="+mn-lt"/>
+                <a:ea typeface="+mn-ea"/>
+                <a:cs typeface="+mn-cs"/>
+              </a:defRPr>
+            </a:lvl1pPr>
+            <a:lvl2pPr marL="742950" indent="-285750" algn="l" defTabSz="914400" rtl="0" eaLnBrk="1" latinLnBrk="0" hangingPunct="1">
+              <a:spcBef>
+                <a:spcPct val="20000"/>
+              </a:spcBef>
+              <a:buFont typeface="Arial" panose="020B0604020202020204" pitchFamily="34" charset="0"/>
+              <a:buChar char="–"/>
+              <a:defRPr sz="2800" kern="1200">
+                <a:solidFill>
+                  <a:schemeClr val="tx1"/>
+                </a:solidFill>
+                <a:latin typeface="+mn-lt"/>
+                <a:ea typeface="+mn-ea"/>
+                <a:cs typeface="+mn-cs"/>
+              </a:defRPr>
+            </a:lvl2pPr>
+            <a:lvl3pPr marL="1143000" indent="-228600" algn="l" defTabSz="914400" rtl="0" eaLnBrk="1" latinLnBrk="0" hangingPunct="1">
+              <a:spcBef>
+                <a:spcPct val="20000"/>
+              </a:spcBef>
+              <a:buFont typeface="Arial" panose="020B0604020202020204" pitchFamily="34" charset="0"/>
+              <a:buChar char="•"/>
+              <a:defRPr sz="2400" kern="1200">
+                <a:solidFill>
+                  <a:schemeClr val="tx1"/>
+                </a:solidFill>
+                <a:latin typeface="+mn-lt"/>
+                <a:ea typeface="+mn-ea"/>
+                <a:cs typeface="+mn-cs"/>
+              </a:defRPr>
+            </a:lvl3pPr>
+            <a:lvl4pPr marL="1600200" indent="-228600" algn="l" defTabSz="914400" rtl="0" eaLnBrk="1" latinLnBrk="0" hangingPunct="1">
+              <a:spcBef>
+                <a:spcPct val="20000"/>
+              </a:spcBef>
+              <a:buFont typeface="Arial" panose="020B0604020202020204" pitchFamily="34" charset="0"/>
+              <a:buChar char="–"/>
+              <a:defRPr sz="2000" kern="1200">
+                <a:solidFill>
+                  <a:schemeClr val="tx1"/>
+                </a:solidFill>
+                <a:latin typeface="+mn-lt"/>
+                <a:ea typeface="+mn-ea"/>
+                <a:cs typeface="+mn-cs"/>
+              </a:defRPr>
+            </a:lvl4pPr>
+            <a:lvl5pPr marL="2057400" indent="-228600" algn="l" defTabSz="914400" rtl="0" eaLnBrk="1" latinLnBrk="0" hangingPunct="1">
+              <a:spcBef>
+                <a:spcPct val="20000"/>
+              </a:spcBef>
+              <a:buFont typeface="Arial" panose="020B0604020202020204" pitchFamily="34" charset="0"/>
+              <a:buChar char="»"/>
+              <a:defRPr sz="2000" kern="1200">
+                <a:solidFill>
+                  <a:schemeClr val="tx1"/>
+                </a:solidFill>
+                <a:latin typeface="+mn-lt"/>
+                <a:ea typeface="+mn-ea"/>
+                <a:cs typeface="+mn-cs"/>
+              </a:defRPr>
+            </a:lvl5pPr>
+            <a:lvl6pPr marL="2514600" indent="-228600" algn="l" defTabSz="914400" rtl="0" eaLnBrk="1" latinLnBrk="0" hangingPunct="1">
+              <a:spcBef>
+                <a:spcPct val="20000"/>
+              </a:spcBef>
+              <a:buFont typeface="Arial" panose="020B0604020202020204" pitchFamily="34" charset="0"/>
+              <a:buChar char="•"/>
+              <a:defRPr sz="2000" kern="1200">
+                <a:solidFill>
+                  <a:schemeClr val="tx1"/>
+                </a:solidFill>
+                <a:latin typeface="+mn-lt"/>
+                <a:ea typeface="+mn-ea"/>
+                <a:cs typeface="+mn-cs"/>
+              </a:defRPr>
+            </a:lvl6pPr>
+            <a:lvl7pPr marL="2971800" indent="-228600" algn="l" defTabSz="914400" rtl="0" eaLnBrk="1" latinLnBrk="0" hangingPunct="1">
+              <a:spcBef>
+                <a:spcPct val="20000"/>
+              </a:spcBef>
+              <a:buFont typeface="Arial" panose="020B0604020202020204" pitchFamily="34" charset="0"/>
+              <a:buChar char="•"/>
+              <a:defRPr sz="2000" kern="1200">
+                <a:solidFill>
+                  <a:schemeClr val="tx1"/>
+                </a:solidFill>
+                <a:latin typeface="+mn-lt"/>
+                <a:ea typeface="+mn-ea"/>
+                <a:cs typeface="+mn-cs"/>
+              </a:defRPr>
+            </a:lvl7pPr>
+            <a:lvl8pPr marL="3429000" indent="-228600" algn="l" defTabSz="914400" rtl="0" eaLnBrk="1" latinLnBrk="0" hangingPunct="1">
+              <a:spcBef>
+                <a:spcPct val="20000"/>
+              </a:spcBef>
+              <a:buFont typeface="Arial" panose="020B0604020202020204" pitchFamily="34" charset="0"/>
+              <a:buChar char="•"/>
+              <a:defRPr sz="2000" kern="1200">
+                <a:solidFill>
+                  <a:schemeClr val="tx1"/>
+                </a:solidFill>
+                <a:latin typeface="+mn-lt"/>
+                <a:ea typeface="+mn-ea"/>
+                <a:cs typeface="+mn-cs"/>
+              </a:defRPr>
+            </a:lvl8pPr>
+            <a:lvl9pPr marL="3886200" indent="-228600" algn="l" defTabSz="914400" rtl="0" eaLnBrk="1" latinLnBrk="0" hangingPunct="1">
+              <a:spcBef>
+                <a:spcPct val="20000"/>
+              </a:spcBef>
+              <a:buFont typeface="Arial" panose="020B0604020202020204" pitchFamily="34" charset="0"/>
+              <a:buChar char="•"/>
+              <a:defRPr sz="2000" kern="1200">
+                <a:solidFill>
+                  <a:schemeClr val="tx1"/>
+                </a:solidFill>
+                <a:latin typeface="+mn-lt"/>
+                <a:ea typeface="+mn-ea"/>
+                <a:cs typeface="+mn-cs"/>
+              </a:defRPr>
+            </a:lvl9pPr>
+          </a:lstStyle>
+          <a:p>
+            <a:pPr marL="0" indent="0" algn="just">
+              <a:buFont typeface="Arial" panose="020B0604020202020204" pitchFamily="34" charset="0"/>
+              <a:buNone/>
+            </a:pPr>
+            <a:endParaRPr lang="en-US" sz="2000" i="1"/>
+          </a:p>
+        </p:txBody>
+      </p:sp>
+      <p:sp>
+        <p:nvSpPr>
+          <p:cNvPr id="10" name="Rectangle 9"/>
+          <p:cNvSpPr/>
+          <p:nvPr/>
+        </p:nvSpPr>
+        <p:spPr>
+          <a:xfrm>
+            <a:off x="1331640" y="980728"/>
+            <a:ext cx="7632848" cy="276999"/>
+          </a:xfrm>
+          <a:prstGeom prst="rect">
+            <a:avLst/>
+          </a:prstGeom>
+        </p:spPr>
+        <p:txBody>
+          <a:bodyPr wrap="square">
+            <a:spAutoFit/>
+          </a:bodyPr>
+          <a:lstStyle/>
+          <a:p>
+            <a:pPr>
+              <a:buFont typeface="Arial" panose="020B0604020202020204" pitchFamily="34" charset="0"/>
+              <a:buChar char="•"/>
+            </a:pPr>
+            <a:r>
+              <a:rPr lang="es-ES" sz="1200" b="0" i="0" dirty="0">
+                <a:solidFill>
+                  <a:srgbClr val="222222"/>
+                </a:solidFill>
+                <a:effectLst/>
+                <a:latin typeface="Segoe UI" panose="020B0502040204020203" pitchFamily="34" charset="0"/>
+              </a:rPr>
+              <a:t> </a:t>
+            </a:r>
+            <a:r>
+              <a:rPr lang="es-ES" sz="1200" dirty="0">
+                <a:solidFill>
+                  <a:srgbClr val="222222"/>
+                </a:solidFill>
+                <a:latin typeface="Segoe UI" panose="020B0502040204020203" pitchFamily="34" charset="0"/>
+              </a:rPr>
+              <a:t>Se creo el Nuevo Formato de Folio, la sección (</a:t>
+            </a:r>
+            <a:r>
+              <a:rPr lang="es-ES" sz="1200" b="1" dirty="0">
+                <a:solidFill>
+                  <a:srgbClr val="222222"/>
+                </a:solidFill>
+                <a:latin typeface="Segoe UI" panose="020B0502040204020203" pitchFamily="34" charset="0"/>
+              </a:rPr>
+              <a:t>Actual</a:t>
+            </a:r>
+            <a:r>
+              <a:rPr lang="es-ES" sz="1200" dirty="0">
+                <a:solidFill>
+                  <a:srgbClr val="222222"/>
+                </a:solidFill>
+                <a:latin typeface="Segoe UI" panose="020B0502040204020203" pitchFamily="34" charset="0"/>
+              </a:rPr>
+              <a:t>) muestra las pieles que están cargadas al folio</a:t>
+            </a:r>
+            <a:r>
+              <a:rPr lang="es-ES" sz="1200" b="0" i="0" dirty="0">
+                <a:solidFill>
+                  <a:srgbClr val="222222"/>
+                </a:solidFill>
+                <a:effectLst/>
+                <a:latin typeface="Segoe UI" panose="020B0502040204020203" pitchFamily="34" charset="0"/>
+              </a:rPr>
+              <a:t>.</a:t>
+            </a:r>
+          </a:p>
+        </p:txBody>
+      </p:sp>
+      <p:pic>
+        <p:nvPicPr>
+          <p:cNvPr id="3" name="Imagen 2" descr="Tabla&#10;&#10;Descripción generada automáticamente con confianza media">
+            <a:extLst>
+              <a:ext uri="{FF2B5EF4-FFF2-40B4-BE49-F238E27FC236}">
+                <a16:creationId xmlns:a16="http://schemas.microsoft.com/office/drawing/2014/main" id="{405AEA33-1D46-47CE-9BCF-6958954C84E4}"/>
+              </a:ext>
+            </a:extLst>
+          </p:cNvPr>
+          <p:cNvPicPr>
+            <a:picLocks noChangeAspect="1"/>
+          </p:cNvPicPr>
+          <p:nvPr/>
+        </p:nvPicPr>
+        <p:blipFill>
+          <a:blip r:embed="rId2">
+            <a:extLst>
+              <a:ext uri="{28A0092B-C50C-407E-A947-70E740481C1C}">
+                <a14:useLocalDpi xmlns:a14="http://schemas.microsoft.com/office/drawing/2010/main" val="0"/>
+              </a:ext>
+            </a:extLst>
+          </a:blip>
+          <a:stretch>
+            <a:fillRect/>
+          </a:stretch>
+        </p:blipFill>
+        <p:spPr>
+          <a:xfrm>
+            <a:off x="2483768" y="1257727"/>
+            <a:ext cx="5328592" cy="5483641"/>
+          </a:xfrm>
+          <a:prstGeom prst="rect">
+            <a:avLst/>
+          </a:prstGeom>
+          <a:ln>
+            <a:solidFill>
+              <a:schemeClr val="tx1"/>
+            </a:solidFill>
+          </a:ln>
+        </p:spPr>
+      </p:pic>
+    </p:spTree>
+    <p:extLst>
+      <p:ext uri="{BB962C8B-B14F-4D97-AF65-F5344CB8AC3E}">
+        <p14:creationId xmlns:p14="http://schemas.microsoft.com/office/powerpoint/2010/main" val="3552015138"/>
+      </p:ext>
+    </p:extLst>
+  </p:cSld>
+  <p:clrMapOvr>
+    <a:masterClrMapping/>
+  </p:clrMapOvr>
+</p:sld>
+</file>
+
+<file path=ppt/slides/slide3.xml><?xml version="1.0" encoding="utf-8"?>
+<p:sld xmlns:a="http://schemas.openxmlformats.org/drawingml/2006/main" xmlns:r="http://schemas.openxmlformats.org/officeDocument/2006/relationships" xmlns:p="http://schemas.openxmlformats.org/presentationml/2006/main">
+  <p:cSld>
+    <p:spTree>
+      <p:nvGrpSpPr>
+        <p:cNvPr id="1" name=""/>
+        <p:cNvGrpSpPr/>
+        <p:nvPr/>
+      </p:nvGrpSpPr>
+      <p:grpSpPr>
+        <a:xfrm>
+          <a:off x="0" y="0"/>
+          <a:ext cx="0" cy="0"/>
+          <a:chOff x="0" y="0"/>
+          <a:chExt cx="0" cy="0"/>
+        </a:xfrm>
+      </p:grpSpPr>
+      <p:sp>
+        <p:nvSpPr>
+          <p:cNvPr id="5" name="Title 1"/>
+          <p:cNvSpPr txBox="1">
+            <a:spLocks/>
+          </p:cNvSpPr>
+          <p:nvPr/>
+        </p:nvSpPr>
+        <p:spPr>
+          <a:xfrm>
+            <a:off x="1187624" y="2564904"/>
+            <a:ext cx="7772400" cy="1470025"/>
+          </a:xfrm>
+          <a:prstGeom prst="rect">
+            <a:avLst/>
+          </a:prstGeom>
+        </p:spPr>
+        <p:txBody>
+          <a:bodyPr vert="horz" lIns="91440" tIns="45720" rIns="91440" bIns="45720" rtlCol="0" anchor="ctr">
+            <a:normAutofit/>
+          </a:bodyPr>
+          <a:lstStyle>
+            <a:lvl1pPr algn="ctr" defTabSz="914400" rtl="0" eaLnBrk="1" latinLnBrk="0" hangingPunct="1">
+              <a:spcBef>
+                <a:spcPct val="0"/>
+              </a:spcBef>
+              <a:buNone/>
+              <a:defRPr sz="4400" kern="1200">
+                <a:solidFill>
+                  <a:schemeClr val="tx1"/>
+                </a:solidFill>
+                <a:latin typeface="+mj-lt"/>
+                <a:ea typeface="+mj-ea"/>
+                <a:cs typeface="+mj-cs"/>
+              </a:defRPr>
+            </a:lvl1pPr>
+          </a:lstStyle>
+          <a:p>
+            <a:r>
+              <a:rPr lang="es-MX" b="1" dirty="0">
+                <a:latin typeface="Century Gothic" panose="020B0502020202020204" pitchFamily="34" charset="0"/>
+              </a:rPr>
               <a:t>16/10/2020 – 22/10/2020</a:t>
             </a:r>
             <a:endParaRPr lang="es-MX" dirty="0">
@@ -3515,7 +3963,7 @@
 </p:sld>
 </file>
 
-<file path=ppt/slides/slide2.xml><?xml version="1.0" encoding="utf-8"?>
+<file path=ppt/slides/slide4.xml><?xml version="1.0" encoding="utf-8"?>
 <p:sld xmlns:a="http://schemas.openxmlformats.org/drawingml/2006/main" xmlns:r="http://schemas.openxmlformats.org/officeDocument/2006/relationships" xmlns:p="http://schemas.openxmlformats.org/presentationml/2006/main">
   <p:cSld>
     <p:spTree>

</xml_diff>

<commit_message>
cambios del dia 27/05/2021
</commit_message>
<xml_diff>
--- a/Scripts_R100_Materiales/Folios_Transaccion/Docs/IT_DEV_FOLIOS_22102020.pptx
+++ b/Scripts_R100_Materiales/Folios_Transaccion/Docs/IT_DEV_FOLIOS_22102020.pptx
@@ -5,13 +5,15 @@
     <p:sldMasterId id="2147483648" r:id="rId1"/>
   </p:sldMasterIdLst>
   <p:notesMasterIdLst>
-    <p:notesMasterId r:id="rId6"/>
+    <p:notesMasterId r:id="rId8"/>
   </p:notesMasterIdLst>
   <p:sldIdLst>
     <p:sldId id="398" r:id="rId2"/>
-    <p:sldId id="397" r:id="rId3"/>
-    <p:sldId id="344" r:id="rId4"/>
-    <p:sldId id="396" r:id="rId5"/>
+    <p:sldId id="400" r:id="rId3"/>
+    <p:sldId id="399" r:id="rId4"/>
+    <p:sldId id="397" r:id="rId5"/>
+    <p:sldId id="344" r:id="rId6"/>
+    <p:sldId id="396" r:id="rId7"/>
   </p:sldIdLst>
   <p:sldSz cx="9144000" cy="6858000" type="screen4x3"/>
   <p:notesSz cx="6858000" cy="9144000"/>
@@ -211,7 +213,7 @@
           <a:p>
             <a:fld id="{A17B1792-3256-4E77-8442-3E205CD69EF5}" type="datetimeFigureOut">
               <a:rPr lang="en-US" smtClean="0"/>
-              <a:t>3/13/2021</a:t>
+              <a:t>5/25/2021</a:t>
             </a:fld>
             <a:endParaRPr lang="en-US"/>
           </a:p>
@@ -657,7 +659,7 @@
           <a:p>
             <a:fld id="{07558649-2619-44F9-8F30-2D6466E57529}" type="datetimeFigureOut">
               <a:rPr lang="en-US" smtClean="0"/>
-              <a:t>3/13/2021</a:t>
+              <a:t>5/25/2021</a:t>
             </a:fld>
             <a:endParaRPr lang="en-US"/>
           </a:p>
@@ -825,7 +827,7 @@
           <a:p>
             <a:fld id="{07558649-2619-44F9-8F30-2D6466E57529}" type="datetimeFigureOut">
               <a:rPr lang="en-US" smtClean="0"/>
-              <a:t>3/13/2021</a:t>
+              <a:t>5/25/2021</a:t>
             </a:fld>
             <a:endParaRPr lang="en-US"/>
           </a:p>
@@ -1003,7 +1005,7 @@
           <a:p>
             <a:fld id="{07558649-2619-44F9-8F30-2D6466E57529}" type="datetimeFigureOut">
               <a:rPr lang="en-US" smtClean="0"/>
-              <a:t>3/13/2021</a:t>
+              <a:t>5/25/2021</a:t>
             </a:fld>
             <a:endParaRPr lang="en-US"/>
           </a:p>
@@ -1171,7 +1173,7 @@
           <a:p>
             <a:fld id="{07558649-2619-44F9-8F30-2D6466E57529}" type="datetimeFigureOut">
               <a:rPr lang="en-US" smtClean="0"/>
-              <a:t>3/13/2021</a:t>
+              <a:t>5/25/2021</a:t>
             </a:fld>
             <a:endParaRPr lang="en-US"/>
           </a:p>
@@ -1416,7 +1418,7 @@
           <a:p>
             <a:fld id="{07558649-2619-44F9-8F30-2D6466E57529}" type="datetimeFigureOut">
               <a:rPr lang="en-US" smtClean="0"/>
-              <a:t>3/13/2021</a:t>
+              <a:t>5/25/2021</a:t>
             </a:fld>
             <a:endParaRPr lang="en-US"/>
           </a:p>
@@ -1701,7 +1703,7 @@
           <a:p>
             <a:fld id="{07558649-2619-44F9-8F30-2D6466E57529}" type="datetimeFigureOut">
               <a:rPr lang="en-US" smtClean="0"/>
-              <a:t>3/13/2021</a:t>
+              <a:t>5/25/2021</a:t>
             </a:fld>
             <a:endParaRPr lang="en-US"/>
           </a:p>
@@ -2120,7 +2122,7 @@
           <a:p>
             <a:fld id="{07558649-2619-44F9-8F30-2D6466E57529}" type="datetimeFigureOut">
               <a:rPr lang="en-US" smtClean="0"/>
-              <a:t>3/13/2021</a:t>
+              <a:t>5/25/2021</a:t>
             </a:fld>
             <a:endParaRPr lang="en-US"/>
           </a:p>
@@ -2237,7 +2239,7 @@
           <a:p>
             <a:fld id="{07558649-2619-44F9-8F30-2D6466E57529}" type="datetimeFigureOut">
               <a:rPr lang="en-US" smtClean="0"/>
-              <a:t>3/13/2021</a:t>
+              <a:t>5/25/2021</a:t>
             </a:fld>
             <a:endParaRPr lang="en-US"/>
           </a:p>
@@ -2332,7 +2334,7 @@
           <a:p>
             <a:fld id="{07558649-2619-44F9-8F30-2D6466E57529}" type="datetimeFigureOut">
               <a:rPr lang="en-US" smtClean="0"/>
-              <a:t>3/13/2021</a:t>
+              <a:t>5/25/2021</a:t>
             </a:fld>
             <a:endParaRPr lang="en-US"/>
           </a:p>
@@ -2607,7 +2609,7 @@
           <a:p>
             <a:fld id="{07558649-2619-44F9-8F30-2D6466E57529}" type="datetimeFigureOut">
               <a:rPr lang="en-US" smtClean="0"/>
-              <a:t>3/13/2021</a:t>
+              <a:t>5/25/2021</a:t>
             </a:fld>
             <a:endParaRPr lang="en-US"/>
           </a:p>
@@ -2859,7 +2861,7 @@
           <a:p>
             <a:fld id="{07558649-2619-44F9-8F30-2D6466E57529}" type="datetimeFigureOut">
               <a:rPr lang="en-US" smtClean="0"/>
-              <a:t>3/13/2021</a:t>
+              <a:t>5/25/2021</a:t>
             </a:fld>
             <a:endParaRPr lang="en-US"/>
           </a:p>
@@ -3079,7 +3081,7 @@
           <a:p>
             <a:fld id="{07558649-2619-44F9-8F30-2D6466E57529}" type="datetimeFigureOut">
               <a:rPr lang="en-US" smtClean="0"/>
-              <a:t>3/13/2021</a:t>
+              <a:t>5/25/2021</a:t>
             </a:fld>
             <a:endParaRPr lang="en-US"/>
           </a:p>
@@ -3496,7 +3498,7 @@
               <a:rPr lang="es-MX" b="1" dirty="0">
                 <a:latin typeface="Century Gothic" panose="020B0502020202020204" pitchFamily="34" charset="0"/>
               </a:rPr>
-              <a:t>06/03/2021 – 13/03/2021</a:t>
+              <a:t>24/05/2021 – 28/05/2021</a:t>
             </a:r>
             <a:endParaRPr lang="es-MX" dirty="0">
               <a:latin typeface="Century Gothic" panose="020B0502020202020204" pitchFamily="34" charset="0"/>
@@ -3518,6 +3520,496 @@
 </file>
 
 <file path=ppt/slides/slide2.xml><?xml version="1.0" encoding="utf-8"?>
+<p:sld xmlns:a="http://schemas.openxmlformats.org/drawingml/2006/main" xmlns:r="http://schemas.openxmlformats.org/officeDocument/2006/relationships" xmlns:p="http://schemas.openxmlformats.org/presentationml/2006/main">
+  <p:cSld>
+    <p:spTree>
+      <p:nvGrpSpPr>
+        <p:cNvPr id="1" name=""/>
+        <p:cNvGrpSpPr/>
+        <p:nvPr/>
+      </p:nvGrpSpPr>
+      <p:grpSpPr>
+        <a:xfrm>
+          <a:off x="0" y="0"/>
+          <a:ext cx="0" cy="0"/>
+          <a:chOff x="0" y="0"/>
+          <a:chExt cx="0" cy="0"/>
+        </a:xfrm>
+      </p:grpSpPr>
+      <p:sp>
+        <p:nvSpPr>
+          <p:cNvPr id="8" name="Title 1"/>
+          <p:cNvSpPr txBox="1">
+            <a:spLocks/>
+          </p:cNvSpPr>
+          <p:nvPr/>
+        </p:nvSpPr>
+        <p:spPr>
+          <a:xfrm>
+            <a:off x="1087408" y="274638"/>
+            <a:ext cx="7229008" cy="634082"/>
+          </a:xfrm>
+          <a:prstGeom prst="rect">
+            <a:avLst/>
+          </a:prstGeom>
+        </p:spPr>
+        <p:txBody>
+          <a:bodyPr/>
+          <a:lstStyle>
+            <a:lvl1pPr algn="ctr" defTabSz="914400" rtl="0" eaLnBrk="1" latinLnBrk="0" hangingPunct="1">
+              <a:spcBef>
+                <a:spcPct val="0"/>
+              </a:spcBef>
+              <a:buNone/>
+              <a:defRPr sz="4400" kern="1200">
+                <a:solidFill>
+                  <a:schemeClr val="tx1"/>
+                </a:solidFill>
+                <a:latin typeface="+mj-lt"/>
+                <a:ea typeface="+mj-ea"/>
+                <a:cs typeface="+mj-cs"/>
+              </a:defRPr>
+            </a:lvl1pPr>
+          </a:lstStyle>
+          <a:p>
+            <a:pPr algn="l"/>
+            <a:r>
+              <a:rPr lang="es-ES" sz="2000" dirty="0">
+                <a:solidFill>
+                  <a:srgbClr val="3F1900"/>
+                </a:solidFill>
+              </a:rPr>
+              <a:t>TRANSFERENCIA DE FOLIOS.</a:t>
+            </a:r>
+            <a:endParaRPr lang="en-US" sz="2000" dirty="0">
+              <a:solidFill>
+                <a:srgbClr val="3F1900"/>
+              </a:solidFill>
+            </a:endParaRPr>
+          </a:p>
+        </p:txBody>
+      </p:sp>
+      <p:sp>
+        <p:nvSpPr>
+          <p:cNvPr id="4" name="Content Placeholder 3"/>
+          <p:cNvSpPr txBox="1">
+            <a:spLocks/>
+          </p:cNvSpPr>
+          <p:nvPr/>
+        </p:nvSpPr>
+        <p:spPr>
+          <a:xfrm>
+            <a:off x="1331640" y="1196753"/>
+            <a:ext cx="7488832" cy="5137780"/>
+          </a:xfrm>
+          <a:prstGeom prst="rect">
+            <a:avLst/>
+          </a:prstGeom>
+        </p:spPr>
+        <p:txBody>
+          <a:bodyPr>
+            <a:normAutofit/>
+          </a:bodyPr>
+          <a:lstStyle>
+            <a:lvl1pPr marL="342900" indent="-342900" algn="l" defTabSz="914400" rtl="0" eaLnBrk="1" latinLnBrk="0" hangingPunct="1">
+              <a:spcBef>
+                <a:spcPct val="20000"/>
+              </a:spcBef>
+              <a:buFont typeface="Arial" panose="020B0604020202020204" pitchFamily="34" charset="0"/>
+              <a:buChar char="•"/>
+              <a:defRPr sz="3200" kern="1200">
+                <a:solidFill>
+                  <a:schemeClr val="tx1"/>
+                </a:solidFill>
+                <a:latin typeface="+mn-lt"/>
+                <a:ea typeface="+mn-ea"/>
+                <a:cs typeface="+mn-cs"/>
+              </a:defRPr>
+            </a:lvl1pPr>
+            <a:lvl2pPr marL="742950" indent="-285750" algn="l" defTabSz="914400" rtl="0" eaLnBrk="1" latinLnBrk="0" hangingPunct="1">
+              <a:spcBef>
+                <a:spcPct val="20000"/>
+              </a:spcBef>
+              <a:buFont typeface="Arial" panose="020B0604020202020204" pitchFamily="34" charset="0"/>
+              <a:buChar char="–"/>
+              <a:defRPr sz="2800" kern="1200">
+                <a:solidFill>
+                  <a:schemeClr val="tx1"/>
+                </a:solidFill>
+                <a:latin typeface="+mn-lt"/>
+                <a:ea typeface="+mn-ea"/>
+                <a:cs typeface="+mn-cs"/>
+              </a:defRPr>
+            </a:lvl2pPr>
+            <a:lvl3pPr marL="1143000" indent="-228600" algn="l" defTabSz="914400" rtl="0" eaLnBrk="1" latinLnBrk="0" hangingPunct="1">
+              <a:spcBef>
+                <a:spcPct val="20000"/>
+              </a:spcBef>
+              <a:buFont typeface="Arial" panose="020B0604020202020204" pitchFamily="34" charset="0"/>
+              <a:buChar char="•"/>
+              <a:defRPr sz="2400" kern="1200">
+                <a:solidFill>
+                  <a:schemeClr val="tx1"/>
+                </a:solidFill>
+                <a:latin typeface="+mn-lt"/>
+                <a:ea typeface="+mn-ea"/>
+                <a:cs typeface="+mn-cs"/>
+              </a:defRPr>
+            </a:lvl3pPr>
+            <a:lvl4pPr marL="1600200" indent="-228600" algn="l" defTabSz="914400" rtl="0" eaLnBrk="1" latinLnBrk="0" hangingPunct="1">
+              <a:spcBef>
+                <a:spcPct val="20000"/>
+              </a:spcBef>
+              <a:buFont typeface="Arial" panose="020B0604020202020204" pitchFamily="34" charset="0"/>
+              <a:buChar char="–"/>
+              <a:defRPr sz="2000" kern="1200">
+                <a:solidFill>
+                  <a:schemeClr val="tx1"/>
+                </a:solidFill>
+                <a:latin typeface="+mn-lt"/>
+                <a:ea typeface="+mn-ea"/>
+                <a:cs typeface="+mn-cs"/>
+              </a:defRPr>
+            </a:lvl4pPr>
+            <a:lvl5pPr marL="2057400" indent="-228600" algn="l" defTabSz="914400" rtl="0" eaLnBrk="1" latinLnBrk="0" hangingPunct="1">
+              <a:spcBef>
+                <a:spcPct val="20000"/>
+              </a:spcBef>
+              <a:buFont typeface="Arial" panose="020B0604020202020204" pitchFamily="34" charset="0"/>
+              <a:buChar char="»"/>
+              <a:defRPr sz="2000" kern="1200">
+                <a:solidFill>
+                  <a:schemeClr val="tx1"/>
+                </a:solidFill>
+                <a:latin typeface="+mn-lt"/>
+                <a:ea typeface="+mn-ea"/>
+                <a:cs typeface="+mn-cs"/>
+              </a:defRPr>
+            </a:lvl5pPr>
+            <a:lvl6pPr marL="2514600" indent="-228600" algn="l" defTabSz="914400" rtl="0" eaLnBrk="1" latinLnBrk="0" hangingPunct="1">
+              <a:spcBef>
+                <a:spcPct val="20000"/>
+              </a:spcBef>
+              <a:buFont typeface="Arial" panose="020B0604020202020204" pitchFamily="34" charset="0"/>
+              <a:buChar char="•"/>
+              <a:defRPr sz="2000" kern="1200">
+                <a:solidFill>
+                  <a:schemeClr val="tx1"/>
+                </a:solidFill>
+                <a:latin typeface="+mn-lt"/>
+                <a:ea typeface="+mn-ea"/>
+                <a:cs typeface="+mn-cs"/>
+              </a:defRPr>
+            </a:lvl6pPr>
+            <a:lvl7pPr marL="2971800" indent="-228600" algn="l" defTabSz="914400" rtl="0" eaLnBrk="1" latinLnBrk="0" hangingPunct="1">
+              <a:spcBef>
+                <a:spcPct val="20000"/>
+              </a:spcBef>
+              <a:buFont typeface="Arial" panose="020B0604020202020204" pitchFamily="34" charset="0"/>
+              <a:buChar char="•"/>
+              <a:defRPr sz="2000" kern="1200">
+                <a:solidFill>
+                  <a:schemeClr val="tx1"/>
+                </a:solidFill>
+                <a:latin typeface="+mn-lt"/>
+                <a:ea typeface="+mn-ea"/>
+                <a:cs typeface="+mn-cs"/>
+              </a:defRPr>
+            </a:lvl7pPr>
+            <a:lvl8pPr marL="3429000" indent="-228600" algn="l" defTabSz="914400" rtl="0" eaLnBrk="1" latinLnBrk="0" hangingPunct="1">
+              <a:spcBef>
+                <a:spcPct val="20000"/>
+              </a:spcBef>
+              <a:buFont typeface="Arial" panose="020B0604020202020204" pitchFamily="34" charset="0"/>
+              <a:buChar char="•"/>
+              <a:defRPr sz="2000" kern="1200">
+                <a:solidFill>
+                  <a:schemeClr val="tx1"/>
+                </a:solidFill>
+                <a:latin typeface="+mn-lt"/>
+                <a:ea typeface="+mn-ea"/>
+                <a:cs typeface="+mn-cs"/>
+              </a:defRPr>
+            </a:lvl8pPr>
+            <a:lvl9pPr marL="3886200" indent="-228600" algn="l" defTabSz="914400" rtl="0" eaLnBrk="1" latinLnBrk="0" hangingPunct="1">
+              <a:spcBef>
+                <a:spcPct val="20000"/>
+              </a:spcBef>
+              <a:buFont typeface="Arial" panose="020B0604020202020204" pitchFamily="34" charset="0"/>
+              <a:buChar char="•"/>
+              <a:defRPr sz="2000" kern="1200">
+                <a:solidFill>
+                  <a:schemeClr val="tx1"/>
+                </a:solidFill>
+                <a:latin typeface="+mn-lt"/>
+                <a:ea typeface="+mn-ea"/>
+                <a:cs typeface="+mn-cs"/>
+              </a:defRPr>
+            </a:lvl9pPr>
+          </a:lstStyle>
+          <a:p>
+            <a:pPr marL="0" indent="0" algn="just">
+              <a:buFont typeface="Arial" panose="020B0604020202020204" pitchFamily="34" charset="0"/>
+              <a:buNone/>
+            </a:pPr>
+            <a:endParaRPr lang="en-US" sz="2000" i="1"/>
+          </a:p>
+        </p:txBody>
+      </p:sp>
+      <p:sp>
+        <p:nvSpPr>
+          <p:cNvPr id="10" name="Rectangle 9"/>
+          <p:cNvSpPr/>
+          <p:nvPr/>
+        </p:nvSpPr>
+        <p:spPr>
+          <a:xfrm>
+            <a:off x="1331640" y="980728"/>
+            <a:ext cx="7632848" cy="461665"/>
+          </a:xfrm>
+          <a:prstGeom prst="rect">
+            <a:avLst/>
+          </a:prstGeom>
+        </p:spPr>
+        <p:txBody>
+          <a:bodyPr wrap="square">
+            <a:spAutoFit/>
+          </a:bodyPr>
+          <a:lstStyle/>
+          <a:p>
+            <a:pPr>
+              <a:buFont typeface="Arial" panose="020B0604020202020204" pitchFamily="34" charset="0"/>
+              <a:buChar char="•"/>
+            </a:pPr>
+            <a:r>
+              <a:rPr lang="es-ES" sz="1200" b="0" i="0" dirty="0">
+                <a:solidFill>
+                  <a:srgbClr val="222222"/>
+                </a:solidFill>
+                <a:effectLst/>
+                <a:latin typeface="Segoe UI" panose="020B0502040204020203" pitchFamily="34" charset="0"/>
+              </a:rPr>
+              <a:t> </a:t>
+            </a:r>
+            <a:r>
+              <a:rPr lang="es-ES" sz="1200" dirty="0">
+                <a:solidFill>
+                  <a:srgbClr val="222222"/>
+                </a:solidFill>
+                <a:latin typeface="Segoe UI" panose="020B0502040204020203" pitchFamily="34" charset="0"/>
+              </a:rPr>
+              <a:t>Se agrego validación para la locación MSL (</a:t>
+            </a:r>
+            <a:r>
+              <a:rPr lang="en-US" sz="1200" b="0" i="0" dirty="0">
+                <a:effectLst/>
+                <a:latin typeface="Segoe UI" panose="020B0502040204020203" pitchFamily="34" charset="0"/>
+              </a:rPr>
+              <a:t>Material Sales Location</a:t>
+            </a:r>
+            <a:r>
+              <a:rPr lang="es-ES" sz="1200" dirty="0">
+                <a:solidFill>
+                  <a:srgbClr val="222222"/>
+                </a:solidFill>
+                <a:latin typeface="Segoe UI" panose="020B0502040204020203" pitchFamily="34" charset="0"/>
+              </a:rPr>
+              <a:t>), el material que este en esta locación solo podrá ser movido por Miguel Carrasco y por Pedro Misael del departamento de Calidad</a:t>
+            </a:r>
+            <a:r>
+              <a:rPr lang="es-ES" sz="1200" b="0" i="0" dirty="0">
+                <a:solidFill>
+                  <a:srgbClr val="222222"/>
+                </a:solidFill>
+                <a:effectLst/>
+                <a:latin typeface="Segoe UI" panose="020B0502040204020203" pitchFamily="34" charset="0"/>
+              </a:rPr>
+              <a:t>.</a:t>
+            </a:r>
+          </a:p>
+        </p:txBody>
+      </p:sp>
+      <p:pic>
+        <p:nvPicPr>
+          <p:cNvPr id="5" name="Imagen 4" descr="Una captura de pantalla de una computadora&#10;&#10;Descripción generada automáticamente">
+            <a:extLst>
+              <a:ext uri="{FF2B5EF4-FFF2-40B4-BE49-F238E27FC236}">
+                <a16:creationId xmlns:a16="http://schemas.microsoft.com/office/drawing/2014/main" id="{4E8D3F11-AE12-4AF2-AE3A-9C08AE1EA8A7}"/>
+              </a:ext>
+            </a:extLst>
+          </p:cNvPr>
+          <p:cNvPicPr>
+            <a:picLocks noChangeAspect="1"/>
+          </p:cNvPicPr>
+          <p:nvPr/>
+        </p:nvPicPr>
+        <p:blipFill rotWithShape="1">
+          <a:blip r:embed="rId2">
+            <a:extLst>
+              <a:ext uri="{28A0092B-C50C-407E-A947-70E740481C1C}">
+                <a14:useLocalDpi xmlns:a14="http://schemas.microsoft.com/office/drawing/2010/main" val="0"/>
+              </a:ext>
+            </a:extLst>
+          </a:blip>
+          <a:srcRect l="50787" t="5201" r="23225" b="10800"/>
+          <a:stretch/>
+        </p:blipFill>
+        <p:spPr>
+          <a:xfrm>
+            <a:off x="1979712" y="1514400"/>
+            <a:ext cx="5976664" cy="5298975"/>
+          </a:xfrm>
+          <a:prstGeom prst="rect">
+            <a:avLst/>
+          </a:prstGeom>
+        </p:spPr>
+      </p:pic>
+      <p:sp>
+        <p:nvSpPr>
+          <p:cNvPr id="6" name="Rectángulo 5">
+            <a:extLst>
+              <a:ext uri="{FF2B5EF4-FFF2-40B4-BE49-F238E27FC236}">
+                <a16:creationId xmlns:a16="http://schemas.microsoft.com/office/drawing/2014/main" id="{AF49C1C9-5E15-4D29-AEA8-934DBC05B053}"/>
+              </a:ext>
+            </a:extLst>
+          </p:cNvPr>
+          <p:cNvSpPr/>
+          <p:nvPr/>
+        </p:nvSpPr>
+        <p:spPr>
+          <a:xfrm>
+            <a:off x="4932040" y="2060848"/>
+            <a:ext cx="432048" cy="432048"/>
+          </a:xfrm>
+          <a:prstGeom prst="rect">
+            <a:avLst/>
+          </a:prstGeom>
+          <a:noFill/>
+          <a:ln>
+            <a:solidFill>
+              <a:srgbClr val="FF0000"/>
+            </a:solidFill>
+          </a:ln>
+        </p:spPr>
+        <p:style>
+          <a:lnRef idx="2">
+            <a:schemeClr val="accent1">
+              <a:shade val="50000"/>
+            </a:schemeClr>
+          </a:lnRef>
+          <a:fillRef idx="1">
+            <a:schemeClr val="accent1"/>
+          </a:fillRef>
+          <a:effectRef idx="0">
+            <a:schemeClr val="accent1"/>
+          </a:effectRef>
+          <a:fontRef idx="minor">
+            <a:schemeClr val="lt1"/>
+          </a:fontRef>
+        </p:style>
+        <p:txBody>
+          <a:bodyPr rtlCol="0" anchor="ctr"/>
+          <a:lstStyle/>
+          <a:p>
+            <a:pPr algn="ctr"/>
+            <a:endParaRPr lang="en-US"/>
+          </a:p>
+        </p:txBody>
+      </p:sp>
+    </p:spTree>
+    <p:extLst>
+      <p:ext uri="{BB962C8B-B14F-4D97-AF65-F5344CB8AC3E}">
+        <p14:creationId xmlns:p14="http://schemas.microsoft.com/office/powerpoint/2010/main" val="2170633103"/>
+      </p:ext>
+    </p:extLst>
+  </p:cSld>
+  <p:clrMapOvr>
+    <a:masterClrMapping/>
+  </p:clrMapOvr>
+</p:sld>
+</file>
+
+<file path=ppt/slides/slide3.xml><?xml version="1.0" encoding="utf-8"?>
+<p:sld xmlns:a="http://schemas.openxmlformats.org/drawingml/2006/main" xmlns:r="http://schemas.openxmlformats.org/officeDocument/2006/relationships" xmlns:p="http://schemas.openxmlformats.org/presentationml/2006/main">
+  <p:cSld>
+    <p:spTree>
+      <p:nvGrpSpPr>
+        <p:cNvPr id="1" name=""/>
+        <p:cNvGrpSpPr/>
+        <p:nvPr/>
+      </p:nvGrpSpPr>
+      <p:grpSpPr>
+        <a:xfrm>
+          <a:off x="0" y="0"/>
+          <a:ext cx="0" cy="0"/>
+          <a:chOff x="0" y="0"/>
+          <a:chExt cx="0" cy="0"/>
+        </a:xfrm>
+      </p:grpSpPr>
+      <p:sp>
+        <p:nvSpPr>
+          <p:cNvPr id="5" name="Title 1"/>
+          <p:cNvSpPr txBox="1">
+            <a:spLocks/>
+          </p:cNvSpPr>
+          <p:nvPr/>
+        </p:nvSpPr>
+        <p:spPr>
+          <a:xfrm>
+            <a:off x="1187624" y="2564904"/>
+            <a:ext cx="7772400" cy="1470025"/>
+          </a:xfrm>
+          <a:prstGeom prst="rect">
+            <a:avLst/>
+          </a:prstGeom>
+        </p:spPr>
+        <p:txBody>
+          <a:bodyPr vert="horz" lIns="91440" tIns="45720" rIns="91440" bIns="45720" rtlCol="0" anchor="ctr">
+            <a:normAutofit/>
+          </a:bodyPr>
+          <a:lstStyle>
+            <a:lvl1pPr algn="ctr" defTabSz="914400" rtl="0" eaLnBrk="1" latinLnBrk="0" hangingPunct="1">
+              <a:spcBef>
+                <a:spcPct val="0"/>
+              </a:spcBef>
+              <a:buNone/>
+              <a:defRPr sz="4400" kern="1200">
+                <a:solidFill>
+                  <a:schemeClr val="tx1"/>
+                </a:solidFill>
+                <a:latin typeface="+mj-lt"/>
+                <a:ea typeface="+mj-ea"/>
+                <a:cs typeface="+mj-cs"/>
+              </a:defRPr>
+            </a:lvl1pPr>
+          </a:lstStyle>
+          <a:p>
+            <a:r>
+              <a:rPr lang="es-MX" b="1" dirty="0">
+                <a:latin typeface="Century Gothic" panose="020B0502020202020204" pitchFamily="34" charset="0"/>
+              </a:rPr>
+              <a:t>06/03/2021 – 13/03/2021</a:t>
+            </a:r>
+            <a:endParaRPr lang="es-MX" dirty="0">
+              <a:latin typeface="Century Gothic" panose="020B0502020202020204" pitchFamily="34" charset="0"/>
+            </a:endParaRPr>
+          </a:p>
+        </p:txBody>
+      </p:sp>
+    </p:spTree>
+    <p:extLst>
+      <p:ext uri="{BB962C8B-B14F-4D97-AF65-F5344CB8AC3E}">
+        <p14:creationId xmlns:p14="http://schemas.microsoft.com/office/powerpoint/2010/main" val="1295021430"/>
+      </p:ext>
+    </p:extLst>
+  </p:cSld>
+  <p:clrMapOvr>
+    <a:masterClrMapping/>
+  </p:clrMapOvr>
+</p:sld>
+</file>
+
+<file path=ppt/slides/slide4.xml><?xml version="1.0" encoding="utf-8"?>
 <p:sld xmlns:a="http://schemas.openxmlformats.org/drawingml/2006/main" xmlns:r="http://schemas.openxmlformats.org/officeDocument/2006/relationships" xmlns:p="http://schemas.openxmlformats.org/presentationml/2006/main">
   <p:cSld>
     <p:spTree>
@@ -3883,7 +4375,7 @@
 </p:sld>
 </file>
 
-<file path=ppt/slides/slide3.xml><?xml version="1.0" encoding="utf-8"?>
+<file path=ppt/slides/slide5.xml><?xml version="1.0" encoding="utf-8"?>
 <p:sld xmlns:a="http://schemas.openxmlformats.org/drawingml/2006/main" xmlns:r="http://schemas.openxmlformats.org/officeDocument/2006/relationships" xmlns:p="http://schemas.openxmlformats.org/presentationml/2006/main">
   <p:cSld>
     <p:spTree>
@@ -3963,7 +4455,7 @@
 </p:sld>
 </file>
 
-<file path=ppt/slides/slide4.xml><?xml version="1.0" encoding="utf-8"?>
+<file path=ppt/slides/slide6.xml><?xml version="1.0" encoding="utf-8"?>
 <p:sld xmlns:a="http://schemas.openxmlformats.org/drawingml/2006/main" xmlns:r="http://schemas.openxmlformats.org/officeDocument/2006/relationships" xmlns:p="http://schemas.openxmlformats.org/presentationml/2006/main">
   <p:cSld>
     <p:spTree>

</xml_diff>

<commit_message>
CAMBIOS DEL DIA 31052021 PARA EVITAR QUE SE GENERE LA MISMA ORDEN EN PLANNING
</commit_message>
<xml_diff>
--- a/Scripts_R100_Materiales/Folios_Transaccion/Docs/IT_DEV_FOLIOS_22102020.pptx
+++ b/Scripts_R100_Materiales/Folios_Transaccion/Docs/IT_DEV_FOLIOS_22102020.pptx
@@ -5,15 +5,17 @@
     <p:sldMasterId id="2147483648" r:id="rId1"/>
   </p:sldMasterIdLst>
   <p:notesMasterIdLst>
-    <p:notesMasterId r:id="rId8"/>
+    <p:notesMasterId r:id="rId10"/>
   </p:notesMasterIdLst>
   <p:sldIdLst>
     <p:sldId id="398" r:id="rId2"/>
     <p:sldId id="400" r:id="rId3"/>
-    <p:sldId id="399" r:id="rId4"/>
-    <p:sldId id="397" r:id="rId5"/>
-    <p:sldId id="344" r:id="rId6"/>
-    <p:sldId id="396" r:id="rId7"/>
+    <p:sldId id="402" r:id="rId4"/>
+    <p:sldId id="401" r:id="rId5"/>
+    <p:sldId id="399" r:id="rId6"/>
+    <p:sldId id="397" r:id="rId7"/>
+    <p:sldId id="344" r:id="rId8"/>
+    <p:sldId id="396" r:id="rId9"/>
   </p:sldIdLst>
   <p:sldSz cx="9144000" cy="6858000" type="screen4x3"/>
   <p:notesSz cx="6858000" cy="9144000"/>
@@ -213,7 +215,7 @@
           <a:p>
             <a:fld id="{A17B1792-3256-4E77-8442-3E205CD69EF5}" type="datetimeFigureOut">
               <a:rPr lang="en-US" smtClean="0"/>
-              <a:t>5/25/2021</a:t>
+              <a:t>5/31/2021</a:t>
             </a:fld>
             <a:endParaRPr lang="en-US"/>
           </a:p>
@@ -659,7 +661,7 @@
           <a:p>
             <a:fld id="{07558649-2619-44F9-8F30-2D6466E57529}" type="datetimeFigureOut">
               <a:rPr lang="en-US" smtClean="0"/>
-              <a:t>5/25/2021</a:t>
+              <a:t>5/31/2021</a:t>
             </a:fld>
             <a:endParaRPr lang="en-US"/>
           </a:p>
@@ -827,7 +829,7 @@
           <a:p>
             <a:fld id="{07558649-2619-44F9-8F30-2D6466E57529}" type="datetimeFigureOut">
               <a:rPr lang="en-US" smtClean="0"/>
-              <a:t>5/25/2021</a:t>
+              <a:t>5/31/2021</a:t>
             </a:fld>
             <a:endParaRPr lang="en-US"/>
           </a:p>
@@ -1005,7 +1007,7 @@
           <a:p>
             <a:fld id="{07558649-2619-44F9-8F30-2D6466E57529}" type="datetimeFigureOut">
               <a:rPr lang="en-US" smtClean="0"/>
-              <a:t>5/25/2021</a:t>
+              <a:t>5/31/2021</a:t>
             </a:fld>
             <a:endParaRPr lang="en-US"/>
           </a:p>
@@ -1173,7 +1175,7 @@
           <a:p>
             <a:fld id="{07558649-2619-44F9-8F30-2D6466E57529}" type="datetimeFigureOut">
               <a:rPr lang="en-US" smtClean="0"/>
-              <a:t>5/25/2021</a:t>
+              <a:t>5/31/2021</a:t>
             </a:fld>
             <a:endParaRPr lang="en-US"/>
           </a:p>
@@ -1418,7 +1420,7 @@
           <a:p>
             <a:fld id="{07558649-2619-44F9-8F30-2D6466E57529}" type="datetimeFigureOut">
               <a:rPr lang="en-US" smtClean="0"/>
-              <a:t>5/25/2021</a:t>
+              <a:t>5/31/2021</a:t>
             </a:fld>
             <a:endParaRPr lang="en-US"/>
           </a:p>
@@ -1703,7 +1705,7 @@
           <a:p>
             <a:fld id="{07558649-2619-44F9-8F30-2D6466E57529}" type="datetimeFigureOut">
               <a:rPr lang="en-US" smtClean="0"/>
-              <a:t>5/25/2021</a:t>
+              <a:t>5/31/2021</a:t>
             </a:fld>
             <a:endParaRPr lang="en-US"/>
           </a:p>
@@ -2122,7 +2124,7 @@
           <a:p>
             <a:fld id="{07558649-2619-44F9-8F30-2D6466E57529}" type="datetimeFigureOut">
               <a:rPr lang="en-US" smtClean="0"/>
-              <a:t>5/25/2021</a:t>
+              <a:t>5/31/2021</a:t>
             </a:fld>
             <a:endParaRPr lang="en-US"/>
           </a:p>
@@ -2239,7 +2241,7 @@
           <a:p>
             <a:fld id="{07558649-2619-44F9-8F30-2D6466E57529}" type="datetimeFigureOut">
               <a:rPr lang="en-US" smtClean="0"/>
-              <a:t>5/25/2021</a:t>
+              <a:t>5/31/2021</a:t>
             </a:fld>
             <a:endParaRPr lang="en-US"/>
           </a:p>
@@ -2334,7 +2336,7 @@
           <a:p>
             <a:fld id="{07558649-2619-44F9-8F30-2D6466E57529}" type="datetimeFigureOut">
               <a:rPr lang="en-US" smtClean="0"/>
-              <a:t>5/25/2021</a:t>
+              <a:t>5/31/2021</a:t>
             </a:fld>
             <a:endParaRPr lang="en-US"/>
           </a:p>
@@ -2609,7 +2611,7 @@
           <a:p>
             <a:fld id="{07558649-2619-44F9-8F30-2D6466E57529}" type="datetimeFigureOut">
               <a:rPr lang="en-US" smtClean="0"/>
-              <a:t>5/25/2021</a:t>
+              <a:t>5/31/2021</a:t>
             </a:fld>
             <a:endParaRPr lang="en-US"/>
           </a:p>
@@ -2861,7 +2863,7 @@
           <a:p>
             <a:fld id="{07558649-2619-44F9-8F30-2D6466E57529}" type="datetimeFigureOut">
               <a:rPr lang="en-US" smtClean="0"/>
-              <a:t>5/25/2021</a:t>
+              <a:t>5/31/2021</a:t>
             </a:fld>
             <a:endParaRPr lang="en-US"/>
           </a:p>
@@ -3081,7 +3083,7 @@
           <a:p>
             <a:fld id="{07558649-2619-44F9-8F30-2D6466E57529}" type="datetimeFigureOut">
               <a:rPr lang="en-US" smtClean="0"/>
-              <a:t>5/25/2021</a:t>
+              <a:t>5/31/2021</a:t>
             </a:fld>
             <a:endParaRPr lang="en-US"/>
           </a:p>
@@ -3798,7 +3800,996 @@
                 </a:solidFill>
                 <a:latin typeface="Segoe UI" panose="020B0502040204020203" pitchFamily="34" charset="0"/>
               </a:rPr>
-              <a:t>Se agrego validación para la locación MSL (</a:t>
+              <a:t>Se agrego </a:t>
+            </a:r>
+            <a:r>
+              <a:rPr lang="en-US" sz="1200" dirty="0" err="1">
+                <a:solidFill>
+                  <a:srgbClr val="222222"/>
+                </a:solidFill>
+                <a:latin typeface="Segoe UI" panose="020B0502040204020203" pitchFamily="34" charset="0"/>
+              </a:rPr>
+              <a:t>opción</a:t>
+            </a:r>
+            <a:r>
+              <a:rPr lang="en-US" sz="1200" dirty="0">
+                <a:solidFill>
+                  <a:srgbClr val="222222"/>
+                </a:solidFill>
+                <a:latin typeface="Segoe UI" panose="020B0502040204020203" pitchFamily="34" charset="0"/>
+              </a:rPr>
+              <a:t> que </a:t>
+            </a:r>
+            <a:r>
+              <a:rPr lang="en-US" sz="1200" dirty="0" err="1">
+                <a:solidFill>
+                  <a:srgbClr val="222222"/>
+                </a:solidFill>
+                <a:latin typeface="Segoe UI" panose="020B0502040204020203" pitchFamily="34" charset="0"/>
+              </a:rPr>
+              <a:t>permite</a:t>
+            </a:r>
+            <a:r>
+              <a:rPr lang="en-US" sz="1200" dirty="0">
+                <a:solidFill>
+                  <a:srgbClr val="222222"/>
+                </a:solidFill>
+                <a:latin typeface="Segoe UI" panose="020B0502040204020203" pitchFamily="34" charset="0"/>
+              </a:rPr>
+              <a:t> </a:t>
+            </a:r>
+            <a:r>
+              <a:rPr lang="en-US" sz="1200" dirty="0" err="1">
+                <a:solidFill>
+                  <a:srgbClr val="222222"/>
+                </a:solidFill>
+                <a:latin typeface="Segoe UI" panose="020B0502040204020203" pitchFamily="34" charset="0"/>
+              </a:rPr>
+              <a:t>crear</a:t>
+            </a:r>
+            <a:r>
+              <a:rPr lang="en-US" sz="1200" dirty="0">
+                <a:solidFill>
+                  <a:srgbClr val="222222"/>
+                </a:solidFill>
+                <a:latin typeface="Segoe UI" panose="020B0502040204020203" pitchFamily="34" charset="0"/>
+              </a:rPr>
+              <a:t> folios </a:t>
+            </a:r>
+            <a:r>
+              <a:rPr lang="en-US" sz="1200" dirty="0" err="1">
+                <a:solidFill>
+                  <a:srgbClr val="222222"/>
+                </a:solidFill>
+                <a:latin typeface="Segoe UI" panose="020B0502040204020203" pitchFamily="34" charset="0"/>
+              </a:rPr>
+              <a:t>apartir</a:t>
+            </a:r>
+            <a:r>
+              <a:rPr lang="en-US" sz="1200" dirty="0">
+                <a:solidFill>
+                  <a:srgbClr val="222222"/>
+                </a:solidFill>
+                <a:latin typeface="Segoe UI" panose="020B0502040204020203" pitchFamily="34" charset="0"/>
+              </a:rPr>
+              <a:t> de un folio </a:t>
+            </a:r>
+            <a:r>
+              <a:rPr lang="en-US" sz="1200" dirty="0" err="1">
+                <a:solidFill>
+                  <a:srgbClr val="222222"/>
+                </a:solidFill>
+                <a:latin typeface="Segoe UI" panose="020B0502040204020203" pitchFamily="34" charset="0"/>
+              </a:rPr>
+              <a:t>detallado</a:t>
+            </a:r>
+            <a:r>
+              <a:rPr lang="en-US" sz="1200" dirty="0">
+                <a:solidFill>
+                  <a:srgbClr val="222222"/>
+                </a:solidFill>
+                <a:latin typeface="Segoe UI" panose="020B0502040204020203" pitchFamily="34" charset="0"/>
+              </a:rPr>
+              <a:t>, </a:t>
+            </a:r>
+            <a:r>
+              <a:rPr lang="en-US" sz="1200" dirty="0" err="1">
+                <a:solidFill>
+                  <a:srgbClr val="222222"/>
+                </a:solidFill>
+                <a:latin typeface="Segoe UI" panose="020B0502040204020203" pitchFamily="34" charset="0"/>
+              </a:rPr>
+              <a:t>esto</a:t>
+            </a:r>
+            <a:r>
+              <a:rPr lang="en-US" sz="1200" dirty="0">
+                <a:solidFill>
+                  <a:srgbClr val="222222"/>
+                </a:solidFill>
+                <a:latin typeface="Segoe UI" panose="020B0502040204020203" pitchFamily="34" charset="0"/>
+              </a:rPr>
+              <a:t> con </a:t>
+            </a:r>
+            <a:r>
+              <a:rPr lang="en-US" sz="1200" dirty="0" err="1">
+                <a:solidFill>
+                  <a:srgbClr val="222222"/>
+                </a:solidFill>
+                <a:latin typeface="Segoe UI" panose="020B0502040204020203" pitchFamily="34" charset="0"/>
+              </a:rPr>
+              <a:t>en</a:t>
+            </a:r>
+            <a:r>
+              <a:rPr lang="en-US" sz="1200" dirty="0">
+                <a:solidFill>
+                  <a:srgbClr val="222222"/>
+                </a:solidFill>
+                <a:latin typeface="Segoe UI" panose="020B0502040204020203" pitchFamily="34" charset="0"/>
+              </a:rPr>
+              <a:t> fin de </a:t>
+            </a:r>
+            <a:r>
+              <a:rPr lang="en-US" sz="1200" dirty="0" err="1">
+                <a:solidFill>
+                  <a:srgbClr val="222222"/>
+                </a:solidFill>
+                <a:latin typeface="Segoe UI" panose="020B0502040204020203" pitchFamily="34" charset="0"/>
+              </a:rPr>
+              <a:t>evitar</a:t>
+            </a:r>
+            <a:r>
+              <a:rPr lang="en-US" sz="1200" dirty="0">
+                <a:solidFill>
+                  <a:srgbClr val="222222"/>
+                </a:solidFill>
+                <a:latin typeface="Segoe UI" panose="020B0502040204020203" pitchFamily="34" charset="0"/>
+              </a:rPr>
+              <a:t> que </a:t>
+            </a:r>
+            <a:r>
+              <a:rPr lang="en-US" sz="1200" dirty="0" err="1">
+                <a:solidFill>
+                  <a:srgbClr val="222222"/>
+                </a:solidFill>
+                <a:latin typeface="Segoe UI" panose="020B0502040204020203" pitchFamily="34" charset="0"/>
+              </a:rPr>
+              <a:t>calidad</a:t>
+            </a:r>
+            <a:r>
+              <a:rPr lang="en-US" sz="1200" dirty="0">
+                <a:solidFill>
+                  <a:srgbClr val="222222"/>
+                </a:solidFill>
+                <a:latin typeface="Segoe UI" panose="020B0502040204020203" pitchFamily="34" charset="0"/>
+              </a:rPr>
+              <a:t> </a:t>
+            </a:r>
+            <a:r>
+              <a:rPr lang="en-US" sz="1200" dirty="0" err="1">
+                <a:solidFill>
+                  <a:srgbClr val="222222"/>
+                </a:solidFill>
+                <a:latin typeface="Segoe UI" panose="020B0502040204020203" pitchFamily="34" charset="0"/>
+              </a:rPr>
+              <a:t>busque</a:t>
+            </a:r>
+            <a:r>
+              <a:rPr lang="en-US" sz="1200" dirty="0">
+                <a:solidFill>
+                  <a:srgbClr val="222222"/>
+                </a:solidFill>
+                <a:latin typeface="Segoe UI" panose="020B0502040204020203" pitchFamily="34" charset="0"/>
+              </a:rPr>
+              <a:t> de </a:t>
+            </a:r>
+            <a:r>
+              <a:rPr lang="en-US" sz="1200" dirty="0" err="1">
+                <a:solidFill>
+                  <a:srgbClr val="222222"/>
+                </a:solidFill>
+                <a:latin typeface="Segoe UI" panose="020B0502040204020203" pitchFamily="34" charset="0"/>
+              </a:rPr>
+              <a:t>manera</a:t>
+            </a:r>
+            <a:r>
+              <a:rPr lang="en-US" sz="1200" dirty="0">
+                <a:solidFill>
+                  <a:srgbClr val="222222"/>
+                </a:solidFill>
+                <a:latin typeface="Segoe UI" panose="020B0502040204020203" pitchFamily="34" charset="0"/>
+              </a:rPr>
+              <a:t> manual </a:t>
+            </a:r>
+            <a:r>
+              <a:rPr lang="en-US" sz="1200" dirty="0" err="1">
+                <a:solidFill>
+                  <a:srgbClr val="222222"/>
+                </a:solidFill>
+                <a:latin typeface="Segoe UI" panose="020B0502040204020203" pitchFamily="34" charset="0"/>
+              </a:rPr>
+              <a:t>en</a:t>
+            </a:r>
+            <a:r>
+              <a:rPr lang="en-US" sz="1200" dirty="0">
+                <a:solidFill>
+                  <a:srgbClr val="222222"/>
+                </a:solidFill>
+                <a:latin typeface="Segoe UI" panose="020B0502040204020203" pitchFamily="34" charset="0"/>
+              </a:rPr>
+              <a:t> los </a:t>
+            </a:r>
+            <a:r>
+              <a:rPr lang="en-US" sz="1200" dirty="0" err="1">
+                <a:solidFill>
+                  <a:srgbClr val="222222"/>
+                </a:solidFill>
+                <a:latin typeface="Segoe UI" panose="020B0502040204020203" pitchFamily="34" charset="0"/>
+              </a:rPr>
+              <a:t>diferentes</a:t>
+            </a:r>
+            <a:r>
+              <a:rPr lang="en-US" sz="1200" dirty="0">
+                <a:solidFill>
+                  <a:srgbClr val="222222"/>
+                </a:solidFill>
+                <a:latin typeface="Segoe UI" panose="020B0502040204020203" pitchFamily="34" charset="0"/>
+              </a:rPr>
+              <a:t> folios de MQU las </a:t>
+            </a:r>
+            <a:r>
+              <a:rPr lang="en-US" sz="1200" dirty="0" err="1">
+                <a:solidFill>
+                  <a:srgbClr val="222222"/>
+                </a:solidFill>
+                <a:latin typeface="Segoe UI" panose="020B0502040204020203" pitchFamily="34" charset="0"/>
+              </a:rPr>
+              <a:t>pieles</a:t>
+            </a:r>
+            <a:r>
+              <a:rPr lang="en-US" sz="1200" dirty="0">
+                <a:solidFill>
+                  <a:srgbClr val="222222"/>
+                </a:solidFill>
+                <a:latin typeface="Segoe UI" panose="020B0502040204020203" pitchFamily="34" charset="0"/>
+              </a:rPr>
+              <a:t> de un folio </a:t>
+            </a:r>
+            <a:r>
+              <a:rPr lang="en-US" sz="1200" dirty="0" err="1">
+                <a:solidFill>
+                  <a:srgbClr val="222222"/>
+                </a:solidFill>
+                <a:latin typeface="Segoe UI" panose="020B0502040204020203" pitchFamily="34" charset="0"/>
+              </a:rPr>
+              <a:t>detallado</a:t>
+            </a:r>
+            <a:r>
+              <a:rPr lang="es-ES" sz="1200" b="0" i="0" dirty="0">
+                <a:solidFill>
+                  <a:srgbClr val="222222"/>
+                </a:solidFill>
+                <a:effectLst/>
+                <a:latin typeface="Segoe UI" panose="020B0502040204020203" pitchFamily="34" charset="0"/>
+              </a:rPr>
+              <a:t>.</a:t>
+            </a:r>
+          </a:p>
+        </p:txBody>
+      </p:sp>
+      <p:pic>
+        <p:nvPicPr>
+          <p:cNvPr id="3" name="Imagen 2" descr="Interfaz de usuario gráfica&#10;&#10;Descripción generada automáticamente">
+            <a:extLst>
+              <a:ext uri="{FF2B5EF4-FFF2-40B4-BE49-F238E27FC236}">
+                <a16:creationId xmlns:a16="http://schemas.microsoft.com/office/drawing/2014/main" id="{151B0094-B2A8-4FEB-9BE5-64EC697C8484}"/>
+              </a:ext>
+            </a:extLst>
+          </p:cNvPr>
+          <p:cNvPicPr>
+            <a:picLocks noChangeAspect="1"/>
+          </p:cNvPicPr>
+          <p:nvPr/>
+        </p:nvPicPr>
+        <p:blipFill>
+          <a:blip r:embed="rId2">
+            <a:extLst>
+              <a:ext uri="{28A0092B-C50C-407E-A947-70E740481C1C}">
+                <a14:useLocalDpi xmlns:a14="http://schemas.microsoft.com/office/drawing/2010/main" val="0"/>
+              </a:ext>
+            </a:extLst>
+          </a:blip>
+          <a:stretch>
+            <a:fillRect/>
+          </a:stretch>
+        </p:blipFill>
+        <p:spPr>
+          <a:xfrm>
+            <a:off x="1331640" y="1442393"/>
+            <a:ext cx="7632848" cy="5353805"/>
+          </a:xfrm>
+          <a:prstGeom prst="rect">
+            <a:avLst/>
+          </a:prstGeom>
+        </p:spPr>
+      </p:pic>
+      <p:sp>
+        <p:nvSpPr>
+          <p:cNvPr id="7" name="Rectángulo 6">
+            <a:extLst>
+              <a:ext uri="{FF2B5EF4-FFF2-40B4-BE49-F238E27FC236}">
+                <a16:creationId xmlns:a16="http://schemas.microsoft.com/office/drawing/2014/main" id="{690B8971-4C7B-4126-A32A-416BF4B8E142}"/>
+              </a:ext>
+            </a:extLst>
+          </p:cNvPr>
+          <p:cNvSpPr/>
+          <p:nvPr/>
+        </p:nvSpPr>
+        <p:spPr>
+          <a:xfrm>
+            <a:off x="6660232" y="5877272"/>
+            <a:ext cx="2304256" cy="432048"/>
+          </a:xfrm>
+          <a:prstGeom prst="rect">
+            <a:avLst/>
+          </a:prstGeom>
+          <a:noFill/>
+          <a:ln>
+            <a:solidFill>
+              <a:srgbClr val="FF0000"/>
+            </a:solidFill>
+          </a:ln>
+        </p:spPr>
+        <p:style>
+          <a:lnRef idx="2">
+            <a:schemeClr val="accent1">
+              <a:shade val="50000"/>
+            </a:schemeClr>
+          </a:lnRef>
+          <a:fillRef idx="1">
+            <a:schemeClr val="accent1"/>
+          </a:fillRef>
+          <a:effectRef idx="0">
+            <a:schemeClr val="accent1"/>
+          </a:effectRef>
+          <a:fontRef idx="minor">
+            <a:schemeClr val="lt1"/>
+          </a:fontRef>
+        </p:style>
+        <p:txBody>
+          <a:bodyPr rtlCol="0" anchor="ctr"/>
+          <a:lstStyle/>
+          <a:p>
+            <a:pPr algn="ctr"/>
+            <a:endParaRPr lang="en-US"/>
+          </a:p>
+        </p:txBody>
+      </p:sp>
+    </p:spTree>
+    <p:extLst>
+      <p:ext uri="{BB962C8B-B14F-4D97-AF65-F5344CB8AC3E}">
+        <p14:creationId xmlns:p14="http://schemas.microsoft.com/office/powerpoint/2010/main" val="2170633103"/>
+      </p:ext>
+    </p:extLst>
+  </p:cSld>
+  <p:clrMapOvr>
+    <a:masterClrMapping/>
+  </p:clrMapOvr>
+</p:sld>
+</file>
+
+<file path=ppt/slides/slide3.xml><?xml version="1.0" encoding="utf-8"?>
+<p:sld xmlns:a="http://schemas.openxmlformats.org/drawingml/2006/main" xmlns:r="http://schemas.openxmlformats.org/officeDocument/2006/relationships" xmlns:p="http://schemas.openxmlformats.org/presentationml/2006/main">
+  <p:cSld>
+    <p:spTree>
+      <p:nvGrpSpPr>
+        <p:cNvPr id="1" name=""/>
+        <p:cNvGrpSpPr/>
+        <p:nvPr/>
+      </p:nvGrpSpPr>
+      <p:grpSpPr>
+        <a:xfrm>
+          <a:off x="0" y="0"/>
+          <a:ext cx="0" cy="0"/>
+          <a:chOff x="0" y="0"/>
+          <a:chExt cx="0" cy="0"/>
+        </a:xfrm>
+      </p:grpSpPr>
+      <p:sp>
+        <p:nvSpPr>
+          <p:cNvPr id="8" name="Title 1"/>
+          <p:cNvSpPr txBox="1">
+            <a:spLocks/>
+          </p:cNvSpPr>
+          <p:nvPr/>
+        </p:nvSpPr>
+        <p:spPr>
+          <a:xfrm>
+            <a:off x="1087408" y="274638"/>
+            <a:ext cx="7229008" cy="634082"/>
+          </a:xfrm>
+          <a:prstGeom prst="rect">
+            <a:avLst/>
+          </a:prstGeom>
+        </p:spPr>
+        <p:txBody>
+          <a:bodyPr/>
+          <a:lstStyle>
+            <a:lvl1pPr algn="ctr" defTabSz="914400" rtl="0" eaLnBrk="1" latinLnBrk="0" hangingPunct="1">
+              <a:spcBef>
+                <a:spcPct val="0"/>
+              </a:spcBef>
+              <a:buNone/>
+              <a:defRPr sz="4400" kern="1200">
+                <a:solidFill>
+                  <a:schemeClr val="tx1"/>
+                </a:solidFill>
+                <a:latin typeface="+mj-lt"/>
+                <a:ea typeface="+mj-ea"/>
+                <a:cs typeface="+mj-cs"/>
+              </a:defRPr>
+            </a:lvl1pPr>
+          </a:lstStyle>
+          <a:p>
+            <a:pPr algn="l"/>
+            <a:r>
+              <a:rPr lang="es-ES" sz="2000" dirty="0">
+                <a:solidFill>
+                  <a:srgbClr val="3F1900"/>
+                </a:solidFill>
+              </a:rPr>
+              <a:t>TRANSFERENCIA DE FOLIOS.</a:t>
+            </a:r>
+            <a:endParaRPr lang="en-US" sz="2000" dirty="0">
+              <a:solidFill>
+                <a:srgbClr val="3F1900"/>
+              </a:solidFill>
+            </a:endParaRPr>
+          </a:p>
+        </p:txBody>
+      </p:sp>
+      <p:sp>
+        <p:nvSpPr>
+          <p:cNvPr id="4" name="Content Placeholder 3"/>
+          <p:cNvSpPr txBox="1">
+            <a:spLocks/>
+          </p:cNvSpPr>
+          <p:nvPr/>
+        </p:nvSpPr>
+        <p:spPr>
+          <a:xfrm>
+            <a:off x="1331640" y="1196753"/>
+            <a:ext cx="7488832" cy="5137780"/>
+          </a:xfrm>
+          <a:prstGeom prst="rect">
+            <a:avLst/>
+          </a:prstGeom>
+        </p:spPr>
+        <p:txBody>
+          <a:bodyPr>
+            <a:normAutofit/>
+          </a:bodyPr>
+          <a:lstStyle>
+            <a:lvl1pPr marL="342900" indent="-342900" algn="l" defTabSz="914400" rtl="0" eaLnBrk="1" latinLnBrk="0" hangingPunct="1">
+              <a:spcBef>
+                <a:spcPct val="20000"/>
+              </a:spcBef>
+              <a:buFont typeface="Arial" panose="020B0604020202020204" pitchFamily="34" charset="0"/>
+              <a:buChar char="•"/>
+              <a:defRPr sz="3200" kern="1200">
+                <a:solidFill>
+                  <a:schemeClr val="tx1"/>
+                </a:solidFill>
+                <a:latin typeface="+mn-lt"/>
+                <a:ea typeface="+mn-ea"/>
+                <a:cs typeface="+mn-cs"/>
+              </a:defRPr>
+            </a:lvl1pPr>
+            <a:lvl2pPr marL="742950" indent="-285750" algn="l" defTabSz="914400" rtl="0" eaLnBrk="1" latinLnBrk="0" hangingPunct="1">
+              <a:spcBef>
+                <a:spcPct val="20000"/>
+              </a:spcBef>
+              <a:buFont typeface="Arial" panose="020B0604020202020204" pitchFamily="34" charset="0"/>
+              <a:buChar char="–"/>
+              <a:defRPr sz="2800" kern="1200">
+                <a:solidFill>
+                  <a:schemeClr val="tx1"/>
+                </a:solidFill>
+                <a:latin typeface="+mn-lt"/>
+                <a:ea typeface="+mn-ea"/>
+                <a:cs typeface="+mn-cs"/>
+              </a:defRPr>
+            </a:lvl2pPr>
+            <a:lvl3pPr marL="1143000" indent="-228600" algn="l" defTabSz="914400" rtl="0" eaLnBrk="1" latinLnBrk="0" hangingPunct="1">
+              <a:spcBef>
+                <a:spcPct val="20000"/>
+              </a:spcBef>
+              <a:buFont typeface="Arial" panose="020B0604020202020204" pitchFamily="34" charset="0"/>
+              <a:buChar char="•"/>
+              <a:defRPr sz="2400" kern="1200">
+                <a:solidFill>
+                  <a:schemeClr val="tx1"/>
+                </a:solidFill>
+                <a:latin typeface="+mn-lt"/>
+                <a:ea typeface="+mn-ea"/>
+                <a:cs typeface="+mn-cs"/>
+              </a:defRPr>
+            </a:lvl3pPr>
+            <a:lvl4pPr marL="1600200" indent="-228600" algn="l" defTabSz="914400" rtl="0" eaLnBrk="1" latinLnBrk="0" hangingPunct="1">
+              <a:spcBef>
+                <a:spcPct val="20000"/>
+              </a:spcBef>
+              <a:buFont typeface="Arial" panose="020B0604020202020204" pitchFamily="34" charset="0"/>
+              <a:buChar char="–"/>
+              <a:defRPr sz="2000" kern="1200">
+                <a:solidFill>
+                  <a:schemeClr val="tx1"/>
+                </a:solidFill>
+                <a:latin typeface="+mn-lt"/>
+                <a:ea typeface="+mn-ea"/>
+                <a:cs typeface="+mn-cs"/>
+              </a:defRPr>
+            </a:lvl4pPr>
+            <a:lvl5pPr marL="2057400" indent="-228600" algn="l" defTabSz="914400" rtl="0" eaLnBrk="1" latinLnBrk="0" hangingPunct="1">
+              <a:spcBef>
+                <a:spcPct val="20000"/>
+              </a:spcBef>
+              <a:buFont typeface="Arial" panose="020B0604020202020204" pitchFamily="34" charset="0"/>
+              <a:buChar char="»"/>
+              <a:defRPr sz="2000" kern="1200">
+                <a:solidFill>
+                  <a:schemeClr val="tx1"/>
+                </a:solidFill>
+                <a:latin typeface="+mn-lt"/>
+                <a:ea typeface="+mn-ea"/>
+                <a:cs typeface="+mn-cs"/>
+              </a:defRPr>
+            </a:lvl5pPr>
+            <a:lvl6pPr marL="2514600" indent="-228600" algn="l" defTabSz="914400" rtl="0" eaLnBrk="1" latinLnBrk="0" hangingPunct="1">
+              <a:spcBef>
+                <a:spcPct val="20000"/>
+              </a:spcBef>
+              <a:buFont typeface="Arial" panose="020B0604020202020204" pitchFamily="34" charset="0"/>
+              <a:buChar char="•"/>
+              <a:defRPr sz="2000" kern="1200">
+                <a:solidFill>
+                  <a:schemeClr val="tx1"/>
+                </a:solidFill>
+                <a:latin typeface="+mn-lt"/>
+                <a:ea typeface="+mn-ea"/>
+                <a:cs typeface="+mn-cs"/>
+              </a:defRPr>
+            </a:lvl6pPr>
+            <a:lvl7pPr marL="2971800" indent="-228600" algn="l" defTabSz="914400" rtl="0" eaLnBrk="1" latinLnBrk="0" hangingPunct="1">
+              <a:spcBef>
+                <a:spcPct val="20000"/>
+              </a:spcBef>
+              <a:buFont typeface="Arial" panose="020B0604020202020204" pitchFamily="34" charset="0"/>
+              <a:buChar char="•"/>
+              <a:defRPr sz="2000" kern="1200">
+                <a:solidFill>
+                  <a:schemeClr val="tx1"/>
+                </a:solidFill>
+                <a:latin typeface="+mn-lt"/>
+                <a:ea typeface="+mn-ea"/>
+                <a:cs typeface="+mn-cs"/>
+              </a:defRPr>
+            </a:lvl7pPr>
+            <a:lvl8pPr marL="3429000" indent="-228600" algn="l" defTabSz="914400" rtl="0" eaLnBrk="1" latinLnBrk="0" hangingPunct="1">
+              <a:spcBef>
+                <a:spcPct val="20000"/>
+              </a:spcBef>
+              <a:buFont typeface="Arial" panose="020B0604020202020204" pitchFamily="34" charset="0"/>
+              <a:buChar char="•"/>
+              <a:defRPr sz="2000" kern="1200">
+                <a:solidFill>
+                  <a:schemeClr val="tx1"/>
+                </a:solidFill>
+                <a:latin typeface="+mn-lt"/>
+                <a:ea typeface="+mn-ea"/>
+                <a:cs typeface="+mn-cs"/>
+              </a:defRPr>
+            </a:lvl8pPr>
+            <a:lvl9pPr marL="3886200" indent="-228600" algn="l" defTabSz="914400" rtl="0" eaLnBrk="1" latinLnBrk="0" hangingPunct="1">
+              <a:spcBef>
+                <a:spcPct val="20000"/>
+              </a:spcBef>
+              <a:buFont typeface="Arial" panose="020B0604020202020204" pitchFamily="34" charset="0"/>
+              <a:buChar char="•"/>
+              <a:defRPr sz="2000" kern="1200">
+                <a:solidFill>
+                  <a:schemeClr val="tx1"/>
+                </a:solidFill>
+                <a:latin typeface="+mn-lt"/>
+                <a:ea typeface="+mn-ea"/>
+                <a:cs typeface="+mn-cs"/>
+              </a:defRPr>
+            </a:lvl9pPr>
+          </a:lstStyle>
+          <a:p>
+            <a:pPr marL="0" indent="0" algn="just">
+              <a:buFont typeface="Arial" panose="020B0604020202020204" pitchFamily="34" charset="0"/>
+              <a:buNone/>
+            </a:pPr>
+            <a:endParaRPr lang="en-US" sz="2000" i="1"/>
+          </a:p>
+        </p:txBody>
+      </p:sp>
+      <p:sp>
+        <p:nvSpPr>
+          <p:cNvPr id="10" name="Rectangle 9"/>
+          <p:cNvSpPr/>
+          <p:nvPr/>
+        </p:nvSpPr>
+        <p:spPr>
+          <a:xfrm>
+            <a:off x="1331640" y="980728"/>
+            <a:ext cx="7632848" cy="276999"/>
+          </a:xfrm>
+          <a:prstGeom prst="rect">
+            <a:avLst/>
+          </a:prstGeom>
+        </p:spPr>
+        <p:txBody>
+          <a:bodyPr wrap="square">
+            <a:spAutoFit/>
+          </a:bodyPr>
+          <a:lstStyle/>
+          <a:p>
+            <a:pPr>
+              <a:buFont typeface="Arial" panose="020B0604020202020204" pitchFamily="34" charset="0"/>
+              <a:buChar char="•"/>
+            </a:pPr>
+            <a:r>
+              <a:rPr lang="es-ES" sz="1200" dirty="0">
+                <a:solidFill>
+                  <a:srgbClr val="222222"/>
+                </a:solidFill>
+                <a:latin typeface="Segoe UI" panose="020B0502040204020203" pitchFamily="34" charset="0"/>
+              </a:rPr>
+              <a:t> Esta opción enviara correos al personal de calidad con cada uno de los folios generados</a:t>
+            </a:r>
+            <a:r>
+              <a:rPr lang="es-ES" sz="1200" b="0" i="0" dirty="0">
+                <a:solidFill>
+                  <a:srgbClr val="222222"/>
+                </a:solidFill>
+                <a:effectLst/>
+                <a:latin typeface="Segoe UI" panose="020B0502040204020203" pitchFamily="34" charset="0"/>
+              </a:rPr>
+              <a:t>.</a:t>
+            </a:r>
+          </a:p>
+        </p:txBody>
+      </p:sp>
+      <p:pic>
+        <p:nvPicPr>
+          <p:cNvPr id="5" name="Imagen 4" descr="Interfaz de usuario gráfica, Texto, Aplicación, Correo electrónico&#10;&#10;Descripción generada automáticamente">
+            <a:extLst>
+              <a:ext uri="{FF2B5EF4-FFF2-40B4-BE49-F238E27FC236}">
+                <a16:creationId xmlns:a16="http://schemas.microsoft.com/office/drawing/2014/main" id="{914F3882-7E9A-40AD-A074-C0C01FA366A6}"/>
+              </a:ext>
+            </a:extLst>
+          </p:cNvPr>
+          <p:cNvPicPr>
+            <a:picLocks noChangeAspect="1"/>
+          </p:cNvPicPr>
+          <p:nvPr/>
+        </p:nvPicPr>
+        <p:blipFill>
+          <a:blip r:embed="rId2">
+            <a:extLst>
+              <a:ext uri="{28A0092B-C50C-407E-A947-70E740481C1C}">
+                <a14:useLocalDpi xmlns:a14="http://schemas.microsoft.com/office/drawing/2010/main" val="0"/>
+              </a:ext>
+            </a:extLst>
+          </a:blip>
+          <a:stretch>
+            <a:fillRect/>
+          </a:stretch>
+        </p:blipFill>
+        <p:spPr>
+          <a:xfrm>
+            <a:off x="1187624" y="1340768"/>
+            <a:ext cx="7848872" cy="2984753"/>
+          </a:xfrm>
+          <a:prstGeom prst="rect">
+            <a:avLst/>
+          </a:prstGeom>
+        </p:spPr>
+      </p:pic>
+    </p:spTree>
+    <p:extLst>
+      <p:ext uri="{BB962C8B-B14F-4D97-AF65-F5344CB8AC3E}">
+        <p14:creationId xmlns:p14="http://schemas.microsoft.com/office/powerpoint/2010/main" val="4145213475"/>
+      </p:ext>
+    </p:extLst>
+  </p:cSld>
+  <p:clrMapOvr>
+    <a:masterClrMapping/>
+  </p:clrMapOvr>
+</p:sld>
+</file>
+
+<file path=ppt/slides/slide4.xml><?xml version="1.0" encoding="utf-8"?>
+<p:sld xmlns:a="http://schemas.openxmlformats.org/drawingml/2006/main" xmlns:r="http://schemas.openxmlformats.org/officeDocument/2006/relationships" xmlns:p="http://schemas.openxmlformats.org/presentationml/2006/main">
+  <p:cSld>
+    <p:spTree>
+      <p:nvGrpSpPr>
+        <p:cNvPr id="1" name=""/>
+        <p:cNvGrpSpPr/>
+        <p:nvPr/>
+      </p:nvGrpSpPr>
+      <p:grpSpPr>
+        <a:xfrm>
+          <a:off x="0" y="0"/>
+          <a:ext cx="0" cy="0"/>
+          <a:chOff x="0" y="0"/>
+          <a:chExt cx="0" cy="0"/>
+        </a:xfrm>
+      </p:grpSpPr>
+      <p:sp>
+        <p:nvSpPr>
+          <p:cNvPr id="8" name="Title 1"/>
+          <p:cNvSpPr txBox="1">
+            <a:spLocks/>
+          </p:cNvSpPr>
+          <p:nvPr/>
+        </p:nvSpPr>
+        <p:spPr>
+          <a:xfrm>
+            <a:off x="1087408" y="274638"/>
+            <a:ext cx="7229008" cy="634082"/>
+          </a:xfrm>
+          <a:prstGeom prst="rect">
+            <a:avLst/>
+          </a:prstGeom>
+        </p:spPr>
+        <p:txBody>
+          <a:bodyPr/>
+          <a:lstStyle>
+            <a:lvl1pPr algn="ctr" defTabSz="914400" rtl="0" eaLnBrk="1" latinLnBrk="0" hangingPunct="1">
+              <a:spcBef>
+                <a:spcPct val="0"/>
+              </a:spcBef>
+              <a:buNone/>
+              <a:defRPr sz="4400" kern="1200">
+                <a:solidFill>
+                  <a:schemeClr val="tx1"/>
+                </a:solidFill>
+                <a:latin typeface="+mj-lt"/>
+                <a:ea typeface="+mj-ea"/>
+                <a:cs typeface="+mj-cs"/>
+              </a:defRPr>
+            </a:lvl1pPr>
+          </a:lstStyle>
+          <a:p>
+            <a:pPr algn="l"/>
+            <a:r>
+              <a:rPr lang="es-ES" sz="2000" dirty="0">
+                <a:solidFill>
+                  <a:srgbClr val="3F1900"/>
+                </a:solidFill>
+              </a:rPr>
+              <a:t>TRANSFERENCIA DE FOLIOS.</a:t>
+            </a:r>
+            <a:endParaRPr lang="en-US" sz="2000" dirty="0">
+              <a:solidFill>
+                <a:srgbClr val="3F1900"/>
+              </a:solidFill>
+            </a:endParaRPr>
+          </a:p>
+        </p:txBody>
+      </p:sp>
+      <p:sp>
+        <p:nvSpPr>
+          <p:cNvPr id="4" name="Content Placeholder 3"/>
+          <p:cNvSpPr txBox="1">
+            <a:spLocks/>
+          </p:cNvSpPr>
+          <p:nvPr/>
+        </p:nvSpPr>
+        <p:spPr>
+          <a:xfrm>
+            <a:off x="1331640" y="1196753"/>
+            <a:ext cx="7488832" cy="5137780"/>
+          </a:xfrm>
+          <a:prstGeom prst="rect">
+            <a:avLst/>
+          </a:prstGeom>
+        </p:spPr>
+        <p:txBody>
+          <a:bodyPr>
+            <a:normAutofit/>
+          </a:bodyPr>
+          <a:lstStyle>
+            <a:lvl1pPr marL="342900" indent="-342900" algn="l" defTabSz="914400" rtl="0" eaLnBrk="1" latinLnBrk="0" hangingPunct="1">
+              <a:spcBef>
+                <a:spcPct val="20000"/>
+              </a:spcBef>
+              <a:buFont typeface="Arial" panose="020B0604020202020204" pitchFamily="34" charset="0"/>
+              <a:buChar char="•"/>
+              <a:defRPr sz="3200" kern="1200">
+                <a:solidFill>
+                  <a:schemeClr val="tx1"/>
+                </a:solidFill>
+                <a:latin typeface="+mn-lt"/>
+                <a:ea typeface="+mn-ea"/>
+                <a:cs typeface="+mn-cs"/>
+              </a:defRPr>
+            </a:lvl1pPr>
+            <a:lvl2pPr marL="742950" indent="-285750" algn="l" defTabSz="914400" rtl="0" eaLnBrk="1" latinLnBrk="0" hangingPunct="1">
+              <a:spcBef>
+                <a:spcPct val="20000"/>
+              </a:spcBef>
+              <a:buFont typeface="Arial" panose="020B0604020202020204" pitchFamily="34" charset="0"/>
+              <a:buChar char="–"/>
+              <a:defRPr sz="2800" kern="1200">
+                <a:solidFill>
+                  <a:schemeClr val="tx1"/>
+                </a:solidFill>
+                <a:latin typeface="+mn-lt"/>
+                <a:ea typeface="+mn-ea"/>
+                <a:cs typeface="+mn-cs"/>
+              </a:defRPr>
+            </a:lvl2pPr>
+            <a:lvl3pPr marL="1143000" indent="-228600" algn="l" defTabSz="914400" rtl="0" eaLnBrk="1" latinLnBrk="0" hangingPunct="1">
+              <a:spcBef>
+                <a:spcPct val="20000"/>
+              </a:spcBef>
+              <a:buFont typeface="Arial" panose="020B0604020202020204" pitchFamily="34" charset="0"/>
+              <a:buChar char="•"/>
+              <a:defRPr sz="2400" kern="1200">
+                <a:solidFill>
+                  <a:schemeClr val="tx1"/>
+                </a:solidFill>
+                <a:latin typeface="+mn-lt"/>
+                <a:ea typeface="+mn-ea"/>
+                <a:cs typeface="+mn-cs"/>
+              </a:defRPr>
+            </a:lvl3pPr>
+            <a:lvl4pPr marL="1600200" indent="-228600" algn="l" defTabSz="914400" rtl="0" eaLnBrk="1" latinLnBrk="0" hangingPunct="1">
+              <a:spcBef>
+                <a:spcPct val="20000"/>
+              </a:spcBef>
+              <a:buFont typeface="Arial" panose="020B0604020202020204" pitchFamily="34" charset="0"/>
+              <a:buChar char="–"/>
+              <a:defRPr sz="2000" kern="1200">
+                <a:solidFill>
+                  <a:schemeClr val="tx1"/>
+                </a:solidFill>
+                <a:latin typeface="+mn-lt"/>
+                <a:ea typeface="+mn-ea"/>
+                <a:cs typeface="+mn-cs"/>
+              </a:defRPr>
+            </a:lvl4pPr>
+            <a:lvl5pPr marL="2057400" indent="-228600" algn="l" defTabSz="914400" rtl="0" eaLnBrk="1" latinLnBrk="0" hangingPunct="1">
+              <a:spcBef>
+                <a:spcPct val="20000"/>
+              </a:spcBef>
+              <a:buFont typeface="Arial" panose="020B0604020202020204" pitchFamily="34" charset="0"/>
+              <a:buChar char="»"/>
+              <a:defRPr sz="2000" kern="1200">
+                <a:solidFill>
+                  <a:schemeClr val="tx1"/>
+                </a:solidFill>
+                <a:latin typeface="+mn-lt"/>
+                <a:ea typeface="+mn-ea"/>
+                <a:cs typeface="+mn-cs"/>
+              </a:defRPr>
+            </a:lvl5pPr>
+            <a:lvl6pPr marL="2514600" indent="-228600" algn="l" defTabSz="914400" rtl="0" eaLnBrk="1" latinLnBrk="0" hangingPunct="1">
+              <a:spcBef>
+                <a:spcPct val="20000"/>
+              </a:spcBef>
+              <a:buFont typeface="Arial" panose="020B0604020202020204" pitchFamily="34" charset="0"/>
+              <a:buChar char="•"/>
+              <a:defRPr sz="2000" kern="1200">
+                <a:solidFill>
+                  <a:schemeClr val="tx1"/>
+                </a:solidFill>
+                <a:latin typeface="+mn-lt"/>
+                <a:ea typeface="+mn-ea"/>
+                <a:cs typeface="+mn-cs"/>
+              </a:defRPr>
+            </a:lvl6pPr>
+            <a:lvl7pPr marL="2971800" indent="-228600" algn="l" defTabSz="914400" rtl="0" eaLnBrk="1" latinLnBrk="0" hangingPunct="1">
+              <a:spcBef>
+                <a:spcPct val="20000"/>
+              </a:spcBef>
+              <a:buFont typeface="Arial" panose="020B0604020202020204" pitchFamily="34" charset="0"/>
+              <a:buChar char="•"/>
+              <a:defRPr sz="2000" kern="1200">
+                <a:solidFill>
+                  <a:schemeClr val="tx1"/>
+                </a:solidFill>
+                <a:latin typeface="+mn-lt"/>
+                <a:ea typeface="+mn-ea"/>
+                <a:cs typeface="+mn-cs"/>
+              </a:defRPr>
+            </a:lvl7pPr>
+            <a:lvl8pPr marL="3429000" indent="-228600" algn="l" defTabSz="914400" rtl="0" eaLnBrk="1" latinLnBrk="0" hangingPunct="1">
+              <a:spcBef>
+                <a:spcPct val="20000"/>
+              </a:spcBef>
+              <a:buFont typeface="Arial" panose="020B0604020202020204" pitchFamily="34" charset="0"/>
+              <a:buChar char="•"/>
+              <a:defRPr sz="2000" kern="1200">
+                <a:solidFill>
+                  <a:schemeClr val="tx1"/>
+                </a:solidFill>
+                <a:latin typeface="+mn-lt"/>
+                <a:ea typeface="+mn-ea"/>
+                <a:cs typeface="+mn-cs"/>
+              </a:defRPr>
+            </a:lvl8pPr>
+            <a:lvl9pPr marL="3886200" indent="-228600" algn="l" defTabSz="914400" rtl="0" eaLnBrk="1" latinLnBrk="0" hangingPunct="1">
+              <a:spcBef>
+                <a:spcPct val="20000"/>
+              </a:spcBef>
+              <a:buFont typeface="Arial" panose="020B0604020202020204" pitchFamily="34" charset="0"/>
+              <a:buChar char="•"/>
+              <a:defRPr sz="2000" kern="1200">
+                <a:solidFill>
+                  <a:schemeClr val="tx1"/>
+                </a:solidFill>
+                <a:latin typeface="+mn-lt"/>
+                <a:ea typeface="+mn-ea"/>
+                <a:cs typeface="+mn-cs"/>
+              </a:defRPr>
+            </a:lvl9pPr>
+          </a:lstStyle>
+          <a:p>
+            <a:pPr marL="0" indent="0" algn="just">
+              <a:buFont typeface="Arial" panose="020B0604020202020204" pitchFamily="34" charset="0"/>
+              <a:buNone/>
+            </a:pPr>
+            <a:endParaRPr lang="en-US" sz="2000" i="1"/>
+          </a:p>
+        </p:txBody>
+      </p:sp>
+      <p:sp>
+        <p:nvSpPr>
+          <p:cNvPr id="10" name="Rectangle 9"/>
+          <p:cNvSpPr/>
+          <p:nvPr/>
+        </p:nvSpPr>
+        <p:spPr>
+          <a:xfrm>
+            <a:off x="1331640" y="980728"/>
+            <a:ext cx="7632848" cy="461665"/>
+          </a:xfrm>
+          <a:prstGeom prst="rect">
+            <a:avLst/>
+          </a:prstGeom>
+        </p:spPr>
+        <p:txBody>
+          <a:bodyPr wrap="square">
+            <a:spAutoFit/>
+          </a:bodyPr>
+          <a:lstStyle/>
+          <a:p>
+            <a:pPr>
+              <a:buFont typeface="Arial" panose="020B0604020202020204" pitchFamily="34" charset="0"/>
+              <a:buChar char="•"/>
+            </a:pPr>
+            <a:r>
+              <a:rPr lang="es-ES" sz="1200" b="0" i="0" dirty="0">
+                <a:solidFill>
+                  <a:srgbClr val="222222"/>
+                </a:solidFill>
+                <a:effectLst/>
+                <a:latin typeface="Segoe UI" panose="020B0502040204020203" pitchFamily="34" charset="0"/>
+              </a:rPr>
+              <a:t> </a:t>
+            </a:r>
+            <a:r>
+              <a:rPr lang="es-ES" sz="1200" dirty="0">
+                <a:solidFill>
+                  <a:srgbClr val="222222"/>
+                </a:solidFill>
+                <a:latin typeface="Segoe UI" panose="020B0502040204020203" pitchFamily="34" charset="0"/>
+              </a:rPr>
+              <a:t>Se creo la locación MSL (</a:t>
             </a:r>
             <a:r>
               <a:rPr lang="en-US" sz="1200" b="0" i="0" dirty="0">
@@ -3814,7 +4805,7 @@
                 </a:solidFill>
                 <a:latin typeface="Segoe UI" panose="020B0502040204020203" pitchFamily="34" charset="0"/>
               </a:rPr>
-              <a:t>), el material que este en esta locación solo podrá ser movido por Miguel Carrasco y por Pedro Misael del departamento de Calidad</a:t>
+              <a:t>), y se agrego validación para que el material que este en esta locación solo pueda ser movido por Miguel Carrasco y por Pedro Misael del departamento de Calidad</a:t>
             </a:r>
             <a:r>
               <a:rPr lang="es-ES" sz="1200" b="0" i="0" dirty="0">
@@ -3919,7 +4910,7 @@
     </p:spTree>
     <p:extLst>
       <p:ext uri="{BB962C8B-B14F-4D97-AF65-F5344CB8AC3E}">
-        <p14:creationId xmlns:p14="http://schemas.microsoft.com/office/powerpoint/2010/main" val="2170633103"/>
+        <p14:creationId xmlns:p14="http://schemas.microsoft.com/office/powerpoint/2010/main" val="2339350082"/>
       </p:ext>
     </p:extLst>
   </p:cSld>
@@ -3929,7 +4920,7 @@
 </p:sld>
 </file>
 
-<file path=ppt/slides/slide3.xml><?xml version="1.0" encoding="utf-8"?>
+<file path=ppt/slides/slide5.xml><?xml version="1.0" encoding="utf-8"?>
 <p:sld xmlns:a="http://schemas.openxmlformats.org/drawingml/2006/main" xmlns:r="http://schemas.openxmlformats.org/officeDocument/2006/relationships" xmlns:p="http://schemas.openxmlformats.org/presentationml/2006/main">
   <p:cSld>
     <p:spTree>
@@ -4009,7 +5000,7 @@
 </p:sld>
 </file>
 
-<file path=ppt/slides/slide4.xml><?xml version="1.0" encoding="utf-8"?>
+<file path=ppt/slides/slide6.xml><?xml version="1.0" encoding="utf-8"?>
 <p:sld xmlns:a="http://schemas.openxmlformats.org/drawingml/2006/main" xmlns:r="http://schemas.openxmlformats.org/officeDocument/2006/relationships" xmlns:p="http://schemas.openxmlformats.org/presentationml/2006/main">
   <p:cSld>
     <p:spTree>
@@ -4375,7 +5366,7 @@
 </p:sld>
 </file>
 
-<file path=ppt/slides/slide5.xml><?xml version="1.0" encoding="utf-8"?>
+<file path=ppt/slides/slide7.xml><?xml version="1.0" encoding="utf-8"?>
 <p:sld xmlns:a="http://schemas.openxmlformats.org/drawingml/2006/main" xmlns:r="http://schemas.openxmlformats.org/officeDocument/2006/relationships" xmlns:p="http://schemas.openxmlformats.org/presentationml/2006/main">
   <p:cSld>
     <p:spTree>
@@ -4455,7 +5446,7 @@
 </p:sld>
 </file>
 
-<file path=ppt/slides/slide6.xml><?xml version="1.0" encoding="utf-8"?>
+<file path=ppt/slides/slide8.xml><?xml version="1.0" encoding="utf-8"?>
 <p:sld xmlns:a="http://schemas.openxmlformats.org/drawingml/2006/main" xmlns:r="http://schemas.openxmlformats.org/officeDocument/2006/relationships" xmlns:p="http://schemas.openxmlformats.org/presentationml/2006/main">
   <p:cSld>
     <p:spTree>

</xml_diff>

<commit_message>
cambios para obtener la locacion y para actualizar el folio hasta el final del proceso
</commit_message>
<xml_diff>
--- a/Scripts_R100_Materiales/Folios_Transaccion/Docs/IT_DEV_FOLIOS_22102020.pptx
+++ b/Scripts_R100_Materiales/Folios_Transaccion/Docs/IT_DEV_FOLIOS_22102020.pptx
@@ -5,17 +5,19 @@
     <p:sldMasterId id="2147483648" r:id="rId1"/>
   </p:sldMasterIdLst>
   <p:notesMasterIdLst>
-    <p:notesMasterId r:id="rId10"/>
+    <p:notesMasterId r:id="rId12"/>
   </p:notesMasterIdLst>
   <p:sldIdLst>
     <p:sldId id="398" r:id="rId2"/>
-    <p:sldId id="400" r:id="rId3"/>
-    <p:sldId id="402" r:id="rId4"/>
-    <p:sldId id="401" r:id="rId5"/>
-    <p:sldId id="399" r:id="rId6"/>
-    <p:sldId id="397" r:id="rId7"/>
-    <p:sldId id="344" r:id="rId8"/>
-    <p:sldId id="396" r:id="rId9"/>
+    <p:sldId id="404" r:id="rId3"/>
+    <p:sldId id="403" r:id="rId4"/>
+    <p:sldId id="400" r:id="rId5"/>
+    <p:sldId id="402" r:id="rId6"/>
+    <p:sldId id="401" r:id="rId7"/>
+    <p:sldId id="399" r:id="rId8"/>
+    <p:sldId id="397" r:id="rId9"/>
+    <p:sldId id="344" r:id="rId10"/>
+    <p:sldId id="396" r:id="rId11"/>
   </p:sldIdLst>
   <p:sldSz cx="9144000" cy="6858000" type="screen4x3"/>
   <p:notesSz cx="6858000" cy="9144000"/>
@@ -215,7 +217,7 @@
           <a:p>
             <a:fld id="{A17B1792-3256-4E77-8442-3E205CD69EF5}" type="datetimeFigureOut">
               <a:rPr lang="en-US" smtClean="0"/>
-              <a:t>5/31/2021</a:t>
+              <a:t>6/21/2021</a:t>
             </a:fld>
             <a:endParaRPr lang="en-US"/>
           </a:p>
@@ -661,7 +663,7 @@
           <a:p>
             <a:fld id="{07558649-2619-44F9-8F30-2D6466E57529}" type="datetimeFigureOut">
               <a:rPr lang="en-US" smtClean="0"/>
-              <a:t>5/31/2021</a:t>
+              <a:t>6/21/2021</a:t>
             </a:fld>
             <a:endParaRPr lang="en-US"/>
           </a:p>
@@ -829,7 +831,7 @@
           <a:p>
             <a:fld id="{07558649-2619-44F9-8F30-2D6466E57529}" type="datetimeFigureOut">
               <a:rPr lang="en-US" smtClean="0"/>
-              <a:t>5/31/2021</a:t>
+              <a:t>6/21/2021</a:t>
             </a:fld>
             <a:endParaRPr lang="en-US"/>
           </a:p>
@@ -1007,7 +1009,7 @@
           <a:p>
             <a:fld id="{07558649-2619-44F9-8F30-2D6466E57529}" type="datetimeFigureOut">
               <a:rPr lang="en-US" smtClean="0"/>
-              <a:t>5/31/2021</a:t>
+              <a:t>6/21/2021</a:t>
             </a:fld>
             <a:endParaRPr lang="en-US"/>
           </a:p>
@@ -1175,7 +1177,7 @@
           <a:p>
             <a:fld id="{07558649-2619-44F9-8F30-2D6466E57529}" type="datetimeFigureOut">
               <a:rPr lang="en-US" smtClean="0"/>
-              <a:t>5/31/2021</a:t>
+              <a:t>6/21/2021</a:t>
             </a:fld>
             <a:endParaRPr lang="en-US"/>
           </a:p>
@@ -1420,7 +1422,7 @@
           <a:p>
             <a:fld id="{07558649-2619-44F9-8F30-2D6466E57529}" type="datetimeFigureOut">
               <a:rPr lang="en-US" smtClean="0"/>
-              <a:t>5/31/2021</a:t>
+              <a:t>6/21/2021</a:t>
             </a:fld>
             <a:endParaRPr lang="en-US"/>
           </a:p>
@@ -1705,7 +1707,7 @@
           <a:p>
             <a:fld id="{07558649-2619-44F9-8F30-2D6466E57529}" type="datetimeFigureOut">
               <a:rPr lang="en-US" smtClean="0"/>
-              <a:t>5/31/2021</a:t>
+              <a:t>6/21/2021</a:t>
             </a:fld>
             <a:endParaRPr lang="en-US"/>
           </a:p>
@@ -2124,7 +2126,7 @@
           <a:p>
             <a:fld id="{07558649-2619-44F9-8F30-2D6466E57529}" type="datetimeFigureOut">
               <a:rPr lang="en-US" smtClean="0"/>
-              <a:t>5/31/2021</a:t>
+              <a:t>6/21/2021</a:t>
             </a:fld>
             <a:endParaRPr lang="en-US"/>
           </a:p>
@@ -2241,7 +2243,7 @@
           <a:p>
             <a:fld id="{07558649-2619-44F9-8F30-2D6466E57529}" type="datetimeFigureOut">
               <a:rPr lang="en-US" smtClean="0"/>
-              <a:t>5/31/2021</a:t>
+              <a:t>6/21/2021</a:t>
             </a:fld>
             <a:endParaRPr lang="en-US"/>
           </a:p>
@@ -2336,7 +2338,7 @@
           <a:p>
             <a:fld id="{07558649-2619-44F9-8F30-2D6466E57529}" type="datetimeFigureOut">
               <a:rPr lang="en-US" smtClean="0"/>
-              <a:t>5/31/2021</a:t>
+              <a:t>6/21/2021</a:t>
             </a:fld>
             <a:endParaRPr lang="en-US"/>
           </a:p>
@@ -2611,7 +2613,7 @@
           <a:p>
             <a:fld id="{07558649-2619-44F9-8F30-2D6466E57529}" type="datetimeFigureOut">
               <a:rPr lang="en-US" smtClean="0"/>
-              <a:t>5/31/2021</a:t>
+              <a:t>6/21/2021</a:t>
             </a:fld>
             <a:endParaRPr lang="en-US"/>
           </a:p>
@@ -2863,7 +2865,7 @@
           <a:p>
             <a:fld id="{07558649-2619-44F9-8F30-2D6466E57529}" type="datetimeFigureOut">
               <a:rPr lang="en-US" smtClean="0"/>
-              <a:t>5/31/2021</a:t>
+              <a:t>6/21/2021</a:t>
             </a:fld>
             <a:endParaRPr lang="en-US"/>
           </a:p>
@@ -3083,7 +3085,7 @@
           <a:p>
             <a:fld id="{07558649-2619-44F9-8F30-2D6466E57529}" type="datetimeFigureOut">
               <a:rPr lang="en-US" smtClean="0"/>
-              <a:t>5/31/2021</a:t>
+              <a:t>6/21/2021</a:t>
             </a:fld>
             <a:endParaRPr lang="en-US"/>
           </a:p>
@@ -3500,7 +3502,7 @@
               <a:rPr lang="es-MX" b="1" dirty="0">
                 <a:latin typeface="Century Gothic" panose="020B0502020202020204" pitchFamily="34" charset="0"/>
               </a:rPr>
-              <a:t>24/05/2021 – 28/05/2021</a:t>
+              <a:t>14/06/2021 – 18/06/2021</a:t>
             </a:r>
             <a:endParaRPr lang="es-MX" dirty="0">
               <a:latin typeface="Century Gothic" panose="020B0502020202020204" pitchFamily="34" charset="0"/>
@@ -3521,7 +3523,1483 @@
 </p:sld>
 </file>
 
+<file path=ppt/slides/slide10.xml><?xml version="1.0" encoding="utf-8"?>
+<p:sld xmlns:a="http://schemas.openxmlformats.org/drawingml/2006/main" xmlns:r="http://schemas.openxmlformats.org/officeDocument/2006/relationships" xmlns:p="http://schemas.openxmlformats.org/presentationml/2006/main">
+  <p:cSld>
+    <p:spTree>
+      <p:nvGrpSpPr>
+        <p:cNvPr id="1" name=""/>
+        <p:cNvGrpSpPr/>
+        <p:nvPr/>
+      </p:nvGrpSpPr>
+      <p:grpSpPr>
+        <a:xfrm>
+          <a:off x="0" y="0"/>
+          <a:ext cx="0" cy="0"/>
+          <a:chOff x="0" y="0"/>
+          <a:chExt cx="0" cy="0"/>
+        </a:xfrm>
+      </p:grpSpPr>
+      <p:sp>
+        <p:nvSpPr>
+          <p:cNvPr id="8" name="Title 1"/>
+          <p:cNvSpPr txBox="1">
+            <a:spLocks/>
+          </p:cNvSpPr>
+          <p:nvPr/>
+        </p:nvSpPr>
+        <p:spPr>
+          <a:xfrm>
+            <a:off x="1087408" y="274638"/>
+            <a:ext cx="7229008" cy="634082"/>
+          </a:xfrm>
+          <a:prstGeom prst="rect">
+            <a:avLst/>
+          </a:prstGeom>
+        </p:spPr>
+        <p:txBody>
+          <a:bodyPr/>
+          <a:lstStyle>
+            <a:lvl1pPr algn="ctr" defTabSz="914400" rtl="0" eaLnBrk="1" latinLnBrk="0" hangingPunct="1">
+              <a:spcBef>
+                <a:spcPct val="0"/>
+              </a:spcBef>
+              <a:buNone/>
+              <a:defRPr sz="4400" kern="1200">
+                <a:solidFill>
+                  <a:schemeClr val="tx1"/>
+                </a:solidFill>
+                <a:latin typeface="+mj-lt"/>
+                <a:ea typeface="+mj-ea"/>
+                <a:cs typeface="+mj-cs"/>
+              </a:defRPr>
+            </a:lvl1pPr>
+          </a:lstStyle>
+          <a:p>
+            <a:pPr algn="l"/>
+            <a:r>
+              <a:rPr lang="es-ES" sz="2000" dirty="0">
+                <a:solidFill>
+                  <a:srgbClr val="3F1900"/>
+                </a:solidFill>
+              </a:rPr>
+              <a:t>TRANSFERENCIA DE FOLIOS: CAMBIO DE COLOR DE PIELES.</a:t>
+            </a:r>
+            <a:endParaRPr lang="en-US" sz="2000" dirty="0">
+              <a:solidFill>
+                <a:srgbClr val="3F1900"/>
+              </a:solidFill>
+            </a:endParaRPr>
+          </a:p>
+        </p:txBody>
+      </p:sp>
+      <p:sp>
+        <p:nvSpPr>
+          <p:cNvPr id="4" name="Content Placeholder 3"/>
+          <p:cNvSpPr txBox="1">
+            <a:spLocks/>
+          </p:cNvSpPr>
+          <p:nvPr/>
+        </p:nvSpPr>
+        <p:spPr>
+          <a:xfrm>
+            <a:off x="1331640" y="1196753"/>
+            <a:ext cx="7488832" cy="5137780"/>
+          </a:xfrm>
+          <a:prstGeom prst="rect">
+            <a:avLst/>
+          </a:prstGeom>
+        </p:spPr>
+        <p:txBody>
+          <a:bodyPr>
+            <a:normAutofit/>
+          </a:bodyPr>
+          <a:lstStyle>
+            <a:lvl1pPr marL="342900" indent="-342900" algn="l" defTabSz="914400" rtl="0" eaLnBrk="1" latinLnBrk="0" hangingPunct="1">
+              <a:spcBef>
+                <a:spcPct val="20000"/>
+              </a:spcBef>
+              <a:buFont typeface="Arial" panose="020B0604020202020204" pitchFamily="34" charset="0"/>
+              <a:buChar char="•"/>
+              <a:defRPr sz="3200" kern="1200">
+                <a:solidFill>
+                  <a:schemeClr val="tx1"/>
+                </a:solidFill>
+                <a:latin typeface="+mn-lt"/>
+                <a:ea typeface="+mn-ea"/>
+                <a:cs typeface="+mn-cs"/>
+              </a:defRPr>
+            </a:lvl1pPr>
+            <a:lvl2pPr marL="742950" indent="-285750" algn="l" defTabSz="914400" rtl="0" eaLnBrk="1" latinLnBrk="0" hangingPunct="1">
+              <a:spcBef>
+                <a:spcPct val="20000"/>
+              </a:spcBef>
+              <a:buFont typeface="Arial" panose="020B0604020202020204" pitchFamily="34" charset="0"/>
+              <a:buChar char="–"/>
+              <a:defRPr sz="2800" kern="1200">
+                <a:solidFill>
+                  <a:schemeClr val="tx1"/>
+                </a:solidFill>
+                <a:latin typeface="+mn-lt"/>
+                <a:ea typeface="+mn-ea"/>
+                <a:cs typeface="+mn-cs"/>
+              </a:defRPr>
+            </a:lvl2pPr>
+            <a:lvl3pPr marL="1143000" indent="-228600" algn="l" defTabSz="914400" rtl="0" eaLnBrk="1" latinLnBrk="0" hangingPunct="1">
+              <a:spcBef>
+                <a:spcPct val="20000"/>
+              </a:spcBef>
+              <a:buFont typeface="Arial" panose="020B0604020202020204" pitchFamily="34" charset="0"/>
+              <a:buChar char="•"/>
+              <a:defRPr sz="2400" kern="1200">
+                <a:solidFill>
+                  <a:schemeClr val="tx1"/>
+                </a:solidFill>
+                <a:latin typeface="+mn-lt"/>
+                <a:ea typeface="+mn-ea"/>
+                <a:cs typeface="+mn-cs"/>
+              </a:defRPr>
+            </a:lvl3pPr>
+            <a:lvl4pPr marL="1600200" indent="-228600" algn="l" defTabSz="914400" rtl="0" eaLnBrk="1" latinLnBrk="0" hangingPunct="1">
+              <a:spcBef>
+                <a:spcPct val="20000"/>
+              </a:spcBef>
+              <a:buFont typeface="Arial" panose="020B0604020202020204" pitchFamily="34" charset="0"/>
+              <a:buChar char="–"/>
+              <a:defRPr sz="2000" kern="1200">
+                <a:solidFill>
+                  <a:schemeClr val="tx1"/>
+                </a:solidFill>
+                <a:latin typeface="+mn-lt"/>
+                <a:ea typeface="+mn-ea"/>
+                <a:cs typeface="+mn-cs"/>
+              </a:defRPr>
+            </a:lvl4pPr>
+            <a:lvl5pPr marL="2057400" indent="-228600" algn="l" defTabSz="914400" rtl="0" eaLnBrk="1" latinLnBrk="0" hangingPunct="1">
+              <a:spcBef>
+                <a:spcPct val="20000"/>
+              </a:spcBef>
+              <a:buFont typeface="Arial" panose="020B0604020202020204" pitchFamily="34" charset="0"/>
+              <a:buChar char="»"/>
+              <a:defRPr sz="2000" kern="1200">
+                <a:solidFill>
+                  <a:schemeClr val="tx1"/>
+                </a:solidFill>
+                <a:latin typeface="+mn-lt"/>
+                <a:ea typeface="+mn-ea"/>
+                <a:cs typeface="+mn-cs"/>
+              </a:defRPr>
+            </a:lvl5pPr>
+            <a:lvl6pPr marL="2514600" indent="-228600" algn="l" defTabSz="914400" rtl="0" eaLnBrk="1" latinLnBrk="0" hangingPunct="1">
+              <a:spcBef>
+                <a:spcPct val="20000"/>
+              </a:spcBef>
+              <a:buFont typeface="Arial" panose="020B0604020202020204" pitchFamily="34" charset="0"/>
+              <a:buChar char="•"/>
+              <a:defRPr sz="2000" kern="1200">
+                <a:solidFill>
+                  <a:schemeClr val="tx1"/>
+                </a:solidFill>
+                <a:latin typeface="+mn-lt"/>
+                <a:ea typeface="+mn-ea"/>
+                <a:cs typeface="+mn-cs"/>
+              </a:defRPr>
+            </a:lvl6pPr>
+            <a:lvl7pPr marL="2971800" indent="-228600" algn="l" defTabSz="914400" rtl="0" eaLnBrk="1" latinLnBrk="0" hangingPunct="1">
+              <a:spcBef>
+                <a:spcPct val="20000"/>
+              </a:spcBef>
+              <a:buFont typeface="Arial" panose="020B0604020202020204" pitchFamily="34" charset="0"/>
+              <a:buChar char="•"/>
+              <a:defRPr sz="2000" kern="1200">
+                <a:solidFill>
+                  <a:schemeClr val="tx1"/>
+                </a:solidFill>
+                <a:latin typeface="+mn-lt"/>
+                <a:ea typeface="+mn-ea"/>
+                <a:cs typeface="+mn-cs"/>
+              </a:defRPr>
+            </a:lvl7pPr>
+            <a:lvl8pPr marL="3429000" indent="-228600" algn="l" defTabSz="914400" rtl="0" eaLnBrk="1" latinLnBrk="0" hangingPunct="1">
+              <a:spcBef>
+                <a:spcPct val="20000"/>
+              </a:spcBef>
+              <a:buFont typeface="Arial" panose="020B0604020202020204" pitchFamily="34" charset="0"/>
+              <a:buChar char="•"/>
+              <a:defRPr sz="2000" kern="1200">
+                <a:solidFill>
+                  <a:schemeClr val="tx1"/>
+                </a:solidFill>
+                <a:latin typeface="+mn-lt"/>
+                <a:ea typeface="+mn-ea"/>
+                <a:cs typeface="+mn-cs"/>
+              </a:defRPr>
+            </a:lvl8pPr>
+            <a:lvl9pPr marL="3886200" indent="-228600" algn="l" defTabSz="914400" rtl="0" eaLnBrk="1" latinLnBrk="0" hangingPunct="1">
+              <a:spcBef>
+                <a:spcPct val="20000"/>
+              </a:spcBef>
+              <a:buFont typeface="Arial" panose="020B0604020202020204" pitchFamily="34" charset="0"/>
+              <a:buChar char="•"/>
+              <a:defRPr sz="2000" kern="1200">
+                <a:solidFill>
+                  <a:schemeClr val="tx1"/>
+                </a:solidFill>
+                <a:latin typeface="+mn-lt"/>
+                <a:ea typeface="+mn-ea"/>
+                <a:cs typeface="+mn-cs"/>
+              </a:defRPr>
+            </a:lvl9pPr>
+          </a:lstStyle>
+          <a:p>
+            <a:pPr marL="0" indent="0" algn="just">
+              <a:buFont typeface="Arial" panose="020B0604020202020204" pitchFamily="34" charset="0"/>
+              <a:buNone/>
+            </a:pPr>
+            <a:endParaRPr lang="en-US" sz="2000" i="1"/>
+          </a:p>
+        </p:txBody>
+      </p:sp>
+      <p:sp>
+        <p:nvSpPr>
+          <p:cNvPr id="10" name="Rectangle 9"/>
+          <p:cNvSpPr/>
+          <p:nvPr/>
+        </p:nvSpPr>
+        <p:spPr>
+          <a:xfrm>
+            <a:off x="1331640" y="1095133"/>
+            <a:ext cx="7632848" cy="461665"/>
+          </a:xfrm>
+          <a:prstGeom prst="rect">
+            <a:avLst/>
+          </a:prstGeom>
+        </p:spPr>
+        <p:txBody>
+          <a:bodyPr wrap="square">
+            <a:spAutoFit/>
+          </a:bodyPr>
+          <a:lstStyle/>
+          <a:p>
+            <a:pPr>
+              <a:buFont typeface="Arial" panose="020B0604020202020204" pitchFamily="34" charset="0"/>
+              <a:buChar char="•"/>
+            </a:pPr>
+            <a:r>
+              <a:rPr lang="es-ES" sz="1200" b="0" i="0" dirty="0">
+                <a:solidFill>
+                  <a:srgbClr val="222222"/>
+                </a:solidFill>
+                <a:effectLst/>
+                <a:latin typeface="Segoe UI" panose="020B0502040204020203" pitchFamily="34" charset="0"/>
+              </a:rPr>
+              <a:t> Se </a:t>
+            </a:r>
+            <a:r>
+              <a:rPr lang="es-ES" sz="1200" dirty="0">
+                <a:solidFill>
+                  <a:srgbClr val="222222"/>
+                </a:solidFill>
+                <a:latin typeface="Segoe UI" panose="020B0502040204020203" pitchFamily="34" charset="0"/>
+              </a:rPr>
+              <a:t>agrego a Pantalla Folios la opción para cambiar de color las pieles e imprimir las etiquetas con el nuevo color.</a:t>
+            </a:r>
+            <a:endParaRPr lang="es-ES" sz="1200" b="0" i="0" dirty="0">
+              <a:solidFill>
+                <a:srgbClr val="222222"/>
+              </a:solidFill>
+              <a:effectLst/>
+              <a:latin typeface="Segoe UI" panose="020B0502040204020203" pitchFamily="34" charset="0"/>
+            </a:endParaRPr>
+          </a:p>
+        </p:txBody>
+      </p:sp>
+      <p:pic>
+        <p:nvPicPr>
+          <p:cNvPr id="7" name="Imagen 6" descr="Interfaz de usuario gráfica, Aplicación, Tabla&#10;&#10;Descripción generada automáticamente">
+            <a:extLst>
+              <a:ext uri="{FF2B5EF4-FFF2-40B4-BE49-F238E27FC236}">
+                <a16:creationId xmlns:a16="http://schemas.microsoft.com/office/drawing/2014/main" id="{1412D3D2-6E60-4CD0-BF83-09A5142874B0}"/>
+              </a:ext>
+            </a:extLst>
+          </p:cNvPr>
+          <p:cNvPicPr>
+            <a:picLocks noChangeAspect="1"/>
+          </p:cNvPicPr>
+          <p:nvPr/>
+        </p:nvPicPr>
+        <p:blipFill>
+          <a:blip r:embed="rId2">
+            <a:extLst>
+              <a:ext uri="{28A0092B-C50C-407E-A947-70E740481C1C}">
+                <a14:useLocalDpi xmlns:a14="http://schemas.microsoft.com/office/drawing/2010/main" val="0"/>
+              </a:ext>
+            </a:extLst>
+          </a:blip>
+          <a:stretch>
+            <a:fillRect/>
+          </a:stretch>
+        </p:blipFill>
+        <p:spPr>
+          <a:xfrm>
+            <a:off x="1331640" y="1556797"/>
+            <a:ext cx="7704856" cy="5184571"/>
+          </a:xfrm>
+          <a:prstGeom prst="rect">
+            <a:avLst/>
+          </a:prstGeom>
+        </p:spPr>
+      </p:pic>
+      <p:sp>
+        <p:nvSpPr>
+          <p:cNvPr id="9" name="Rectángulo 8">
+            <a:extLst>
+              <a:ext uri="{FF2B5EF4-FFF2-40B4-BE49-F238E27FC236}">
+                <a16:creationId xmlns:a16="http://schemas.microsoft.com/office/drawing/2014/main" id="{46E099D5-0DE3-484B-A40B-A00567D1261D}"/>
+              </a:ext>
+            </a:extLst>
+          </p:cNvPr>
+          <p:cNvSpPr/>
+          <p:nvPr/>
+        </p:nvSpPr>
+        <p:spPr>
+          <a:xfrm>
+            <a:off x="6804248" y="3429000"/>
+            <a:ext cx="1800200" cy="216024"/>
+          </a:xfrm>
+          <a:prstGeom prst="rect">
+            <a:avLst/>
+          </a:prstGeom>
+          <a:noFill/>
+          <a:ln>
+            <a:solidFill>
+              <a:srgbClr val="FF0000"/>
+            </a:solidFill>
+          </a:ln>
+        </p:spPr>
+        <p:style>
+          <a:lnRef idx="2">
+            <a:schemeClr val="accent1">
+              <a:shade val="50000"/>
+            </a:schemeClr>
+          </a:lnRef>
+          <a:fillRef idx="1">
+            <a:schemeClr val="accent1"/>
+          </a:fillRef>
+          <a:effectRef idx="0">
+            <a:schemeClr val="accent1"/>
+          </a:effectRef>
+          <a:fontRef idx="minor">
+            <a:schemeClr val="lt1"/>
+          </a:fontRef>
+        </p:style>
+        <p:txBody>
+          <a:bodyPr rtlCol="0" anchor="ctr"/>
+          <a:lstStyle/>
+          <a:p>
+            <a:pPr algn="ctr"/>
+            <a:endParaRPr lang="en-US"/>
+          </a:p>
+        </p:txBody>
+      </p:sp>
+    </p:spTree>
+    <p:extLst>
+      <p:ext uri="{BB962C8B-B14F-4D97-AF65-F5344CB8AC3E}">
+        <p14:creationId xmlns:p14="http://schemas.microsoft.com/office/powerpoint/2010/main" val="2311067179"/>
+      </p:ext>
+    </p:extLst>
+  </p:cSld>
+  <p:clrMapOvr>
+    <a:masterClrMapping/>
+  </p:clrMapOvr>
+</p:sld>
+</file>
+
 <file path=ppt/slides/slide2.xml><?xml version="1.0" encoding="utf-8"?>
+<p:sld xmlns:a="http://schemas.openxmlformats.org/drawingml/2006/main" xmlns:r="http://schemas.openxmlformats.org/officeDocument/2006/relationships" xmlns:p="http://schemas.openxmlformats.org/presentationml/2006/main">
+  <p:cSld>
+    <p:spTree>
+      <p:nvGrpSpPr>
+        <p:cNvPr id="1" name=""/>
+        <p:cNvGrpSpPr/>
+        <p:nvPr/>
+      </p:nvGrpSpPr>
+      <p:grpSpPr>
+        <a:xfrm>
+          <a:off x="0" y="0"/>
+          <a:ext cx="0" cy="0"/>
+          <a:chOff x="0" y="0"/>
+          <a:chExt cx="0" cy="0"/>
+        </a:xfrm>
+      </p:grpSpPr>
+      <p:sp>
+        <p:nvSpPr>
+          <p:cNvPr id="8" name="Title 1"/>
+          <p:cNvSpPr txBox="1">
+            <a:spLocks/>
+          </p:cNvSpPr>
+          <p:nvPr/>
+        </p:nvSpPr>
+        <p:spPr>
+          <a:xfrm>
+            <a:off x="1087408" y="274638"/>
+            <a:ext cx="7229008" cy="634082"/>
+          </a:xfrm>
+          <a:prstGeom prst="rect">
+            <a:avLst/>
+          </a:prstGeom>
+        </p:spPr>
+        <p:txBody>
+          <a:bodyPr/>
+          <a:lstStyle>
+            <a:lvl1pPr algn="ctr" defTabSz="914400" rtl="0" eaLnBrk="1" latinLnBrk="0" hangingPunct="1">
+              <a:spcBef>
+                <a:spcPct val="0"/>
+              </a:spcBef>
+              <a:buNone/>
+              <a:defRPr sz="4400" kern="1200">
+                <a:solidFill>
+                  <a:schemeClr val="tx1"/>
+                </a:solidFill>
+                <a:latin typeface="+mj-lt"/>
+                <a:ea typeface="+mj-ea"/>
+                <a:cs typeface="+mj-cs"/>
+              </a:defRPr>
+            </a:lvl1pPr>
+          </a:lstStyle>
+          <a:p>
+            <a:pPr algn="l"/>
+            <a:r>
+              <a:rPr lang="es-ES" sz="2000" dirty="0">
+                <a:solidFill>
+                  <a:srgbClr val="3F1900"/>
+                </a:solidFill>
+              </a:rPr>
+              <a:t>Estación de Devolución de Pieles.</a:t>
+            </a:r>
+            <a:endParaRPr lang="en-US" sz="2000" dirty="0">
+              <a:solidFill>
+                <a:srgbClr val="3F1900"/>
+              </a:solidFill>
+            </a:endParaRPr>
+          </a:p>
+        </p:txBody>
+      </p:sp>
+      <p:sp>
+        <p:nvSpPr>
+          <p:cNvPr id="4" name="Content Placeholder 3"/>
+          <p:cNvSpPr txBox="1">
+            <a:spLocks/>
+          </p:cNvSpPr>
+          <p:nvPr/>
+        </p:nvSpPr>
+        <p:spPr>
+          <a:xfrm>
+            <a:off x="1331640" y="1196753"/>
+            <a:ext cx="7488832" cy="5137780"/>
+          </a:xfrm>
+          <a:prstGeom prst="rect">
+            <a:avLst/>
+          </a:prstGeom>
+        </p:spPr>
+        <p:txBody>
+          <a:bodyPr>
+            <a:normAutofit/>
+          </a:bodyPr>
+          <a:lstStyle>
+            <a:lvl1pPr marL="342900" indent="-342900" algn="l" defTabSz="914400" rtl="0" eaLnBrk="1" latinLnBrk="0" hangingPunct="1">
+              <a:spcBef>
+                <a:spcPct val="20000"/>
+              </a:spcBef>
+              <a:buFont typeface="Arial" panose="020B0604020202020204" pitchFamily="34" charset="0"/>
+              <a:buChar char="•"/>
+              <a:defRPr sz="3200" kern="1200">
+                <a:solidFill>
+                  <a:schemeClr val="tx1"/>
+                </a:solidFill>
+                <a:latin typeface="+mn-lt"/>
+                <a:ea typeface="+mn-ea"/>
+                <a:cs typeface="+mn-cs"/>
+              </a:defRPr>
+            </a:lvl1pPr>
+            <a:lvl2pPr marL="742950" indent="-285750" algn="l" defTabSz="914400" rtl="0" eaLnBrk="1" latinLnBrk="0" hangingPunct="1">
+              <a:spcBef>
+                <a:spcPct val="20000"/>
+              </a:spcBef>
+              <a:buFont typeface="Arial" panose="020B0604020202020204" pitchFamily="34" charset="0"/>
+              <a:buChar char="–"/>
+              <a:defRPr sz="2800" kern="1200">
+                <a:solidFill>
+                  <a:schemeClr val="tx1"/>
+                </a:solidFill>
+                <a:latin typeface="+mn-lt"/>
+                <a:ea typeface="+mn-ea"/>
+                <a:cs typeface="+mn-cs"/>
+              </a:defRPr>
+            </a:lvl2pPr>
+            <a:lvl3pPr marL="1143000" indent="-228600" algn="l" defTabSz="914400" rtl="0" eaLnBrk="1" latinLnBrk="0" hangingPunct="1">
+              <a:spcBef>
+                <a:spcPct val="20000"/>
+              </a:spcBef>
+              <a:buFont typeface="Arial" panose="020B0604020202020204" pitchFamily="34" charset="0"/>
+              <a:buChar char="•"/>
+              <a:defRPr sz="2400" kern="1200">
+                <a:solidFill>
+                  <a:schemeClr val="tx1"/>
+                </a:solidFill>
+                <a:latin typeface="+mn-lt"/>
+                <a:ea typeface="+mn-ea"/>
+                <a:cs typeface="+mn-cs"/>
+              </a:defRPr>
+            </a:lvl3pPr>
+            <a:lvl4pPr marL="1600200" indent="-228600" algn="l" defTabSz="914400" rtl="0" eaLnBrk="1" latinLnBrk="0" hangingPunct="1">
+              <a:spcBef>
+                <a:spcPct val="20000"/>
+              </a:spcBef>
+              <a:buFont typeface="Arial" panose="020B0604020202020204" pitchFamily="34" charset="0"/>
+              <a:buChar char="–"/>
+              <a:defRPr sz="2000" kern="1200">
+                <a:solidFill>
+                  <a:schemeClr val="tx1"/>
+                </a:solidFill>
+                <a:latin typeface="+mn-lt"/>
+                <a:ea typeface="+mn-ea"/>
+                <a:cs typeface="+mn-cs"/>
+              </a:defRPr>
+            </a:lvl4pPr>
+            <a:lvl5pPr marL="2057400" indent="-228600" algn="l" defTabSz="914400" rtl="0" eaLnBrk="1" latinLnBrk="0" hangingPunct="1">
+              <a:spcBef>
+                <a:spcPct val="20000"/>
+              </a:spcBef>
+              <a:buFont typeface="Arial" panose="020B0604020202020204" pitchFamily="34" charset="0"/>
+              <a:buChar char="»"/>
+              <a:defRPr sz="2000" kern="1200">
+                <a:solidFill>
+                  <a:schemeClr val="tx1"/>
+                </a:solidFill>
+                <a:latin typeface="+mn-lt"/>
+                <a:ea typeface="+mn-ea"/>
+                <a:cs typeface="+mn-cs"/>
+              </a:defRPr>
+            </a:lvl5pPr>
+            <a:lvl6pPr marL="2514600" indent="-228600" algn="l" defTabSz="914400" rtl="0" eaLnBrk="1" latinLnBrk="0" hangingPunct="1">
+              <a:spcBef>
+                <a:spcPct val="20000"/>
+              </a:spcBef>
+              <a:buFont typeface="Arial" panose="020B0604020202020204" pitchFamily="34" charset="0"/>
+              <a:buChar char="•"/>
+              <a:defRPr sz="2000" kern="1200">
+                <a:solidFill>
+                  <a:schemeClr val="tx1"/>
+                </a:solidFill>
+                <a:latin typeface="+mn-lt"/>
+                <a:ea typeface="+mn-ea"/>
+                <a:cs typeface="+mn-cs"/>
+              </a:defRPr>
+            </a:lvl6pPr>
+            <a:lvl7pPr marL="2971800" indent="-228600" algn="l" defTabSz="914400" rtl="0" eaLnBrk="1" latinLnBrk="0" hangingPunct="1">
+              <a:spcBef>
+                <a:spcPct val="20000"/>
+              </a:spcBef>
+              <a:buFont typeface="Arial" panose="020B0604020202020204" pitchFamily="34" charset="0"/>
+              <a:buChar char="•"/>
+              <a:defRPr sz="2000" kern="1200">
+                <a:solidFill>
+                  <a:schemeClr val="tx1"/>
+                </a:solidFill>
+                <a:latin typeface="+mn-lt"/>
+                <a:ea typeface="+mn-ea"/>
+                <a:cs typeface="+mn-cs"/>
+              </a:defRPr>
+            </a:lvl7pPr>
+            <a:lvl8pPr marL="3429000" indent="-228600" algn="l" defTabSz="914400" rtl="0" eaLnBrk="1" latinLnBrk="0" hangingPunct="1">
+              <a:spcBef>
+                <a:spcPct val="20000"/>
+              </a:spcBef>
+              <a:buFont typeface="Arial" panose="020B0604020202020204" pitchFamily="34" charset="0"/>
+              <a:buChar char="•"/>
+              <a:defRPr sz="2000" kern="1200">
+                <a:solidFill>
+                  <a:schemeClr val="tx1"/>
+                </a:solidFill>
+                <a:latin typeface="+mn-lt"/>
+                <a:ea typeface="+mn-ea"/>
+                <a:cs typeface="+mn-cs"/>
+              </a:defRPr>
+            </a:lvl8pPr>
+            <a:lvl9pPr marL="3886200" indent="-228600" algn="l" defTabSz="914400" rtl="0" eaLnBrk="1" latinLnBrk="0" hangingPunct="1">
+              <a:spcBef>
+                <a:spcPct val="20000"/>
+              </a:spcBef>
+              <a:buFont typeface="Arial" panose="020B0604020202020204" pitchFamily="34" charset="0"/>
+              <a:buChar char="•"/>
+              <a:defRPr sz="2000" kern="1200">
+                <a:solidFill>
+                  <a:schemeClr val="tx1"/>
+                </a:solidFill>
+                <a:latin typeface="+mn-lt"/>
+                <a:ea typeface="+mn-ea"/>
+                <a:cs typeface="+mn-cs"/>
+              </a:defRPr>
+            </a:lvl9pPr>
+          </a:lstStyle>
+          <a:p>
+            <a:pPr marL="0" indent="0" algn="just">
+              <a:buFont typeface="Arial" panose="020B0604020202020204" pitchFamily="34" charset="0"/>
+              <a:buNone/>
+            </a:pPr>
+            <a:endParaRPr lang="en-US" sz="2000" i="1"/>
+          </a:p>
+        </p:txBody>
+      </p:sp>
+      <p:sp>
+        <p:nvSpPr>
+          <p:cNvPr id="10" name="Rectangle 9"/>
+          <p:cNvSpPr/>
+          <p:nvPr/>
+        </p:nvSpPr>
+        <p:spPr>
+          <a:xfrm>
+            <a:off x="1159416" y="980728"/>
+            <a:ext cx="7949088" cy="830997"/>
+          </a:xfrm>
+          <a:prstGeom prst="rect">
+            <a:avLst/>
+          </a:prstGeom>
+        </p:spPr>
+        <p:txBody>
+          <a:bodyPr wrap="square">
+            <a:spAutoFit/>
+          </a:bodyPr>
+          <a:lstStyle/>
+          <a:p>
+            <a:pPr>
+              <a:buFont typeface="Arial" panose="020B0604020202020204" pitchFamily="34" charset="0"/>
+              <a:buChar char="•"/>
+            </a:pPr>
+            <a:r>
+              <a:rPr lang="es-ES" sz="1200" b="0" i="0" dirty="0">
+                <a:solidFill>
+                  <a:srgbClr val="222222"/>
+                </a:solidFill>
+                <a:effectLst/>
+                <a:latin typeface="Segoe UI" panose="020B0502040204020203" pitchFamily="34" charset="0"/>
+              </a:rPr>
+              <a:t> </a:t>
+            </a:r>
+            <a:r>
+              <a:rPr lang="es-ES" sz="1200" dirty="0">
+                <a:solidFill>
+                  <a:srgbClr val="222222"/>
+                </a:solidFill>
+                <a:latin typeface="Segoe UI" panose="020B0502040204020203" pitchFamily="34" charset="0"/>
+              </a:rPr>
+              <a:t>Se </a:t>
+            </a:r>
+            <a:r>
+              <a:rPr lang="en-US" sz="1200" dirty="0" err="1">
+                <a:solidFill>
+                  <a:srgbClr val="222222"/>
+                </a:solidFill>
+                <a:latin typeface="Segoe UI" panose="020B0502040204020203" pitchFamily="34" charset="0"/>
+              </a:rPr>
+              <a:t>creo</a:t>
+            </a:r>
+            <a:r>
+              <a:rPr lang="en-US" sz="1200" dirty="0">
+                <a:solidFill>
+                  <a:srgbClr val="222222"/>
+                </a:solidFill>
+                <a:latin typeface="Segoe UI" panose="020B0502040204020203" pitchFamily="34" charset="0"/>
+              </a:rPr>
+              <a:t> </a:t>
+            </a:r>
+            <a:r>
+              <a:rPr lang="en-US" sz="1200" dirty="0" err="1">
+                <a:solidFill>
+                  <a:srgbClr val="222222"/>
+                </a:solidFill>
+                <a:latin typeface="Segoe UI" panose="020B0502040204020203" pitchFamily="34" charset="0"/>
+              </a:rPr>
+              <a:t>pantalla</a:t>
+            </a:r>
+            <a:r>
+              <a:rPr lang="en-US" sz="1200" dirty="0">
+                <a:solidFill>
+                  <a:srgbClr val="222222"/>
+                </a:solidFill>
+                <a:latin typeface="Segoe UI" panose="020B0502040204020203" pitchFamily="34" charset="0"/>
+              </a:rPr>
+              <a:t> que </a:t>
+            </a:r>
+            <a:r>
+              <a:rPr lang="en-US" sz="1200" dirty="0" err="1">
+                <a:solidFill>
+                  <a:srgbClr val="222222"/>
+                </a:solidFill>
+                <a:latin typeface="Segoe UI" panose="020B0502040204020203" pitchFamily="34" charset="0"/>
+              </a:rPr>
+              <a:t>permitira</a:t>
+            </a:r>
+            <a:r>
+              <a:rPr lang="en-US" sz="1200" dirty="0">
+                <a:solidFill>
+                  <a:srgbClr val="222222"/>
+                </a:solidFill>
+                <a:latin typeface="Segoe UI" panose="020B0502040204020203" pitchFamily="34" charset="0"/>
+              </a:rPr>
+              <a:t> </a:t>
+            </a:r>
+            <a:r>
+              <a:rPr lang="en-US" sz="1200" dirty="0" err="1">
+                <a:solidFill>
+                  <a:srgbClr val="222222"/>
+                </a:solidFill>
+                <a:latin typeface="Segoe UI" panose="020B0502040204020203" pitchFamily="34" charset="0"/>
+              </a:rPr>
+              <a:t>realizar</a:t>
+            </a:r>
+            <a:r>
+              <a:rPr lang="en-US" sz="1200" dirty="0">
+                <a:solidFill>
+                  <a:srgbClr val="222222"/>
+                </a:solidFill>
+                <a:latin typeface="Segoe UI" panose="020B0502040204020203" pitchFamily="34" charset="0"/>
+              </a:rPr>
+              <a:t> las </a:t>
+            </a:r>
+            <a:r>
+              <a:rPr lang="en-US" sz="1200" dirty="0" err="1">
+                <a:solidFill>
+                  <a:srgbClr val="222222"/>
+                </a:solidFill>
+                <a:latin typeface="Segoe UI" panose="020B0502040204020203" pitchFamily="34" charset="0"/>
+              </a:rPr>
+              <a:t>devoluciones</a:t>
+            </a:r>
+            <a:r>
+              <a:rPr lang="en-US" sz="1200" dirty="0">
+                <a:solidFill>
+                  <a:srgbClr val="222222"/>
+                </a:solidFill>
+                <a:latin typeface="Segoe UI" panose="020B0502040204020203" pitchFamily="34" charset="0"/>
+              </a:rPr>
+              <a:t> de </a:t>
+            </a:r>
+            <a:r>
+              <a:rPr lang="en-US" sz="1200" dirty="0" err="1">
+                <a:solidFill>
+                  <a:srgbClr val="222222"/>
+                </a:solidFill>
+                <a:latin typeface="Segoe UI" panose="020B0502040204020203" pitchFamily="34" charset="0"/>
+              </a:rPr>
+              <a:t>pieles</a:t>
+            </a:r>
+            <a:r>
+              <a:rPr lang="en-US" sz="1200" dirty="0">
+                <a:solidFill>
+                  <a:srgbClr val="222222"/>
+                </a:solidFill>
+                <a:latin typeface="Segoe UI" panose="020B0502040204020203" pitchFamily="34" charset="0"/>
+              </a:rPr>
+              <a:t> de </a:t>
+            </a:r>
+            <a:r>
+              <a:rPr lang="en-US" sz="1200" dirty="0" err="1">
+                <a:solidFill>
+                  <a:srgbClr val="222222"/>
+                </a:solidFill>
+                <a:latin typeface="Segoe UI" panose="020B0502040204020203" pitchFamily="34" charset="0"/>
+              </a:rPr>
+              <a:t>producción</a:t>
+            </a:r>
+            <a:r>
+              <a:rPr lang="en-US" sz="1200" dirty="0">
+                <a:solidFill>
+                  <a:srgbClr val="222222"/>
+                </a:solidFill>
+                <a:latin typeface="Segoe UI" panose="020B0502040204020203" pitchFamily="34" charset="0"/>
+              </a:rPr>
+              <a:t>, </a:t>
+            </a:r>
+            <a:r>
+              <a:rPr lang="en-US" sz="1200" dirty="0" err="1">
+                <a:solidFill>
+                  <a:srgbClr val="222222"/>
+                </a:solidFill>
+                <a:latin typeface="Segoe UI" panose="020B0502040204020203" pitchFamily="34" charset="0"/>
+              </a:rPr>
+              <a:t>esto</a:t>
+            </a:r>
+            <a:r>
+              <a:rPr lang="en-US" sz="1200" dirty="0">
+                <a:solidFill>
+                  <a:srgbClr val="222222"/>
+                </a:solidFill>
+                <a:latin typeface="Segoe UI" panose="020B0502040204020203" pitchFamily="34" charset="0"/>
+              </a:rPr>
+              <a:t> con la </a:t>
+            </a:r>
+            <a:r>
+              <a:rPr lang="en-US" sz="1200" dirty="0" err="1">
+                <a:solidFill>
+                  <a:srgbClr val="222222"/>
+                </a:solidFill>
+                <a:latin typeface="Segoe UI" panose="020B0502040204020203" pitchFamily="34" charset="0"/>
+              </a:rPr>
+              <a:t>intención</a:t>
+            </a:r>
+            <a:r>
+              <a:rPr lang="en-US" sz="1200" dirty="0">
+                <a:solidFill>
+                  <a:srgbClr val="222222"/>
+                </a:solidFill>
+                <a:latin typeface="Segoe UI" panose="020B0502040204020203" pitchFamily="34" charset="0"/>
+              </a:rPr>
+              <a:t> de que </a:t>
+            </a:r>
+            <a:r>
+              <a:rPr lang="en-US" sz="1200" dirty="0" err="1">
+                <a:solidFill>
+                  <a:srgbClr val="222222"/>
+                </a:solidFill>
+                <a:latin typeface="Segoe UI" panose="020B0502040204020203" pitchFamily="34" charset="0"/>
+              </a:rPr>
+              <a:t>el</a:t>
+            </a:r>
+            <a:r>
+              <a:rPr lang="en-US" sz="1200" dirty="0">
+                <a:solidFill>
+                  <a:srgbClr val="222222"/>
+                </a:solidFill>
+                <a:latin typeface="Segoe UI" panose="020B0502040204020203" pitchFamily="34" charset="0"/>
+              </a:rPr>
+              <a:t> </a:t>
+            </a:r>
+            <a:r>
+              <a:rPr lang="en-US" sz="1200" dirty="0" err="1">
+                <a:solidFill>
+                  <a:srgbClr val="222222"/>
+                </a:solidFill>
+                <a:latin typeface="Segoe UI" panose="020B0502040204020203" pitchFamily="34" charset="0"/>
+              </a:rPr>
+              <a:t>proceso</a:t>
+            </a:r>
+            <a:r>
+              <a:rPr lang="en-US" sz="1200" dirty="0">
+                <a:solidFill>
+                  <a:srgbClr val="222222"/>
+                </a:solidFill>
+                <a:latin typeface="Segoe UI" panose="020B0502040204020203" pitchFamily="34" charset="0"/>
+              </a:rPr>
+              <a:t> se realize mas </a:t>
+            </a:r>
+            <a:r>
+              <a:rPr lang="en-US" sz="1200" dirty="0" err="1">
+                <a:solidFill>
+                  <a:srgbClr val="222222"/>
+                </a:solidFill>
+                <a:latin typeface="Segoe UI" panose="020B0502040204020203" pitchFamily="34" charset="0"/>
+              </a:rPr>
+              <a:t>rapido</a:t>
+            </a:r>
+            <a:r>
+              <a:rPr lang="en-US" sz="1200" dirty="0">
+                <a:solidFill>
+                  <a:srgbClr val="222222"/>
+                </a:solidFill>
+                <a:latin typeface="Segoe UI" panose="020B0502040204020203" pitchFamily="34" charset="0"/>
+              </a:rPr>
+              <a:t> y </a:t>
+            </a:r>
+            <a:r>
+              <a:rPr lang="en-US" sz="1200" dirty="0" err="1">
+                <a:solidFill>
+                  <a:srgbClr val="222222"/>
+                </a:solidFill>
+                <a:latin typeface="Segoe UI" panose="020B0502040204020203" pitchFamily="34" charset="0"/>
+              </a:rPr>
+              <a:t>eficiente</a:t>
+            </a:r>
+            <a:r>
+              <a:rPr lang="en-US" sz="1200" dirty="0">
+                <a:solidFill>
+                  <a:srgbClr val="222222"/>
+                </a:solidFill>
+                <a:latin typeface="Segoe UI" panose="020B0502040204020203" pitchFamily="34" charset="0"/>
+              </a:rPr>
+              <a:t>. La </a:t>
+            </a:r>
+            <a:r>
+              <a:rPr lang="en-US" sz="1200" dirty="0" err="1">
+                <a:solidFill>
+                  <a:srgbClr val="222222"/>
+                </a:solidFill>
+                <a:latin typeface="Segoe UI" panose="020B0502040204020203" pitchFamily="34" charset="0"/>
+              </a:rPr>
+              <a:t>pantalla</a:t>
+            </a:r>
+            <a:r>
+              <a:rPr lang="en-US" sz="1200" dirty="0">
+                <a:solidFill>
+                  <a:srgbClr val="222222"/>
+                </a:solidFill>
+                <a:latin typeface="Segoe UI" panose="020B0502040204020203" pitchFamily="34" charset="0"/>
+              </a:rPr>
+              <a:t> </a:t>
+            </a:r>
+            <a:r>
+              <a:rPr lang="en-US" sz="1200" dirty="0" err="1">
+                <a:solidFill>
+                  <a:srgbClr val="222222"/>
+                </a:solidFill>
+                <a:latin typeface="Segoe UI" panose="020B0502040204020203" pitchFamily="34" charset="0"/>
+              </a:rPr>
+              <a:t>cuenta</a:t>
+            </a:r>
+            <a:r>
+              <a:rPr lang="en-US" sz="1200" dirty="0">
+                <a:solidFill>
+                  <a:srgbClr val="222222"/>
+                </a:solidFill>
+                <a:latin typeface="Segoe UI" panose="020B0502040204020203" pitchFamily="34" charset="0"/>
+              </a:rPr>
+              <a:t> con un campo </a:t>
+            </a:r>
+            <a:r>
+              <a:rPr lang="en-US" sz="1200" dirty="0" err="1">
+                <a:solidFill>
+                  <a:srgbClr val="222222"/>
+                </a:solidFill>
+                <a:latin typeface="Segoe UI" panose="020B0502040204020203" pitchFamily="34" charset="0"/>
+              </a:rPr>
+              <a:t>donde</a:t>
+            </a:r>
+            <a:r>
+              <a:rPr lang="en-US" sz="1200" dirty="0">
+                <a:solidFill>
+                  <a:srgbClr val="222222"/>
+                </a:solidFill>
+                <a:latin typeface="Segoe UI" panose="020B0502040204020203" pitchFamily="34" charset="0"/>
+              </a:rPr>
+              <a:t> </a:t>
+            </a:r>
+            <a:r>
+              <a:rPr lang="en-US" sz="1200" dirty="0" err="1">
+                <a:solidFill>
+                  <a:srgbClr val="222222"/>
+                </a:solidFill>
+                <a:latin typeface="Segoe UI" panose="020B0502040204020203" pitchFamily="34" charset="0"/>
+              </a:rPr>
+              <a:t>pondremos</a:t>
+            </a:r>
+            <a:r>
+              <a:rPr lang="en-US" sz="1200" dirty="0">
+                <a:solidFill>
+                  <a:srgbClr val="222222"/>
+                </a:solidFill>
+                <a:latin typeface="Segoe UI" panose="020B0502040204020203" pitchFamily="34" charset="0"/>
+              </a:rPr>
+              <a:t> </a:t>
+            </a:r>
+            <a:r>
+              <a:rPr lang="en-US" sz="1200" dirty="0" err="1">
+                <a:solidFill>
+                  <a:srgbClr val="222222"/>
+                </a:solidFill>
+                <a:latin typeface="Segoe UI" panose="020B0502040204020203" pitchFamily="34" charset="0"/>
+              </a:rPr>
+              <a:t>el</a:t>
+            </a:r>
+            <a:r>
+              <a:rPr lang="en-US" sz="1200" dirty="0">
+                <a:solidFill>
+                  <a:srgbClr val="222222"/>
+                </a:solidFill>
+                <a:latin typeface="Segoe UI" panose="020B0502040204020203" pitchFamily="34" charset="0"/>
+              </a:rPr>
+              <a:t> folio que </a:t>
+            </a:r>
+            <a:r>
+              <a:rPr lang="en-US" sz="1200" dirty="0" err="1">
+                <a:solidFill>
+                  <a:srgbClr val="222222"/>
+                </a:solidFill>
+                <a:latin typeface="Segoe UI" panose="020B0502040204020203" pitchFamily="34" charset="0"/>
+              </a:rPr>
+              <a:t>contiene</a:t>
+            </a:r>
+            <a:r>
+              <a:rPr lang="en-US" sz="1200" dirty="0">
+                <a:solidFill>
+                  <a:srgbClr val="222222"/>
+                </a:solidFill>
+                <a:latin typeface="Segoe UI" panose="020B0502040204020203" pitchFamily="34" charset="0"/>
+              </a:rPr>
+              <a:t> </a:t>
+            </a:r>
+            <a:r>
+              <a:rPr lang="en-US" sz="1200" dirty="0" err="1">
+                <a:solidFill>
+                  <a:srgbClr val="222222"/>
+                </a:solidFill>
+                <a:latin typeface="Segoe UI" panose="020B0502040204020203" pitchFamily="34" charset="0"/>
+              </a:rPr>
+              <a:t>pieles</a:t>
+            </a:r>
+            <a:r>
+              <a:rPr lang="en-US" sz="1200" dirty="0">
+                <a:solidFill>
+                  <a:srgbClr val="222222"/>
+                </a:solidFill>
+                <a:latin typeface="Segoe UI" panose="020B0502040204020203" pitchFamily="34" charset="0"/>
+              </a:rPr>
+              <a:t> para </a:t>
+            </a:r>
+            <a:r>
+              <a:rPr lang="en-US" sz="1200" dirty="0" err="1">
+                <a:solidFill>
+                  <a:srgbClr val="222222"/>
+                </a:solidFill>
+                <a:latin typeface="Segoe UI" panose="020B0502040204020203" pitchFamily="34" charset="0"/>
+              </a:rPr>
+              <a:t>devoluciones</a:t>
+            </a:r>
+            <a:r>
+              <a:rPr lang="en-US" sz="1200" dirty="0">
+                <a:solidFill>
+                  <a:srgbClr val="222222"/>
+                </a:solidFill>
+                <a:latin typeface="Segoe UI" panose="020B0502040204020203" pitchFamily="34" charset="0"/>
+              </a:rPr>
+              <a:t> </a:t>
+            </a:r>
+            <a:r>
+              <a:rPr lang="en-US" sz="1200" dirty="0" err="1">
+                <a:solidFill>
+                  <a:srgbClr val="222222"/>
+                </a:solidFill>
+                <a:latin typeface="Segoe UI" panose="020B0502040204020203" pitchFamily="34" charset="0"/>
+              </a:rPr>
+              <a:t>en</a:t>
+            </a:r>
+            <a:r>
+              <a:rPr lang="en-US" sz="1200" dirty="0">
+                <a:solidFill>
+                  <a:srgbClr val="222222"/>
+                </a:solidFill>
+                <a:latin typeface="Segoe UI" panose="020B0502040204020203" pitchFamily="34" charset="0"/>
+              </a:rPr>
+              <a:t> la </a:t>
+            </a:r>
+            <a:r>
+              <a:rPr lang="en-US" sz="1200" dirty="0" err="1">
+                <a:solidFill>
+                  <a:srgbClr val="222222"/>
+                </a:solidFill>
+                <a:latin typeface="Segoe UI" panose="020B0502040204020203" pitchFamily="34" charset="0"/>
+              </a:rPr>
+              <a:t>parte</a:t>
+            </a:r>
+            <a:r>
+              <a:rPr lang="en-US" sz="1200" dirty="0">
+                <a:solidFill>
+                  <a:srgbClr val="222222"/>
+                </a:solidFill>
+                <a:latin typeface="Segoe UI" panose="020B0502040204020203" pitchFamily="34" charset="0"/>
+              </a:rPr>
+              <a:t> superior </a:t>
+            </a:r>
+            <a:r>
+              <a:rPr lang="en-US" sz="1200" dirty="0" err="1">
+                <a:solidFill>
+                  <a:srgbClr val="222222"/>
+                </a:solidFill>
+                <a:latin typeface="Segoe UI" panose="020B0502040204020203" pitchFamily="34" charset="0"/>
+              </a:rPr>
+              <a:t>izquierda</a:t>
+            </a:r>
+            <a:r>
+              <a:rPr lang="en-US" sz="1200" dirty="0">
+                <a:solidFill>
+                  <a:srgbClr val="222222"/>
+                </a:solidFill>
+                <a:latin typeface="Segoe UI" panose="020B0502040204020203" pitchFamily="34" charset="0"/>
+              </a:rPr>
+              <a:t> de la </a:t>
+            </a:r>
+            <a:r>
+              <a:rPr lang="en-US" sz="1200" dirty="0" err="1">
+                <a:solidFill>
+                  <a:srgbClr val="222222"/>
+                </a:solidFill>
+                <a:latin typeface="Segoe UI" panose="020B0502040204020203" pitchFamily="34" charset="0"/>
+              </a:rPr>
+              <a:t>pantalla</a:t>
+            </a:r>
+            <a:r>
+              <a:rPr lang="en-US" sz="1200" dirty="0">
+                <a:solidFill>
+                  <a:srgbClr val="222222"/>
+                </a:solidFill>
+                <a:latin typeface="Segoe UI" panose="020B0502040204020203" pitchFamily="34" charset="0"/>
+              </a:rPr>
+              <a:t> temenos dos </a:t>
+            </a:r>
+            <a:r>
+              <a:rPr lang="en-US" sz="1200" dirty="0" err="1">
+                <a:solidFill>
+                  <a:srgbClr val="222222"/>
+                </a:solidFill>
+                <a:latin typeface="Segoe UI" panose="020B0502040204020203" pitchFamily="34" charset="0"/>
+              </a:rPr>
+              <a:t>botones</a:t>
+            </a:r>
+            <a:r>
+              <a:rPr lang="en-US" sz="1200" dirty="0">
+                <a:solidFill>
+                  <a:srgbClr val="222222"/>
+                </a:solidFill>
+                <a:latin typeface="Segoe UI" panose="020B0502040204020203" pitchFamily="34" charset="0"/>
+              </a:rPr>
+              <a:t>: El primero </a:t>
+            </a:r>
+            <a:r>
+              <a:rPr lang="en-US" sz="1200" dirty="0" err="1">
+                <a:solidFill>
+                  <a:srgbClr val="222222"/>
+                </a:solidFill>
+                <a:latin typeface="Segoe UI" panose="020B0502040204020203" pitchFamily="34" charset="0"/>
+              </a:rPr>
+              <a:t>sirve</a:t>
+            </a:r>
+            <a:r>
+              <a:rPr lang="en-US" sz="1200" dirty="0">
+                <a:solidFill>
+                  <a:srgbClr val="222222"/>
+                </a:solidFill>
+                <a:latin typeface="Segoe UI" panose="020B0502040204020203" pitchFamily="34" charset="0"/>
+              </a:rPr>
+              <a:t> para </a:t>
+            </a:r>
+            <a:r>
+              <a:rPr lang="en-US" sz="1200" dirty="0" err="1">
+                <a:solidFill>
+                  <a:srgbClr val="222222"/>
+                </a:solidFill>
+                <a:latin typeface="Segoe UI" panose="020B0502040204020203" pitchFamily="34" charset="0"/>
+              </a:rPr>
+              <a:t>cancelar</a:t>
+            </a:r>
+            <a:r>
+              <a:rPr lang="en-US" sz="1200" dirty="0">
+                <a:solidFill>
+                  <a:srgbClr val="222222"/>
+                </a:solidFill>
+                <a:latin typeface="Segoe UI" panose="020B0502040204020203" pitchFamily="34" charset="0"/>
+              </a:rPr>
+              <a:t> la </a:t>
+            </a:r>
+            <a:r>
+              <a:rPr lang="en-US" sz="1200" dirty="0" err="1">
+                <a:solidFill>
+                  <a:srgbClr val="222222"/>
+                </a:solidFill>
+                <a:latin typeface="Segoe UI" panose="020B0502040204020203" pitchFamily="34" charset="0"/>
+              </a:rPr>
+              <a:t>devolución</a:t>
+            </a:r>
+            <a:r>
+              <a:rPr lang="en-US" sz="1200" dirty="0">
+                <a:solidFill>
+                  <a:srgbClr val="222222"/>
+                </a:solidFill>
+                <a:latin typeface="Segoe UI" panose="020B0502040204020203" pitchFamily="34" charset="0"/>
+              </a:rPr>
+              <a:t> y </a:t>
+            </a:r>
+            <a:r>
+              <a:rPr lang="en-US" sz="1200" dirty="0" err="1">
+                <a:solidFill>
+                  <a:srgbClr val="222222"/>
+                </a:solidFill>
+                <a:latin typeface="Segoe UI" panose="020B0502040204020203" pitchFamily="34" charset="0"/>
+              </a:rPr>
+              <a:t>el</a:t>
+            </a:r>
+            <a:r>
+              <a:rPr lang="en-US" sz="1200" dirty="0">
+                <a:solidFill>
+                  <a:srgbClr val="222222"/>
+                </a:solidFill>
+                <a:latin typeface="Segoe UI" panose="020B0502040204020203" pitchFamily="34" charset="0"/>
+              </a:rPr>
+              <a:t> </a:t>
+            </a:r>
+            <a:r>
+              <a:rPr lang="en-US" sz="1200" dirty="0" err="1">
+                <a:solidFill>
+                  <a:srgbClr val="222222"/>
+                </a:solidFill>
+                <a:latin typeface="Segoe UI" panose="020B0502040204020203" pitchFamily="34" charset="0"/>
+              </a:rPr>
+              <a:t>segundo</a:t>
+            </a:r>
+            <a:r>
+              <a:rPr lang="en-US" sz="1200" dirty="0">
+                <a:solidFill>
+                  <a:srgbClr val="222222"/>
+                </a:solidFill>
+                <a:latin typeface="Segoe UI" panose="020B0502040204020203" pitchFamily="34" charset="0"/>
+              </a:rPr>
+              <a:t> para </a:t>
+            </a:r>
+            <a:r>
+              <a:rPr lang="en-US" sz="1200" dirty="0" err="1">
+                <a:solidFill>
+                  <a:srgbClr val="222222"/>
+                </a:solidFill>
+                <a:latin typeface="Segoe UI" panose="020B0502040204020203" pitchFamily="34" charset="0"/>
+              </a:rPr>
+              <a:t>aceptar</a:t>
+            </a:r>
+            <a:r>
+              <a:rPr lang="en-US" sz="1200" dirty="0">
+                <a:solidFill>
+                  <a:srgbClr val="222222"/>
+                </a:solidFill>
+                <a:latin typeface="Segoe UI" panose="020B0502040204020203" pitchFamily="34" charset="0"/>
+              </a:rPr>
+              <a:t> la </a:t>
+            </a:r>
+            <a:r>
+              <a:rPr lang="en-US" sz="1200" dirty="0" err="1">
+                <a:solidFill>
+                  <a:srgbClr val="222222"/>
+                </a:solidFill>
+                <a:latin typeface="Segoe UI" panose="020B0502040204020203" pitchFamily="34" charset="0"/>
+              </a:rPr>
+              <a:t>devolución</a:t>
+            </a:r>
+            <a:r>
+              <a:rPr lang="en-US" sz="1200" dirty="0">
+                <a:solidFill>
+                  <a:srgbClr val="222222"/>
+                </a:solidFill>
+                <a:latin typeface="Segoe UI" panose="020B0502040204020203" pitchFamily="34" charset="0"/>
+              </a:rPr>
+              <a:t> de las </a:t>
+            </a:r>
+            <a:r>
+              <a:rPr lang="en-US" sz="1200" dirty="0" err="1">
+                <a:solidFill>
+                  <a:srgbClr val="222222"/>
+                </a:solidFill>
+                <a:latin typeface="Segoe UI" panose="020B0502040204020203" pitchFamily="34" charset="0"/>
+              </a:rPr>
+              <a:t>pieles</a:t>
+            </a:r>
+            <a:r>
+              <a:rPr lang="en-US" sz="1200" dirty="0">
+                <a:solidFill>
+                  <a:srgbClr val="222222"/>
+                </a:solidFill>
+                <a:latin typeface="Segoe UI" panose="020B0502040204020203" pitchFamily="34" charset="0"/>
+              </a:rPr>
+              <a:t>.</a:t>
+            </a:r>
+            <a:endParaRPr lang="es-ES" sz="1200" b="0" i="0" dirty="0">
+              <a:solidFill>
+                <a:srgbClr val="222222"/>
+              </a:solidFill>
+              <a:effectLst/>
+              <a:latin typeface="Segoe UI" panose="020B0502040204020203" pitchFamily="34" charset="0"/>
+            </a:endParaRPr>
+          </a:p>
+        </p:txBody>
+      </p:sp>
+      <p:pic>
+        <p:nvPicPr>
+          <p:cNvPr id="9" name="Imagen 8" descr="Interfaz de usuario gráfica, Texto, Aplicación&#10;&#10;Descripción generada automáticamente">
+            <a:extLst>
+              <a:ext uri="{FF2B5EF4-FFF2-40B4-BE49-F238E27FC236}">
+                <a16:creationId xmlns:a16="http://schemas.microsoft.com/office/drawing/2014/main" id="{6B541273-E114-456A-A50F-92F8CF87CDDE}"/>
+              </a:ext>
+            </a:extLst>
+          </p:cNvPr>
+          <p:cNvPicPr>
+            <a:picLocks noChangeAspect="1"/>
+          </p:cNvPicPr>
+          <p:nvPr/>
+        </p:nvPicPr>
+        <p:blipFill>
+          <a:blip r:embed="rId2">
+            <a:extLst>
+              <a:ext uri="{28A0092B-C50C-407E-A947-70E740481C1C}">
+                <a14:useLocalDpi xmlns:a14="http://schemas.microsoft.com/office/drawing/2010/main" val="0"/>
+              </a:ext>
+            </a:extLst>
+          </a:blip>
+          <a:stretch>
+            <a:fillRect/>
+          </a:stretch>
+        </p:blipFill>
+        <p:spPr>
+          <a:xfrm>
+            <a:off x="1159416" y="1811724"/>
+            <a:ext cx="7949088" cy="4968645"/>
+          </a:xfrm>
+          <a:prstGeom prst="rect">
+            <a:avLst/>
+          </a:prstGeom>
+        </p:spPr>
+      </p:pic>
+      <p:sp>
+        <p:nvSpPr>
+          <p:cNvPr id="11" name="Rectángulo 10">
+            <a:extLst>
+              <a:ext uri="{FF2B5EF4-FFF2-40B4-BE49-F238E27FC236}">
+                <a16:creationId xmlns:a16="http://schemas.microsoft.com/office/drawing/2014/main" id="{57E6FB61-EA29-4921-83C2-CB56A4C44766}"/>
+              </a:ext>
+            </a:extLst>
+          </p:cNvPr>
+          <p:cNvSpPr/>
+          <p:nvPr/>
+        </p:nvSpPr>
+        <p:spPr>
+          <a:xfrm>
+            <a:off x="8460432" y="2048074"/>
+            <a:ext cx="648072" cy="228798"/>
+          </a:xfrm>
+          <a:prstGeom prst="rect">
+            <a:avLst/>
+          </a:prstGeom>
+          <a:noFill/>
+          <a:ln>
+            <a:solidFill>
+              <a:srgbClr val="FF0000"/>
+            </a:solidFill>
+          </a:ln>
+        </p:spPr>
+        <p:style>
+          <a:lnRef idx="2">
+            <a:schemeClr val="accent1">
+              <a:shade val="50000"/>
+            </a:schemeClr>
+          </a:lnRef>
+          <a:fillRef idx="1">
+            <a:schemeClr val="accent1"/>
+          </a:fillRef>
+          <a:effectRef idx="0">
+            <a:schemeClr val="accent1"/>
+          </a:effectRef>
+          <a:fontRef idx="minor">
+            <a:schemeClr val="lt1"/>
+          </a:fontRef>
+        </p:style>
+        <p:txBody>
+          <a:bodyPr rtlCol="0" anchor="ctr"/>
+          <a:lstStyle/>
+          <a:p>
+            <a:pPr algn="ctr"/>
+            <a:endParaRPr lang="en-US"/>
+          </a:p>
+        </p:txBody>
+      </p:sp>
+    </p:spTree>
+    <p:extLst>
+      <p:ext uri="{BB962C8B-B14F-4D97-AF65-F5344CB8AC3E}">
+        <p14:creationId xmlns:p14="http://schemas.microsoft.com/office/powerpoint/2010/main" val="2952197749"/>
+      </p:ext>
+    </p:extLst>
+  </p:cSld>
+  <p:clrMapOvr>
+    <a:masterClrMapping/>
+  </p:clrMapOvr>
+</p:sld>
+</file>
+
+<file path=ppt/slides/slide3.xml><?xml version="1.0" encoding="utf-8"?>
+<p:sld xmlns:a="http://schemas.openxmlformats.org/drawingml/2006/main" xmlns:r="http://schemas.openxmlformats.org/officeDocument/2006/relationships" xmlns:p="http://schemas.openxmlformats.org/presentationml/2006/main">
+  <p:cSld>
+    <p:spTree>
+      <p:nvGrpSpPr>
+        <p:cNvPr id="1" name=""/>
+        <p:cNvGrpSpPr/>
+        <p:nvPr/>
+      </p:nvGrpSpPr>
+      <p:grpSpPr>
+        <a:xfrm>
+          <a:off x="0" y="0"/>
+          <a:ext cx="0" cy="0"/>
+          <a:chOff x="0" y="0"/>
+          <a:chExt cx="0" cy="0"/>
+        </a:xfrm>
+      </p:grpSpPr>
+      <p:sp>
+        <p:nvSpPr>
+          <p:cNvPr id="5" name="Title 1"/>
+          <p:cNvSpPr txBox="1">
+            <a:spLocks/>
+          </p:cNvSpPr>
+          <p:nvPr/>
+        </p:nvSpPr>
+        <p:spPr>
+          <a:xfrm>
+            <a:off x="1187624" y="2564904"/>
+            <a:ext cx="7772400" cy="1470025"/>
+          </a:xfrm>
+          <a:prstGeom prst="rect">
+            <a:avLst/>
+          </a:prstGeom>
+        </p:spPr>
+        <p:txBody>
+          <a:bodyPr vert="horz" lIns="91440" tIns="45720" rIns="91440" bIns="45720" rtlCol="0" anchor="ctr">
+            <a:normAutofit/>
+          </a:bodyPr>
+          <a:lstStyle>
+            <a:lvl1pPr algn="ctr" defTabSz="914400" rtl="0" eaLnBrk="1" latinLnBrk="0" hangingPunct="1">
+              <a:spcBef>
+                <a:spcPct val="0"/>
+              </a:spcBef>
+              <a:buNone/>
+              <a:defRPr sz="4400" kern="1200">
+                <a:solidFill>
+                  <a:schemeClr val="tx1"/>
+                </a:solidFill>
+                <a:latin typeface="+mj-lt"/>
+                <a:ea typeface="+mj-ea"/>
+                <a:cs typeface="+mj-cs"/>
+              </a:defRPr>
+            </a:lvl1pPr>
+          </a:lstStyle>
+          <a:p>
+            <a:r>
+              <a:rPr lang="es-MX" b="1" dirty="0">
+                <a:latin typeface="Century Gothic" panose="020B0502020202020204" pitchFamily="34" charset="0"/>
+              </a:rPr>
+              <a:t>24/05/2021 – 28/05/2021</a:t>
+            </a:r>
+            <a:endParaRPr lang="es-MX" dirty="0">
+              <a:latin typeface="Century Gothic" panose="020B0502020202020204" pitchFamily="34" charset="0"/>
+            </a:endParaRPr>
+          </a:p>
+        </p:txBody>
+      </p:sp>
+    </p:spTree>
+    <p:extLst>
+      <p:ext uri="{BB962C8B-B14F-4D97-AF65-F5344CB8AC3E}">
+        <p14:creationId xmlns:p14="http://schemas.microsoft.com/office/powerpoint/2010/main" val="2095554785"/>
+      </p:ext>
+    </p:extLst>
+  </p:cSld>
+  <p:clrMapOvr>
+    <a:masterClrMapping/>
+  </p:clrMapOvr>
+</p:sld>
+</file>
+
+<file path=ppt/slides/slide4.xml><?xml version="1.0" encoding="utf-8"?>
 <p:sld xmlns:a="http://schemas.openxmlformats.org/drawingml/2006/main" xmlns:r="http://schemas.openxmlformats.org/officeDocument/2006/relationships" xmlns:p="http://schemas.openxmlformats.org/presentationml/2006/main">
   <p:cSld>
     <p:spTree>
@@ -4177,7 +5655,7 @@
 </p:sld>
 </file>
 
-<file path=ppt/slides/slide3.xml><?xml version="1.0" encoding="utf-8"?>
+<file path=ppt/slides/slide5.xml><?xml version="1.0" encoding="utf-8"?>
 <p:sld xmlns:a="http://schemas.openxmlformats.org/drawingml/2006/main" xmlns:r="http://schemas.openxmlformats.org/officeDocument/2006/relationships" xmlns:p="http://schemas.openxmlformats.org/presentationml/2006/main">
   <p:cSld>
     <p:spTree>
@@ -4510,7 +5988,7 @@
 </p:sld>
 </file>
 
-<file path=ppt/slides/slide4.xml><?xml version="1.0" encoding="utf-8"?>
+<file path=ppt/slides/slide6.xml><?xml version="1.0" encoding="utf-8"?>
 <p:sld xmlns:a="http://schemas.openxmlformats.org/drawingml/2006/main" xmlns:r="http://schemas.openxmlformats.org/officeDocument/2006/relationships" xmlns:p="http://schemas.openxmlformats.org/presentationml/2006/main">
   <p:cSld>
     <p:spTree>
@@ -4920,7 +6398,7 @@
 </p:sld>
 </file>
 
-<file path=ppt/slides/slide5.xml><?xml version="1.0" encoding="utf-8"?>
+<file path=ppt/slides/slide7.xml><?xml version="1.0" encoding="utf-8"?>
 <p:sld xmlns:a="http://schemas.openxmlformats.org/drawingml/2006/main" xmlns:r="http://schemas.openxmlformats.org/officeDocument/2006/relationships" xmlns:p="http://schemas.openxmlformats.org/presentationml/2006/main">
   <p:cSld>
     <p:spTree>
@@ -5000,7 +6478,7 @@
 </p:sld>
 </file>
 
-<file path=ppt/slides/slide6.xml><?xml version="1.0" encoding="utf-8"?>
+<file path=ppt/slides/slide8.xml><?xml version="1.0" encoding="utf-8"?>
 <p:sld xmlns:a="http://schemas.openxmlformats.org/drawingml/2006/main" xmlns:r="http://schemas.openxmlformats.org/officeDocument/2006/relationships" xmlns:p="http://schemas.openxmlformats.org/presentationml/2006/main">
   <p:cSld>
     <p:spTree>
@@ -5366,7 +6844,7 @@
 </p:sld>
 </file>
 
-<file path=ppt/slides/slide7.xml><?xml version="1.0" encoding="utf-8"?>
+<file path=ppt/slides/slide9.xml><?xml version="1.0" encoding="utf-8"?>
 <p:sld xmlns:a="http://schemas.openxmlformats.org/drawingml/2006/main" xmlns:r="http://schemas.openxmlformats.org/officeDocument/2006/relationships" xmlns:p="http://schemas.openxmlformats.org/presentationml/2006/main">
   <p:cSld>
     <p:spTree>
@@ -5437,398 +6915,6 @@
     <p:extLst>
       <p:ext uri="{BB962C8B-B14F-4D97-AF65-F5344CB8AC3E}">
         <p14:creationId xmlns:p14="http://schemas.microsoft.com/office/powerpoint/2010/main" val="1449075767"/>
-      </p:ext>
-    </p:extLst>
-  </p:cSld>
-  <p:clrMapOvr>
-    <a:masterClrMapping/>
-  </p:clrMapOvr>
-</p:sld>
-</file>
-
-<file path=ppt/slides/slide8.xml><?xml version="1.0" encoding="utf-8"?>
-<p:sld xmlns:a="http://schemas.openxmlformats.org/drawingml/2006/main" xmlns:r="http://schemas.openxmlformats.org/officeDocument/2006/relationships" xmlns:p="http://schemas.openxmlformats.org/presentationml/2006/main">
-  <p:cSld>
-    <p:spTree>
-      <p:nvGrpSpPr>
-        <p:cNvPr id="1" name=""/>
-        <p:cNvGrpSpPr/>
-        <p:nvPr/>
-      </p:nvGrpSpPr>
-      <p:grpSpPr>
-        <a:xfrm>
-          <a:off x="0" y="0"/>
-          <a:ext cx="0" cy="0"/>
-          <a:chOff x="0" y="0"/>
-          <a:chExt cx="0" cy="0"/>
-        </a:xfrm>
-      </p:grpSpPr>
-      <p:sp>
-        <p:nvSpPr>
-          <p:cNvPr id="8" name="Title 1"/>
-          <p:cNvSpPr txBox="1">
-            <a:spLocks/>
-          </p:cNvSpPr>
-          <p:nvPr/>
-        </p:nvSpPr>
-        <p:spPr>
-          <a:xfrm>
-            <a:off x="1087408" y="274638"/>
-            <a:ext cx="7229008" cy="634082"/>
-          </a:xfrm>
-          <a:prstGeom prst="rect">
-            <a:avLst/>
-          </a:prstGeom>
-        </p:spPr>
-        <p:txBody>
-          <a:bodyPr/>
-          <a:lstStyle>
-            <a:lvl1pPr algn="ctr" defTabSz="914400" rtl="0" eaLnBrk="1" latinLnBrk="0" hangingPunct="1">
-              <a:spcBef>
-                <a:spcPct val="0"/>
-              </a:spcBef>
-              <a:buNone/>
-              <a:defRPr sz="4400" kern="1200">
-                <a:solidFill>
-                  <a:schemeClr val="tx1"/>
-                </a:solidFill>
-                <a:latin typeface="+mj-lt"/>
-                <a:ea typeface="+mj-ea"/>
-                <a:cs typeface="+mj-cs"/>
-              </a:defRPr>
-            </a:lvl1pPr>
-          </a:lstStyle>
-          <a:p>
-            <a:pPr algn="l"/>
-            <a:r>
-              <a:rPr lang="es-ES" sz="2000" dirty="0">
-                <a:solidFill>
-                  <a:srgbClr val="3F1900"/>
-                </a:solidFill>
-              </a:rPr>
-              <a:t>TRANSFERENCIA DE FOLIOS: CAMBIO DE COLOR DE PIELES.</a:t>
-            </a:r>
-            <a:endParaRPr lang="en-US" sz="2000" dirty="0">
-              <a:solidFill>
-                <a:srgbClr val="3F1900"/>
-              </a:solidFill>
-            </a:endParaRPr>
-          </a:p>
-        </p:txBody>
-      </p:sp>
-      <p:sp>
-        <p:nvSpPr>
-          <p:cNvPr id="4" name="Content Placeholder 3"/>
-          <p:cNvSpPr txBox="1">
-            <a:spLocks/>
-          </p:cNvSpPr>
-          <p:nvPr/>
-        </p:nvSpPr>
-        <p:spPr>
-          <a:xfrm>
-            <a:off x="1331640" y="1196753"/>
-            <a:ext cx="7488832" cy="5137780"/>
-          </a:xfrm>
-          <a:prstGeom prst="rect">
-            <a:avLst/>
-          </a:prstGeom>
-        </p:spPr>
-        <p:txBody>
-          <a:bodyPr>
-            <a:normAutofit/>
-          </a:bodyPr>
-          <a:lstStyle>
-            <a:lvl1pPr marL="342900" indent="-342900" algn="l" defTabSz="914400" rtl="0" eaLnBrk="1" latinLnBrk="0" hangingPunct="1">
-              <a:spcBef>
-                <a:spcPct val="20000"/>
-              </a:spcBef>
-              <a:buFont typeface="Arial" panose="020B0604020202020204" pitchFamily="34" charset="0"/>
-              <a:buChar char="•"/>
-              <a:defRPr sz="3200" kern="1200">
-                <a:solidFill>
-                  <a:schemeClr val="tx1"/>
-                </a:solidFill>
-                <a:latin typeface="+mn-lt"/>
-                <a:ea typeface="+mn-ea"/>
-                <a:cs typeface="+mn-cs"/>
-              </a:defRPr>
-            </a:lvl1pPr>
-            <a:lvl2pPr marL="742950" indent="-285750" algn="l" defTabSz="914400" rtl="0" eaLnBrk="1" latinLnBrk="0" hangingPunct="1">
-              <a:spcBef>
-                <a:spcPct val="20000"/>
-              </a:spcBef>
-              <a:buFont typeface="Arial" panose="020B0604020202020204" pitchFamily="34" charset="0"/>
-              <a:buChar char="–"/>
-              <a:defRPr sz="2800" kern="1200">
-                <a:solidFill>
-                  <a:schemeClr val="tx1"/>
-                </a:solidFill>
-                <a:latin typeface="+mn-lt"/>
-                <a:ea typeface="+mn-ea"/>
-                <a:cs typeface="+mn-cs"/>
-              </a:defRPr>
-            </a:lvl2pPr>
-            <a:lvl3pPr marL="1143000" indent="-228600" algn="l" defTabSz="914400" rtl="0" eaLnBrk="1" latinLnBrk="0" hangingPunct="1">
-              <a:spcBef>
-                <a:spcPct val="20000"/>
-              </a:spcBef>
-              <a:buFont typeface="Arial" panose="020B0604020202020204" pitchFamily="34" charset="0"/>
-              <a:buChar char="•"/>
-              <a:defRPr sz="2400" kern="1200">
-                <a:solidFill>
-                  <a:schemeClr val="tx1"/>
-                </a:solidFill>
-                <a:latin typeface="+mn-lt"/>
-                <a:ea typeface="+mn-ea"/>
-                <a:cs typeface="+mn-cs"/>
-              </a:defRPr>
-            </a:lvl3pPr>
-            <a:lvl4pPr marL="1600200" indent="-228600" algn="l" defTabSz="914400" rtl="0" eaLnBrk="1" latinLnBrk="0" hangingPunct="1">
-              <a:spcBef>
-                <a:spcPct val="20000"/>
-              </a:spcBef>
-              <a:buFont typeface="Arial" panose="020B0604020202020204" pitchFamily="34" charset="0"/>
-              <a:buChar char="–"/>
-              <a:defRPr sz="2000" kern="1200">
-                <a:solidFill>
-                  <a:schemeClr val="tx1"/>
-                </a:solidFill>
-                <a:latin typeface="+mn-lt"/>
-                <a:ea typeface="+mn-ea"/>
-                <a:cs typeface="+mn-cs"/>
-              </a:defRPr>
-            </a:lvl4pPr>
-            <a:lvl5pPr marL="2057400" indent="-228600" algn="l" defTabSz="914400" rtl="0" eaLnBrk="1" latinLnBrk="0" hangingPunct="1">
-              <a:spcBef>
-                <a:spcPct val="20000"/>
-              </a:spcBef>
-              <a:buFont typeface="Arial" panose="020B0604020202020204" pitchFamily="34" charset="0"/>
-              <a:buChar char="»"/>
-              <a:defRPr sz="2000" kern="1200">
-                <a:solidFill>
-                  <a:schemeClr val="tx1"/>
-                </a:solidFill>
-                <a:latin typeface="+mn-lt"/>
-                <a:ea typeface="+mn-ea"/>
-                <a:cs typeface="+mn-cs"/>
-              </a:defRPr>
-            </a:lvl5pPr>
-            <a:lvl6pPr marL="2514600" indent="-228600" algn="l" defTabSz="914400" rtl="0" eaLnBrk="1" latinLnBrk="0" hangingPunct="1">
-              <a:spcBef>
-                <a:spcPct val="20000"/>
-              </a:spcBef>
-              <a:buFont typeface="Arial" panose="020B0604020202020204" pitchFamily="34" charset="0"/>
-              <a:buChar char="•"/>
-              <a:defRPr sz="2000" kern="1200">
-                <a:solidFill>
-                  <a:schemeClr val="tx1"/>
-                </a:solidFill>
-                <a:latin typeface="+mn-lt"/>
-                <a:ea typeface="+mn-ea"/>
-                <a:cs typeface="+mn-cs"/>
-              </a:defRPr>
-            </a:lvl6pPr>
-            <a:lvl7pPr marL="2971800" indent="-228600" algn="l" defTabSz="914400" rtl="0" eaLnBrk="1" latinLnBrk="0" hangingPunct="1">
-              <a:spcBef>
-                <a:spcPct val="20000"/>
-              </a:spcBef>
-              <a:buFont typeface="Arial" panose="020B0604020202020204" pitchFamily="34" charset="0"/>
-              <a:buChar char="•"/>
-              <a:defRPr sz="2000" kern="1200">
-                <a:solidFill>
-                  <a:schemeClr val="tx1"/>
-                </a:solidFill>
-                <a:latin typeface="+mn-lt"/>
-                <a:ea typeface="+mn-ea"/>
-                <a:cs typeface="+mn-cs"/>
-              </a:defRPr>
-            </a:lvl7pPr>
-            <a:lvl8pPr marL="3429000" indent="-228600" algn="l" defTabSz="914400" rtl="0" eaLnBrk="1" latinLnBrk="0" hangingPunct="1">
-              <a:spcBef>
-                <a:spcPct val="20000"/>
-              </a:spcBef>
-              <a:buFont typeface="Arial" panose="020B0604020202020204" pitchFamily="34" charset="0"/>
-              <a:buChar char="•"/>
-              <a:defRPr sz="2000" kern="1200">
-                <a:solidFill>
-                  <a:schemeClr val="tx1"/>
-                </a:solidFill>
-                <a:latin typeface="+mn-lt"/>
-                <a:ea typeface="+mn-ea"/>
-                <a:cs typeface="+mn-cs"/>
-              </a:defRPr>
-            </a:lvl8pPr>
-            <a:lvl9pPr marL="3886200" indent="-228600" algn="l" defTabSz="914400" rtl="0" eaLnBrk="1" latinLnBrk="0" hangingPunct="1">
-              <a:spcBef>
-                <a:spcPct val="20000"/>
-              </a:spcBef>
-              <a:buFont typeface="Arial" panose="020B0604020202020204" pitchFamily="34" charset="0"/>
-              <a:buChar char="•"/>
-              <a:defRPr sz="2000" kern="1200">
-                <a:solidFill>
-                  <a:schemeClr val="tx1"/>
-                </a:solidFill>
-                <a:latin typeface="+mn-lt"/>
-                <a:ea typeface="+mn-ea"/>
-                <a:cs typeface="+mn-cs"/>
-              </a:defRPr>
-            </a:lvl9pPr>
-          </a:lstStyle>
-          <a:p>
-            <a:pPr marL="0" indent="0" algn="just">
-              <a:buFont typeface="Arial" panose="020B0604020202020204" pitchFamily="34" charset="0"/>
-              <a:buNone/>
-            </a:pPr>
-            <a:endParaRPr lang="en-US" sz="2000" i="1"/>
-          </a:p>
-        </p:txBody>
-      </p:sp>
-      <p:sp>
-        <p:nvSpPr>
-          <p:cNvPr id="10" name="Rectangle 9"/>
-          <p:cNvSpPr/>
-          <p:nvPr/>
-        </p:nvSpPr>
-        <p:spPr>
-          <a:xfrm>
-            <a:off x="1331640" y="1095133"/>
-            <a:ext cx="7632848" cy="461665"/>
-          </a:xfrm>
-          <a:prstGeom prst="rect">
-            <a:avLst/>
-          </a:prstGeom>
-        </p:spPr>
-        <p:txBody>
-          <a:bodyPr wrap="square">
-            <a:spAutoFit/>
-          </a:bodyPr>
-          <a:lstStyle/>
-          <a:p>
-            <a:pPr>
-              <a:buFont typeface="Arial" panose="020B0604020202020204" pitchFamily="34" charset="0"/>
-              <a:buChar char="•"/>
-            </a:pPr>
-            <a:r>
-              <a:rPr lang="es-ES" sz="1200" b="0" i="0" dirty="0">
-                <a:solidFill>
-                  <a:srgbClr val="222222"/>
-                </a:solidFill>
-                <a:effectLst/>
-                <a:latin typeface="Segoe UI" panose="020B0502040204020203" pitchFamily="34" charset="0"/>
-              </a:rPr>
-              <a:t> Se </a:t>
-            </a:r>
-            <a:r>
-              <a:rPr lang="es-ES" sz="1200" dirty="0">
-                <a:solidFill>
-                  <a:srgbClr val="222222"/>
-                </a:solidFill>
-                <a:latin typeface="Segoe UI" panose="020B0502040204020203" pitchFamily="34" charset="0"/>
-              </a:rPr>
-              <a:t>agrego a Pantalla Folios la opción para cambiar de color las pieles e imprimir las etiquetas con el nuevo color.</a:t>
-            </a:r>
-            <a:endParaRPr lang="es-ES" sz="1200" b="0" i="0" dirty="0">
-              <a:solidFill>
-                <a:srgbClr val="222222"/>
-              </a:solidFill>
-              <a:effectLst/>
-              <a:latin typeface="Segoe UI" panose="020B0502040204020203" pitchFamily="34" charset="0"/>
-            </a:endParaRPr>
-          </a:p>
-        </p:txBody>
-      </p:sp>
-      <p:pic>
-        <p:nvPicPr>
-          <p:cNvPr id="7" name="Imagen 6" descr="Interfaz de usuario gráfica, Aplicación, Tabla&#10;&#10;Descripción generada automáticamente">
-            <a:extLst>
-              <a:ext uri="{FF2B5EF4-FFF2-40B4-BE49-F238E27FC236}">
-                <a16:creationId xmlns:a16="http://schemas.microsoft.com/office/drawing/2014/main" id="{1412D3D2-6E60-4CD0-BF83-09A5142874B0}"/>
-              </a:ext>
-            </a:extLst>
-          </p:cNvPr>
-          <p:cNvPicPr>
-            <a:picLocks noChangeAspect="1"/>
-          </p:cNvPicPr>
-          <p:nvPr/>
-        </p:nvPicPr>
-        <p:blipFill>
-          <a:blip r:embed="rId2">
-            <a:extLst>
-              <a:ext uri="{28A0092B-C50C-407E-A947-70E740481C1C}">
-                <a14:useLocalDpi xmlns:a14="http://schemas.microsoft.com/office/drawing/2010/main" val="0"/>
-              </a:ext>
-            </a:extLst>
-          </a:blip>
-          <a:stretch>
-            <a:fillRect/>
-          </a:stretch>
-        </p:blipFill>
-        <p:spPr>
-          <a:xfrm>
-            <a:off x="1331640" y="1556797"/>
-            <a:ext cx="7704856" cy="5184571"/>
-          </a:xfrm>
-          <a:prstGeom prst="rect">
-            <a:avLst/>
-          </a:prstGeom>
-        </p:spPr>
-      </p:pic>
-      <p:sp>
-        <p:nvSpPr>
-          <p:cNvPr id="9" name="Rectángulo 8">
-            <a:extLst>
-              <a:ext uri="{FF2B5EF4-FFF2-40B4-BE49-F238E27FC236}">
-                <a16:creationId xmlns:a16="http://schemas.microsoft.com/office/drawing/2014/main" id="{46E099D5-0DE3-484B-A40B-A00567D1261D}"/>
-              </a:ext>
-            </a:extLst>
-          </p:cNvPr>
-          <p:cNvSpPr/>
-          <p:nvPr/>
-        </p:nvSpPr>
-        <p:spPr>
-          <a:xfrm>
-            <a:off x="6804248" y="3429000"/>
-            <a:ext cx="1800200" cy="216024"/>
-          </a:xfrm>
-          <a:prstGeom prst="rect">
-            <a:avLst/>
-          </a:prstGeom>
-          <a:noFill/>
-          <a:ln>
-            <a:solidFill>
-              <a:srgbClr val="FF0000"/>
-            </a:solidFill>
-          </a:ln>
-        </p:spPr>
-        <p:style>
-          <a:lnRef idx="2">
-            <a:schemeClr val="accent1">
-              <a:shade val="50000"/>
-            </a:schemeClr>
-          </a:lnRef>
-          <a:fillRef idx="1">
-            <a:schemeClr val="accent1"/>
-          </a:fillRef>
-          <a:effectRef idx="0">
-            <a:schemeClr val="accent1"/>
-          </a:effectRef>
-          <a:fontRef idx="minor">
-            <a:schemeClr val="lt1"/>
-          </a:fontRef>
-        </p:style>
-        <p:txBody>
-          <a:bodyPr rtlCol="0" anchor="ctr"/>
-          <a:lstStyle/>
-          <a:p>
-            <a:pPr algn="ctr"/>
-            <a:endParaRPr lang="en-US"/>
-          </a:p>
-        </p:txBody>
-      </p:sp>
-    </p:spTree>
-    <p:extLst>
-      <p:ext uri="{BB962C8B-B14F-4D97-AF65-F5344CB8AC3E}">
-        <p14:creationId xmlns:p14="http://schemas.microsoft.com/office/powerpoint/2010/main" val="2311067179"/>
       </p:ext>
     </p:extLst>
   </p:cSld>

</xml_diff>

<commit_message>
SE AGREGO SP PARA STOCK STATUS PDF Y TRACKING LOTE POR COLOR
</commit_message>
<xml_diff>
--- a/Scripts_R100_Materiales/Folios_Transaccion/Docs/IT_DEV_FOLIOS_22102020.pptx
+++ b/Scripts_R100_Materiales/Folios_Transaccion/Docs/IT_DEV_FOLIOS_22102020.pptx
@@ -5,28 +5,30 @@
     <p:sldMasterId id="2147483648" r:id="rId1"/>
   </p:sldMasterIdLst>
   <p:notesMasterIdLst>
-    <p:notesMasterId r:id="rId21"/>
+    <p:notesMasterId r:id="rId23"/>
   </p:notesMasterIdLst>
   <p:sldIdLst>
     <p:sldId id="398" r:id="rId2"/>
-    <p:sldId id="411" r:id="rId3"/>
-    <p:sldId id="412" r:id="rId4"/>
-    <p:sldId id="413" r:id="rId5"/>
-    <p:sldId id="414" r:id="rId6"/>
-    <p:sldId id="409" r:id="rId7"/>
-    <p:sldId id="406" r:id="rId8"/>
-    <p:sldId id="407" r:id="rId9"/>
-    <p:sldId id="408" r:id="rId10"/>
-    <p:sldId id="405" r:id="rId11"/>
-    <p:sldId id="404" r:id="rId12"/>
-    <p:sldId id="403" r:id="rId13"/>
-    <p:sldId id="400" r:id="rId14"/>
-    <p:sldId id="402" r:id="rId15"/>
-    <p:sldId id="401" r:id="rId16"/>
-    <p:sldId id="399" r:id="rId17"/>
-    <p:sldId id="397" r:id="rId18"/>
-    <p:sldId id="344" r:id="rId19"/>
-    <p:sldId id="396" r:id="rId20"/>
+    <p:sldId id="416" r:id="rId3"/>
+    <p:sldId id="415" r:id="rId4"/>
+    <p:sldId id="411" r:id="rId5"/>
+    <p:sldId id="412" r:id="rId6"/>
+    <p:sldId id="413" r:id="rId7"/>
+    <p:sldId id="414" r:id="rId8"/>
+    <p:sldId id="409" r:id="rId9"/>
+    <p:sldId id="406" r:id="rId10"/>
+    <p:sldId id="407" r:id="rId11"/>
+    <p:sldId id="408" r:id="rId12"/>
+    <p:sldId id="405" r:id="rId13"/>
+    <p:sldId id="404" r:id="rId14"/>
+    <p:sldId id="403" r:id="rId15"/>
+    <p:sldId id="400" r:id="rId16"/>
+    <p:sldId id="402" r:id="rId17"/>
+    <p:sldId id="401" r:id="rId18"/>
+    <p:sldId id="399" r:id="rId19"/>
+    <p:sldId id="397" r:id="rId20"/>
+    <p:sldId id="344" r:id="rId21"/>
+    <p:sldId id="396" r:id="rId22"/>
   </p:sldIdLst>
   <p:sldSz cx="9144000" cy="6858000" type="screen4x3"/>
   <p:notesSz cx="6858000" cy="9144000"/>
@@ -226,7 +228,7 @@
           <a:p>
             <a:fld id="{A17B1792-3256-4E77-8442-3E205CD69EF5}" type="datetimeFigureOut">
               <a:rPr lang="en-US" smtClean="0"/>
-              <a:t>7/5/2021</a:t>
+              <a:t>11/1/2021</a:t>
             </a:fld>
             <a:endParaRPr lang="en-US"/>
           </a:p>
@@ -672,7 +674,7 @@
           <a:p>
             <a:fld id="{07558649-2619-44F9-8F30-2D6466E57529}" type="datetimeFigureOut">
               <a:rPr lang="en-US" smtClean="0"/>
-              <a:t>7/5/2021</a:t>
+              <a:t>11/1/2021</a:t>
             </a:fld>
             <a:endParaRPr lang="en-US"/>
           </a:p>
@@ -840,7 +842,7 @@
           <a:p>
             <a:fld id="{07558649-2619-44F9-8F30-2D6466E57529}" type="datetimeFigureOut">
               <a:rPr lang="en-US" smtClean="0"/>
-              <a:t>7/5/2021</a:t>
+              <a:t>11/1/2021</a:t>
             </a:fld>
             <a:endParaRPr lang="en-US"/>
           </a:p>
@@ -1018,7 +1020,7 @@
           <a:p>
             <a:fld id="{07558649-2619-44F9-8F30-2D6466E57529}" type="datetimeFigureOut">
               <a:rPr lang="en-US" smtClean="0"/>
-              <a:t>7/5/2021</a:t>
+              <a:t>11/1/2021</a:t>
             </a:fld>
             <a:endParaRPr lang="en-US"/>
           </a:p>
@@ -1186,7 +1188,7 @@
           <a:p>
             <a:fld id="{07558649-2619-44F9-8F30-2D6466E57529}" type="datetimeFigureOut">
               <a:rPr lang="en-US" smtClean="0"/>
-              <a:t>7/5/2021</a:t>
+              <a:t>11/1/2021</a:t>
             </a:fld>
             <a:endParaRPr lang="en-US"/>
           </a:p>
@@ -1431,7 +1433,7 @@
           <a:p>
             <a:fld id="{07558649-2619-44F9-8F30-2D6466E57529}" type="datetimeFigureOut">
               <a:rPr lang="en-US" smtClean="0"/>
-              <a:t>7/5/2021</a:t>
+              <a:t>11/1/2021</a:t>
             </a:fld>
             <a:endParaRPr lang="en-US"/>
           </a:p>
@@ -1716,7 +1718,7 @@
           <a:p>
             <a:fld id="{07558649-2619-44F9-8F30-2D6466E57529}" type="datetimeFigureOut">
               <a:rPr lang="en-US" smtClean="0"/>
-              <a:t>7/5/2021</a:t>
+              <a:t>11/1/2021</a:t>
             </a:fld>
             <a:endParaRPr lang="en-US"/>
           </a:p>
@@ -2135,7 +2137,7 @@
           <a:p>
             <a:fld id="{07558649-2619-44F9-8F30-2D6466E57529}" type="datetimeFigureOut">
               <a:rPr lang="en-US" smtClean="0"/>
-              <a:t>7/5/2021</a:t>
+              <a:t>11/1/2021</a:t>
             </a:fld>
             <a:endParaRPr lang="en-US"/>
           </a:p>
@@ -2252,7 +2254,7 @@
           <a:p>
             <a:fld id="{07558649-2619-44F9-8F30-2D6466E57529}" type="datetimeFigureOut">
               <a:rPr lang="en-US" smtClean="0"/>
-              <a:t>7/5/2021</a:t>
+              <a:t>11/1/2021</a:t>
             </a:fld>
             <a:endParaRPr lang="en-US"/>
           </a:p>
@@ -2347,7 +2349,7 @@
           <a:p>
             <a:fld id="{07558649-2619-44F9-8F30-2D6466E57529}" type="datetimeFigureOut">
               <a:rPr lang="en-US" smtClean="0"/>
-              <a:t>7/5/2021</a:t>
+              <a:t>11/1/2021</a:t>
             </a:fld>
             <a:endParaRPr lang="en-US"/>
           </a:p>
@@ -2622,7 +2624,7 @@
           <a:p>
             <a:fld id="{07558649-2619-44F9-8F30-2D6466E57529}" type="datetimeFigureOut">
               <a:rPr lang="en-US" smtClean="0"/>
-              <a:t>7/5/2021</a:t>
+              <a:t>11/1/2021</a:t>
             </a:fld>
             <a:endParaRPr lang="en-US"/>
           </a:p>
@@ -2874,7 +2876,7 @@
           <a:p>
             <a:fld id="{07558649-2619-44F9-8F30-2D6466E57529}" type="datetimeFigureOut">
               <a:rPr lang="en-US" smtClean="0"/>
-              <a:t>7/5/2021</a:t>
+              <a:t>11/1/2021</a:t>
             </a:fld>
             <a:endParaRPr lang="en-US"/>
           </a:p>
@@ -3094,7 +3096,7 @@
           <a:p>
             <a:fld id="{07558649-2619-44F9-8F30-2D6466E57529}" type="datetimeFigureOut">
               <a:rPr lang="en-US" smtClean="0"/>
-              <a:t>7/5/2021</a:t>
+              <a:t>11/1/2021</a:t>
             </a:fld>
             <a:endParaRPr lang="en-US"/>
           </a:p>
@@ -3511,7 +3513,7 @@
               <a:rPr lang="es-MX" b="1" dirty="0">
                 <a:latin typeface="Century Gothic" panose="020B0502020202020204" pitchFamily="34" charset="0"/>
               </a:rPr>
-              <a:t>28/06/2021 – 05/07/2021</a:t>
+              <a:t>25/10/2021 – 29/10/2021</a:t>
             </a:r>
             <a:endParaRPr lang="es-MX" dirty="0">
               <a:latin typeface="Century Gothic" panose="020B0502020202020204" pitchFamily="34" charset="0"/>
@@ -3551,6 +3553,720 @@
       </p:grpSpPr>
       <p:sp>
         <p:nvSpPr>
+          <p:cNvPr id="8" name="Title 1"/>
+          <p:cNvSpPr txBox="1">
+            <a:spLocks/>
+          </p:cNvSpPr>
+          <p:nvPr/>
+        </p:nvSpPr>
+        <p:spPr>
+          <a:xfrm>
+            <a:off x="1087408" y="274638"/>
+            <a:ext cx="7229008" cy="634082"/>
+          </a:xfrm>
+          <a:prstGeom prst="rect">
+            <a:avLst/>
+          </a:prstGeom>
+        </p:spPr>
+        <p:txBody>
+          <a:bodyPr/>
+          <a:lstStyle>
+            <a:lvl1pPr algn="ctr" defTabSz="914400" rtl="0" eaLnBrk="1" latinLnBrk="0" hangingPunct="1">
+              <a:spcBef>
+                <a:spcPct val="0"/>
+              </a:spcBef>
+              <a:buNone/>
+              <a:defRPr sz="4400" kern="1200">
+                <a:solidFill>
+                  <a:schemeClr val="tx1"/>
+                </a:solidFill>
+                <a:latin typeface="+mj-lt"/>
+                <a:ea typeface="+mj-ea"/>
+                <a:cs typeface="+mj-cs"/>
+              </a:defRPr>
+            </a:lvl1pPr>
+          </a:lstStyle>
+          <a:p>
+            <a:pPr algn="l"/>
+            <a:r>
+              <a:rPr lang="es-ES" sz="2000" dirty="0">
+                <a:solidFill>
+                  <a:srgbClr val="3F1900"/>
+                </a:solidFill>
+              </a:rPr>
+              <a:t>Estación de Devolución de Pieles.</a:t>
+            </a:r>
+            <a:endParaRPr lang="en-US" sz="2000" dirty="0">
+              <a:solidFill>
+                <a:srgbClr val="3F1900"/>
+              </a:solidFill>
+            </a:endParaRPr>
+          </a:p>
+        </p:txBody>
+      </p:sp>
+      <p:sp>
+        <p:nvSpPr>
+          <p:cNvPr id="4" name="Content Placeholder 3"/>
+          <p:cNvSpPr txBox="1">
+            <a:spLocks/>
+          </p:cNvSpPr>
+          <p:nvPr/>
+        </p:nvSpPr>
+        <p:spPr>
+          <a:xfrm>
+            <a:off x="1331640" y="1196753"/>
+            <a:ext cx="7488832" cy="5137780"/>
+          </a:xfrm>
+          <a:prstGeom prst="rect">
+            <a:avLst/>
+          </a:prstGeom>
+        </p:spPr>
+        <p:txBody>
+          <a:bodyPr>
+            <a:normAutofit/>
+          </a:bodyPr>
+          <a:lstStyle>
+            <a:lvl1pPr marL="342900" indent="-342900" algn="l" defTabSz="914400" rtl="0" eaLnBrk="1" latinLnBrk="0" hangingPunct="1">
+              <a:spcBef>
+                <a:spcPct val="20000"/>
+              </a:spcBef>
+              <a:buFont typeface="Arial" panose="020B0604020202020204" pitchFamily="34" charset="0"/>
+              <a:buChar char="•"/>
+              <a:defRPr sz="3200" kern="1200">
+                <a:solidFill>
+                  <a:schemeClr val="tx1"/>
+                </a:solidFill>
+                <a:latin typeface="+mn-lt"/>
+                <a:ea typeface="+mn-ea"/>
+                <a:cs typeface="+mn-cs"/>
+              </a:defRPr>
+            </a:lvl1pPr>
+            <a:lvl2pPr marL="742950" indent="-285750" algn="l" defTabSz="914400" rtl="0" eaLnBrk="1" latinLnBrk="0" hangingPunct="1">
+              <a:spcBef>
+                <a:spcPct val="20000"/>
+              </a:spcBef>
+              <a:buFont typeface="Arial" panose="020B0604020202020204" pitchFamily="34" charset="0"/>
+              <a:buChar char="–"/>
+              <a:defRPr sz="2800" kern="1200">
+                <a:solidFill>
+                  <a:schemeClr val="tx1"/>
+                </a:solidFill>
+                <a:latin typeface="+mn-lt"/>
+                <a:ea typeface="+mn-ea"/>
+                <a:cs typeface="+mn-cs"/>
+              </a:defRPr>
+            </a:lvl2pPr>
+            <a:lvl3pPr marL="1143000" indent="-228600" algn="l" defTabSz="914400" rtl="0" eaLnBrk="1" latinLnBrk="0" hangingPunct="1">
+              <a:spcBef>
+                <a:spcPct val="20000"/>
+              </a:spcBef>
+              <a:buFont typeface="Arial" panose="020B0604020202020204" pitchFamily="34" charset="0"/>
+              <a:buChar char="•"/>
+              <a:defRPr sz="2400" kern="1200">
+                <a:solidFill>
+                  <a:schemeClr val="tx1"/>
+                </a:solidFill>
+                <a:latin typeface="+mn-lt"/>
+                <a:ea typeface="+mn-ea"/>
+                <a:cs typeface="+mn-cs"/>
+              </a:defRPr>
+            </a:lvl3pPr>
+            <a:lvl4pPr marL="1600200" indent="-228600" algn="l" defTabSz="914400" rtl="0" eaLnBrk="1" latinLnBrk="0" hangingPunct="1">
+              <a:spcBef>
+                <a:spcPct val="20000"/>
+              </a:spcBef>
+              <a:buFont typeface="Arial" panose="020B0604020202020204" pitchFamily="34" charset="0"/>
+              <a:buChar char="–"/>
+              <a:defRPr sz="2000" kern="1200">
+                <a:solidFill>
+                  <a:schemeClr val="tx1"/>
+                </a:solidFill>
+                <a:latin typeface="+mn-lt"/>
+                <a:ea typeface="+mn-ea"/>
+                <a:cs typeface="+mn-cs"/>
+              </a:defRPr>
+            </a:lvl4pPr>
+            <a:lvl5pPr marL="2057400" indent="-228600" algn="l" defTabSz="914400" rtl="0" eaLnBrk="1" latinLnBrk="0" hangingPunct="1">
+              <a:spcBef>
+                <a:spcPct val="20000"/>
+              </a:spcBef>
+              <a:buFont typeface="Arial" panose="020B0604020202020204" pitchFamily="34" charset="0"/>
+              <a:buChar char="»"/>
+              <a:defRPr sz="2000" kern="1200">
+                <a:solidFill>
+                  <a:schemeClr val="tx1"/>
+                </a:solidFill>
+                <a:latin typeface="+mn-lt"/>
+                <a:ea typeface="+mn-ea"/>
+                <a:cs typeface="+mn-cs"/>
+              </a:defRPr>
+            </a:lvl5pPr>
+            <a:lvl6pPr marL="2514600" indent="-228600" algn="l" defTabSz="914400" rtl="0" eaLnBrk="1" latinLnBrk="0" hangingPunct="1">
+              <a:spcBef>
+                <a:spcPct val="20000"/>
+              </a:spcBef>
+              <a:buFont typeface="Arial" panose="020B0604020202020204" pitchFamily="34" charset="0"/>
+              <a:buChar char="•"/>
+              <a:defRPr sz="2000" kern="1200">
+                <a:solidFill>
+                  <a:schemeClr val="tx1"/>
+                </a:solidFill>
+                <a:latin typeface="+mn-lt"/>
+                <a:ea typeface="+mn-ea"/>
+                <a:cs typeface="+mn-cs"/>
+              </a:defRPr>
+            </a:lvl6pPr>
+            <a:lvl7pPr marL="2971800" indent="-228600" algn="l" defTabSz="914400" rtl="0" eaLnBrk="1" latinLnBrk="0" hangingPunct="1">
+              <a:spcBef>
+                <a:spcPct val="20000"/>
+              </a:spcBef>
+              <a:buFont typeface="Arial" panose="020B0604020202020204" pitchFamily="34" charset="0"/>
+              <a:buChar char="•"/>
+              <a:defRPr sz="2000" kern="1200">
+                <a:solidFill>
+                  <a:schemeClr val="tx1"/>
+                </a:solidFill>
+                <a:latin typeface="+mn-lt"/>
+                <a:ea typeface="+mn-ea"/>
+                <a:cs typeface="+mn-cs"/>
+              </a:defRPr>
+            </a:lvl7pPr>
+            <a:lvl8pPr marL="3429000" indent="-228600" algn="l" defTabSz="914400" rtl="0" eaLnBrk="1" latinLnBrk="0" hangingPunct="1">
+              <a:spcBef>
+                <a:spcPct val="20000"/>
+              </a:spcBef>
+              <a:buFont typeface="Arial" panose="020B0604020202020204" pitchFamily="34" charset="0"/>
+              <a:buChar char="•"/>
+              <a:defRPr sz="2000" kern="1200">
+                <a:solidFill>
+                  <a:schemeClr val="tx1"/>
+                </a:solidFill>
+                <a:latin typeface="+mn-lt"/>
+                <a:ea typeface="+mn-ea"/>
+                <a:cs typeface="+mn-cs"/>
+              </a:defRPr>
+            </a:lvl8pPr>
+            <a:lvl9pPr marL="3886200" indent="-228600" algn="l" defTabSz="914400" rtl="0" eaLnBrk="1" latinLnBrk="0" hangingPunct="1">
+              <a:spcBef>
+                <a:spcPct val="20000"/>
+              </a:spcBef>
+              <a:buFont typeface="Arial" panose="020B0604020202020204" pitchFamily="34" charset="0"/>
+              <a:buChar char="•"/>
+              <a:defRPr sz="2000" kern="1200">
+                <a:solidFill>
+                  <a:schemeClr val="tx1"/>
+                </a:solidFill>
+                <a:latin typeface="+mn-lt"/>
+                <a:ea typeface="+mn-ea"/>
+                <a:cs typeface="+mn-cs"/>
+              </a:defRPr>
+            </a:lvl9pPr>
+          </a:lstStyle>
+          <a:p>
+            <a:pPr marL="0" indent="0" algn="just">
+              <a:buFont typeface="Arial" panose="020B0604020202020204" pitchFamily="34" charset="0"/>
+              <a:buNone/>
+            </a:pPr>
+            <a:endParaRPr lang="en-US" sz="2000" i="1"/>
+          </a:p>
+        </p:txBody>
+      </p:sp>
+      <p:sp>
+        <p:nvSpPr>
+          <p:cNvPr id="10" name="Rectangle 9"/>
+          <p:cNvSpPr/>
+          <p:nvPr/>
+        </p:nvSpPr>
+        <p:spPr>
+          <a:xfrm>
+            <a:off x="1159416" y="980728"/>
+            <a:ext cx="7949088" cy="461665"/>
+          </a:xfrm>
+          <a:prstGeom prst="rect">
+            <a:avLst/>
+          </a:prstGeom>
+        </p:spPr>
+        <p:txBody>
+          <a:bodyPr wrap="square">
+            <a:spAutoFit/>
+          </a:bodyPr>
+          <a:lstStyle/>
+          <a:p>
+            <a:pPr>
+              <a:buFont typeface="Arial" panose="020B0604020202020204" pitchFamily="34" charset="0"/>
+              <a:buChar char="•"/>
+            </a:pPr>
+            <a:r>
+              <a:rPr lang="es-ES" sz="1200" dirty="0">
+                <a:solidFill>
+                  <a:srgbClr val="222222"/>
+                </a:solidFill>
+                <a:latin typeface="Segoe UI" panose="020B0502040204020203" pitchFamily="34" charset="0"/>
+              </a:rPr>
+              <a:t> La pantalla </a:t>
+            </a:r>
+            <a:r>
+              <a:rPr lang="es-ES" sz="1200" b="1" dirty="0">
+                <a:solidFill>
+                  <a:srgbClr val="222222"/>
+                </a:solidFill>
+                <a:latin typeface="Segoe UI" panose="020B0502040204020203" pitchFamily="34" charset="0"/>
+              </a:rPr>
+              <a:t>Devolución de piel </a:t>
+            </a:r>
+            <a:r>
+              <a:rPr lang="es-ES" sz="1200" dirty="0">
+                <a:solidFill>
+                  <a:srgbClr val="222222"/>
+                </a:solidFill>
+                <a:latin typeface="Segoe UI" panose="020B0502040204020203" pitchFamily="34" charset="0"/>
+              </a:rPr>
+              <a:t>primero nos pedirá un Numero de Reloj y Contraseña que se les proporcionara a las personas autorizadas para realizar esta acción.</a:t>
+            </a:r>
+            <a:endParaRPr lang="es-ES" sz="1200" b="0" i="0" dirty="0">
+              <a:solidFill>
+                <a:srgbClr val="222222"/>
+              </a:solidFill>
+              <a:effectLst/>
+              <a:latin typeface="Segoe UI" panose="020B0502040204020203" pitchFamily="34" charset="0"/>
+            </a:endParaRPr>
+          </a:p>
+        </p:txBody>
+      </p:sp>
+      <p:pic>
+        <p:nvPicPr>
+          <p:cNvPr id="6" name="Imagen 5" descr="Interfaz de usuario gráfica, Aplicación&#10;&#10;Descripción generada automáticamente">
+            <a:extLst>
+              <a:ext uri="{FF2B5EF4-FFF2-40B4-BE49-F238E27FC236}">
+                <a16:creationId xmlns:a16="http://schemas.microsoft.com/office/drawing/2014/main" id="{F73ED8AB-5701-420D-9861-9BB0962D8063}"/>
+              </a:ext>
+            </a:extLst>
+          </p:cNvPr>
+          <p:cNvPicPr>
+            <a:picLocks noChangeAspect="1"/>
+          </p:cNvPicPr>
+          <p:nvPr/>
+        </p:nvPicPr>
+        <p:blipFill>
+          <a:blip r:embed="rId2">
+            <a:extLst>
+              <a:ext uri="{28A0092B-C50C-407E-A947-70E740481C1C}">
+                <a14:useLocalDpi xmlns:a14="http://schemas.microsoft.com/office/drawing/2010/main" val="0"/>
+              </a:ext>
+            </a:extLst>
+          </a:blip>
+          <a:stretch>
+            <a:fillRect/>
+          </a:stretch>
+        </p:blipFill>
+        <p:spPr>
+          <a:xfrm>
+            <a:off x="1159416" y="1627059"/>
+            <a:ext cx="7949088" cy="4707474"/>
+          </a:xfrm>
+          <a:prstGeom prst="rect">
+            <a:avLst/>
+          </a:prstGeom>
+        </p:spPr>
+      </p:pic>
+    </p:spTree>
+    <p:extLst>
+      <p:ext uri="{BB962C8B-B14F-4D97-AF65-F5344CB8AC3E}">
+        <p14:creationId xmlns:p14="http://schemas.microsoft.com/office/powerpoint/2010/main" val="1116123231"/>
+      </p:ext>
+    </p:extLst>
+  </p:cSld>
+  <p:clrMapOvr>
+    <a:masterClrMapping/>
+  </p:clrMapOvr>
+</p:sld>
+</file>
+
+<file path=ppt/slides/slide11.xml><?xml version="1.0" encoding="utf-8"?>
+<p:sld xmlns:a="http://schemas.openxmlformats.org/drawingml/2006/main" xmlns:r="http://schemas.openxmlformats.org/officeDocument/2006/relationships" xmlns:p="http://schemas.openxmlformats.org/presentationml/2006/main">
+  <p:cSld>
+    <p:spTree>
+      <p:nvGrpSpPr>
+        <p:cNvPr id="1" name=""/>
+        <p:cNvGrpSpPr/>
+        <p:nvPr/>
+      </p:nvGrpSpPr>
+      <p:grpSpPr>
+        <a:xfrm>
+          <a:off x="0" y="0"/>
+          <a:ext cx="0" cy="0"/>
+          <a:chOff x="0" y="0"/>
+          <a:chExt cx="0" cy="0"/>
+        </a:xfrm>
+      </p:grpSpPr>
+      <p:sp>
+        <p:nvSpPr>
+          <p:cNvPr id="8" name="Title 1"/>
+          <p:cNvSpPr txBox="1">
+            <a:spLocks/>
+          </p:cNvSpPr>
+          <p:nvPr/>
+        </p:nvSpPr>
+        <p:spPr>
+          <a:xfrm>
+            <a:off x="1087408" y="274638"/>
+            <a:ext cx="7229008" cy="634082"/>
+          </a:xfrm>
+          <a:prstGeom prst="rect">
+            <a:avLst/>
+          </a:prstGeom>
+        </p:spPr>
+        <p:txBody>
+          <a:bodyPr/>
+          <a:lstStyle>
+            <a:lvl1pPr algn="ctr" defTabSz="914400" rtl="0" eaLnBrk="1" latinLnBrk="0" hangingPunct="1">
+              <a:spcBef>
+                <a:spcPct val="0"/>
+              </a:spcBef>
+              <a:buNone/>
+              <a:defRPr sz="4400" kern="1200">
+                <a:solidFill>
+                  <a:schemeClr val="tx1"/>
+                </a:solidFill>
+                <a:latin typeface="+mj-lt"/>
+                <a:ea typeface="+mj-ea"/>
+                <a:cs typeface="+mj-cs"/>
+              </a:defRPr>
+            </a:lvl1pPr>
+          </a:lstStyle>
+          <a:p>
+            <a:pPr algn="l"/>
+            <a:r>
+              <a:rPr lang="es-ES" sz="2000" dirty="0">
+                <a:solidFill>
+                  <a:srgbClr val="3F1900"/>
+                </a:solidFill>
+              </a:rPr>
+              <a:t>Estación de Devolución de Pieles.</a:t>
+            </a:r>
+            <a:endParaRPr lang="en-US" sz="2000" dirty="0">
+              <a:solidFill>
+                <a:srgbClr val="3F1900"/>
+              </a:solidFill>
+            </a:endParaRPr>
+          </a:p>
+        </p:txBody>
+      </p:sp>
+      <p:sp>
+        <p:nvSpPr>
+          <p:cNvPr id="4" name="Content Placeholder 3"/>
+          <p:cNvSpPr txBox="1">
+            <a:spLocks/>
+          </p:cNvSpPr>
+          <p:nvPr/>
+        </p:nvSpPr>
+        <p:spPr>
+          <a:xfrm>
+            <a:off x="1331640" y="1196753"/>
+            <a:ext cx="7488832" cy="5137780"/>
+          </a:xfrm>
+          <a:prstGeom prst="rect">
+            <a:avLst/>
+          </a:prstGeom>
+        </p:spPr>
+        <p:txBody>
+          <a:bodyPr>
+            <a:normAutofit/>
+          </a:bodyPr>
+          <a:lstStyle>
+            <a:lvl1pPr marL="342900" indent="-342900" algn="l" defTabSz="914400" rtl="0" eaLnBrk="1" latinLnBrk="0" hangingPunct="1">
+              <a:spcBef>
+                <a:spcPct val="20000"/>
+              </a:spcBef>
+              <a:buFont typeface="Arial" panose="020B0604020202020204" pitchFamily="34" charset="0"/>
+              <a:buChar char="•"/>
+              <a:defRPr sz="3200" kern="1200">
+                <a:solidFill>
+                  <a:schemeClr val="tx1"/>
+                </a:solidFill>
+                <a:latin typeface="+mn-lt"/>
+                <a:ea typeface="+mn-ea"/>
+                <a:cs typeface="+mn-cs"/>
+              </a:defRPr>
+            </a:lvl1pPr>
+            <a:lvl2pPr marL="742950" indent="-285750" algn="l" defTabSz="914400" rtl="0" eaLnBrk="1" latinLnBrk="0" hangingPunct="1">
+              <a:spcBef>
+                <a:spcPct val="20000"/>
+              </a:spcBef>
+              <a:buFont typeface="Arial" panose="020B0604020202020204" pitchFamily="34" charset="0"/>
+              <a:buChar char="–"/>
+              <a:defRPr sz="2800" kern="1200">
+                <a:solidFill>
+                  <a:schemeClr val="tx1"/>
+                </a:solidFill>
+                <a:latin typeface="+mn-lt"/>
+                <a:ea typeface="+mn-ea"/>
+                <a:cs typeface="+mn-cs"/>
+              </a:defRPr>
+            </a:lvl2pPr>
+            <a:lvl3pPr marL="1143000" indent="-228600" algn="l" defTabSz="914400" rtl="0" eaLnBrk="1" latinLnBrk="0" hangingPunct="1">
+              <a:spcBef>
+                <a:spcPct val="20000"/>
+              </a:spcBef>
+              <a:buFont typeface="Arial" panose="020B0604020202020204" pitchFamily="34" charset="0"/>
+              <a:buChar char="•"/>
+              <a:defRPr sz="2400" kern="1200">
+                <a:solidFill>
+                  <a:schemeClr val="tx1"/>
+                </a:solidFill>
+                <a:latin typeface="+mn-lt"/>
+                <a:ea typeface="+mn-ea"/>
+                <a:cs typeface="+mn-cs"/>
+              </a:defRPr>
+            </a:lvl3pPr>
+            <a:lvl4pPr marL="1600200" indent="-228600" algn="l" defTabSz="914400" rtl="0" eaLnBrk="1" latinLnBrk="0" hangingPunct="1">
+              <a:spcBef>
+                <a:spcPct val="20000"/>
+              </a:spcBef>
+              <a:buFont typeface="Arial" panose="020B0604020202020204" pitchFamily="34" charset="0"/>
+              <a:buChar char="–"/>
+              <a:defRPr sz="2000" kern="1200">
+                <a:solidFill>
+                  <a:schemeClr val="tx1"/>
+                </a:solidFill>
+                <a:latin typeface="+mn-lt"/>
+                <a:ea typeface="+mn-ea"/>
+                <a:cs typeface="+mn-cs"/>
+              </a:defRPr>
+            </a:lvl4pPr>
+            <a:lvl5pPr marL="2057400" indent="-228600" algn="l" defTabSz="914400" rtl="0" eaLnBrk="1" latinLnBrk="0" hangingPunct="1">
+              <a:spcBef>
+                <a:spcPct val="20000"/>
+              </a:spcBef>
+              <a:buFont typeface="Arial" panose="020B0604020202020204" pitchFamily="34" charset="0"/>
+              <a:buChar char="»"/>
+              <a:defRPr sz="2000" kern="1200">
+                <a:solidFill>
+                  <a:schemeClr val="tx1"/>
+                </a:solidFill>
+                <a:latin typeface="+mn-lt"/>
+                <a:ea typeface="+mn-ea"/>
+                <a:cs typeface="+mn-cs"/>
+              </a:defRPr>
+            </a:lvl5pPr>
+            <a:lvl6pPr marL="2514600" indent="-228600" algn="l" defTabSz="914400" rtl="0" eaLnBrk="1" latinLnBrk="0" hangingPunct="1">
+              <a:spcBef>
+                <a:spcPct val="20000"/>
+              </a:spcBef>
+              <a:buFont typeface="Arial" panose="020B0604020202020204" pitchFamily="34" charset="0"/>
+              <a:buChar char="•"/>
+              <a:defRPr sz="2000" kern="1200">
+                <a:solidFill>
+                  <a:schemeClr val="tx1"/>
+                </a:solidFill>
+                <a:latin typeface="+mn-lt"/>
+                <a:ea typeface="+mn-ea"/>
+                <a:cs typeface="+mn-cs"/>
+              </a:defRPr>
+            </a:lvl6pPr>
+            <a:lvl7pPr marL="2971800" indent="-228600" algn="l" defTabSz="914400" rtl="0" eaLnBrk="1" latinLnBrk="0" hangingPunct="1">
+              <a:spcBef>
+                <a:spcPct val="20000"/>
+              </a:spcBef>
+              <a:buFont typeface="Arial" panose="020B0604020202020204" pitchFamily="34" charset="0"/>
+              <a:buChar char="•"/>
+              <a:defRPr sz="2000" kern="1200">
+                <a:solidFill>
+                  <a:schemeClr val="tx1"/>
+                </a:solidFill>
+                <a:latin typeface="+mn-lt"/>
+                <a:ea typeface="+mn-ea"/>
+                <a:cs typeface="+mn-cs"/>
+              </a:defRPr>
+            </a:lvl7pPr>
+            <a:lvl8pPr marL="3429000" indent="-228600" algn="l" defTabSz="914400" rtl="0" eaLnBrk="1" latinLnBrk="0" hangingPunct="1">
+              <a:spcBef>
+                <a:spcPct val="20000"/>
+              </a:spcBef>
+              <a:buFont typeface="Arial" panose="020B0604020202020204" pitchFamily="34" charset="0"/>
+              <a:buChar char="•"/>
+              <a:defRPr sz="2000" kern="1200">
+                <a:solidFill>
+                  <a:schemeClr val="tx1"/>
+                </a:solidFill>
+                <a:latin typeface="+mn-lt"/>
+                <a:ea typeface="+mn-ea"/>
+                <a:cs typeface="+mn-cs"/>
+              </a:defRPr>
+            </a:lvl8pPr>
+            <a:lvl9pPr marL="3886200" indent="-228600" algn="l" defTabSz="914400" rtl="0" eaLnBrk="1" latinLnBrk="0" hangingPunct="1">
+              <a:spcBef>
+                <a:spcPct val="20000"/>
+              </a:spcBef>
+              <a:buFont typeface="Arial" panose="020B0604020202020204" pitchFamily="34" charset="0"/>
+              <a:buChar char="•"/>
+              <a:defRPr sz="2000" kern="1200">
+                <a:solidFill>
+                  <a:schemeClr val="tx1"/>
+                </a:solidFill>
+                <a:latin typeface="+mn-lt"/>
+                <a:ea typeface="+mn-ea"/>
+                <a:cs typeface="+mn-cs"/>
+              </a:defRPr>
+            </a:lvl9pPr>
+          </a:lstStyle>
+          <a:p>
+            <a:pPr marL="0" indent="0" algn="just">
+              <a:buFont typeface="Arial" panose="020B0604020202020204" pitchFamily="34" charset="0"/>
+              <a:buNone/>
+            </a:pPr>
+            <a:endParaRPr lang="en-US" sz="2000" i="1"/>
+          </a:p>
+        </p:txBody>
+      </p:sp>
+      <p:sp>
+        <p:nvSpPr>
+          <p:cNvPr id="10" name="Rectangle 9"/>
+          <p:cNvSpPr/>
+          <p:nvPr/>
+        </p:nvSpPr>
+        <p:spPr>
+          <a:xfrm>
+            <a:off x="1159416" y="980728"/>
+            <a:ext cx="7949088" cy="646331"/>
+          </a:xfrm>
+          <a:prstGeom prst="rect">
+            <a:avLst/>
+          </a:prstGeom>
+        </p:spPr>
+        <p:txBody>
+          <a:bodyPr wrap="square">
+            <a:spAutoFit/>
+          </a:bodyPr>
+          <a:lstStyle/>
+          <a:p>
+            <a:pPr>
+              <a:buFont typeface="Arial" panose="020B0604020202020204" pitchFamily="34" charset="0"/>
+              <a:buChar char="•"/>
+            </a:pPr>
+            <a:r>
+              <a:rPr lang="es-ES" sz="1200" dirty="0">
+                <a:solidFill>
+                  <a:srgbClr val="222222"/>
+                </a:solidFill>
+                <a:latin typeface="Segoe UI" panose="020B0502040204020203" pitchFamily="34" charset="0"/>
+              </a:rPr>
+              <a:t> Si los datos capturados en la pantalla anterior son correctos se mostraran las pieles disponibles en el folio para devolución, nota: </a:t>
+            </a:r>
+            <a:r>
+              <a:rPr lang="es-ES" sz="1200" b="1" dirty="0">
+                <a:solidFill>
+                  <a:srgbClr val="222222"/>
+                </a:solidFill>
+                <a:latin typeface="Segoe UI" panose="020B0502040204020203" pitchFamily="34" charset="0"/>
+              </a:rPr>
+              <a:t>si las pieles ya están cortadas completas no estarán disponibles para devolución</a:t>
+            </a:r>
+            <a:r>
+              <a:rPr lang="es-ES" sz="1200" dirty="0">
+                <a:solidFill>
+                  <a:srgbClr val="222222"/>
+                </a:solidFill>
+                <a:latin typeface="Segoe UI" panose="020B0502040204020203" pitchFamily="34" charset="0"/>
+              </a:rPr>
+              <a:t>, para marcar la piel para devolución solo tiene que presionar la tecla (</a:t>
+            </a:r>
+            <a:r>
+              <a:rPr lang="es-ES" sz="1200" b="1" dirty="0">
+                <a:solidFill>
+                  <a:srgbClr val="222222"/>
+                </a:solidFill>
+                <a:latin typeface="Segoe UI" panose="020B0502040204020203" pitchFamily="34" charset="0"/>
+              </a:rPr>
+              <a:t>Espaciadora</a:t>
+            </a:r>
+            <a:r>
+              <a:rPr lang="es-ES" sz="1200" dirty="0">
+                <a:solidFill>
+                  <a:srgbClr val="222222"/>
+                </a:solidFill>
+                <a:latin typeface="Segoe UI" panose="020B0502040204020203" pitchFamily="34" charset="0"/>
+              </a:rPr>
+              <a:t>).</a:t>
+            </a:r>
+            <a:endParaRPr lang="es-ES" sz="1200" b="0" i="0" dirty="0">
+              <a:solidFill>
+                <a:srgbClr val="222222"/>
+              </a:solidFill>
+              <a:effectLst/>
+              <a:latin typeface="Segoe UI" panose="020B0502040204020203" pitchFamily="34" charset="0"/>
+            </a:endParaRPr>
+          </a:p>
+        </p:txBody>
+      </p:sp>
+      <p:pic>
+        <p:nvPicPr>
+          <p:cNvPr id="3" name="Imagen 2" descr="Interfaz de usuario gráfica, Aplicación, Word&#10;&#10;Descripción generada automáticamente">
+            <a:extLst>
+              <a:ext uri="{FF2B5EF4-FFF2-40B4-BE49-F238E27FC236}">
+                <a16:creationId xmlns:a16="http://schemas.microsoft.com/office/drawing/2014/main" id="{C81FC5EE-0741-41A7-A947-7DA92E9F3FD6}"/>
+              </a:ext>
+            </a:extLst>
+          </p:cNvPr>
+          <p:cNvPicPr>
+            <a:picLocks noChangeAspect="1"/>
+          </p:cNvPicPr>
+          <p:nvPr/>
+        </p:nvPicPr>
+        <p:blipFill>
+          <a:blip r:embed="rId2">
+            <a:extLst>
+              <a:ext uri="{28A0092B-C50C-407E-A947-70E740481C1C}">
+                <a14:useLocalDpi xmlns:a14="http://schemas.microsoft.com/office/drawing/2010/main" val="0"/>
+              </a:ext>
+            </a:extLst>
+          </a:blip>
+          <a:stretch>
+            <a:fillRect/>
+          </a:stretch>
+        </p:blipFill>
+        <p:spPr>
+          <a:xfrm>
+            <a:off x="1159416" y="1627058"/>
+            <a:ext cx="7949088" cy="5186317"/>
+          </a:xfrm>
+          <a:prstGeom prst="rect">
+            <a:avLst/>
+          </a:prstGeom>
+        </p:spPr>
+      </p:pic>
+    </p:spTree>
+    <p:extLst>
+      <p:ext uri="{BB962C8B-B14F-4D97-AF65-F5344CB8AC3E}">
+        <p14:creationId xmlns:p14="http://schemas.microsoft.com/office/powerpoint/2010/main" val="287871341"/>
+      </p:ext>
+    </p:extLst>
+  </p:cSld>
+  <p:clrMapOvr>
+    <a:masterClrMapping/>
+  </p:clrMapOvr>
+</p:sld>
+</file>
+
+<file path=ppt/slides/slide12.xml><?xml version="1.0" encoding="utf-8"?>
+<p:sld xmlns:a="http://schemas.openxmlformats.org/drawingml/2006/main" xmlns:r="http://schemas.openxmlformats.org/officeDocument/2006/relationships" xmlns:p="http://schemas.openxmlformats.org/presentationml/2006/main">
+  <p:cSld>
+    <p:spTree>
+      <p:nvGrpSpPr>
+        <p:cNvPr id="1" name=""/>
+        <p:cNvGrpSpPr/>
+        <p:nvPr/>
+      </p:nvGrpSpPr>
+      <p:grpSpPr>
+        <a:xfrm>
+          <a:off x="0" y="0"/>
+          <a:ext cx="0" cy="0"/>
+          <a:chOff x="0" y="0"/>
+          <a:chExt cx="0" cy="0"/>
+        </a:xfrm>
+      </p:grpSpPr>
+      <p:sp>
+        <p:nvSpPr>
           <p:cNvPr id="5" name="Title 1"/>
           <p:cNvSpPr txBox="1">
             <a:spLocks/>
@@ -3612,7 +4328,7 @@
 </p:sld>
 </file>
 
-<file path=ppt/slides/slide11.xml><?xml version="1.0" encoding="utf-8"?>
+<file path=ppt/slides/slide13.xml><?xml version="1.0" encoding="utf-8"?>
 <p:sld xmlns:a="http://schemas.openxmlformats.org/drawingml/2006/main" xmlns:r="http://schemas.openxmlformats.org/officeDocument/2006/relationships" xmlns:p="http://schemas.openxmlformats.org/presentationml/2006/main">
   <p:cSld>
     <p:spTree>
@@ -4616,7 +5332,7 @@
 </p:sld>
 </file>
 
-<file path=ppt/slides/slide12.xml><?xml version="1.0" encoding="utf-8"?>
+<file path=ppt/slides/slide14.xml><?xml version="1.0" encoding="utf-8"?>
 <p:sld xmlns:a="http://schemas.openxmlformats.org/drawingml/2006/main" xmlns:r="http://schemas.openxmlformats.org/officeDocument/2006/relationships" xmlns:p="http://schemas.openxmlformats.org/presentationml/2006/main">
   <p:cSld>
     <p:spTree>
@@ -4696,7 +5412,7 @@
 </p:sld>
 </file>
 
-<file path=ppt/slides/slide13.xml><?xml version="1.0" encoding="utf-8"?>
+<file path=ppt/slides/slide15.xml><?xml version="1.0" encoding="utf-8"?>
 <p:sld xmlns:a="http://schemas.openxmlformats.org/drawingml/2006/main" xmlns:r="http://schemas.openxmlformats.org/officeDocument/2006/relationships" xmlns:p="http://schemas.openxmlformats.org/presentationml/2006/main">
   <p:cSld>
     <p:spTree>
@@ -5352,7 +6068,7 @@
 </p:sld>
 </file>
 
-<file path=ppt/slides/slide14.xml><?xml version="1.0" encoding="utf-8"?>
+<file path=ppt/slides/slide16.xml><?xml version="1.0" encoding="utf-8"?>
 <p:sld xmlns:a="http://schemas.openxmlformats.org/drawingml/2006/main" xmlns:r="http://schemas.openxmlformats.org/officeDocument/2006/relationships" xmlns:p="http://schemas.openxmlformats.org/presentationml/2006/main">
   <p:cSld>
     <p:spTree>
@@ -5685,7 +6401,7 @@
 </p:sld>
 </file>
 
-<file path=ppt/slides/slide15.xml><?xml version="1.0" encoding="utf-8"?>
+<file path=ppt/slides/slide17.xml><?xml version="1.0" encoding="utf-8"?>
 <p:sld xmlns:a="http://schemas.openxmlformats.org/drawingml/2006/main" xmlns:r="http://schemas.openxmlformats.org/officeDocument/2006/relationships" xmlns:p="http://schemas.openxmlformats.org/presentationml/2006/main">
   <p:cSld>
     <p:spTree>
@@ -6095,7 +6811,7 @@
 </p:sld>
 </file>
 
-<file path=ppt/slides/slide16.xml><?xml version="1.0" encoding="utf-8"?>
+<file path=ppt/slides/slide18.xml><?xml version="1.0" encoding="utf-8"?>
 <p:sld xmlns:a="http://schemas.openxmlformats.org/drawingml/2006/main" xmlns:r="http://schemas.openxmlformats.org/officeDocument/2006/relationships" xmlns:p="http://schemas.openxmlformats.org/presentationml/2006/main">
   <p:cSld>
     <p:spTree>
@@ -6175,7 +6891,7 @@
 </p:sld>
 </file>
 
-<file path=ppt/slides/slide17.xml><?xml version="1.0" encoding="utf-8"?>
+<file path=ppt/slides/slide19.xml><?xml version="1.0" encoding="utf-8"?>
 <p:sld xmlns:a="http://schemas.openxmlformats.org/drawingml/2006/main" xmlns:r="http://schemas.openxmlformats.org/officeDocument/2006/relationships" xmlns:p="http://schemas.openxmlformats.org/presentationml/2006/main">
   <p:cSld>
     <p:spTree>
@@ -6541,7 +7257,7 @@
 </p:sld>
 </file>
 
-<file path=ppt/slides/slide18.xml><?xml version="1.0" encoding="utf-8"?>
+<file path=ppt/slides/slide2.xml><?xml version="1.0" encoding="utf-8"?>
 <p:sld xmlns:a="http://schemas.openxmlformats.org/drawingml/2006/main" xmlns:r="http://schemas.openxmlformats.org/officeDocument/2006/relationships" xmlns:p="http://schemas.openxmlformats.org/presentationml/2006/main">
   <p:cSld>
     <p:spTree>
@@ -6560,6 +7276,737 @@
       </p:grpSpPr>
       <p:sp>
         <p:nvSpPr>
+          <p:cNvPr id="8" name="Title 1"/>
+          <p:cNvSpPr txBox="1">
+            <a:spLocks/>
+          </p:cNvSpPr>
+          <p:nvPr/>
+        </p:nvSpPr>
+        <p:spPr>
+          <a:xfrm>
+            <a:off x="1087408" y="274638"/>
+            <a:ext cx="7229008" cy="634082"/>
+          </a:xfrm>
+          <a:prstGeom prst="rect">
+            <a:avLst/>
+          </a:prstGeom>
+        </p:spPr>
+        <p:txBody>
+          <a:bodyPr/>
+          <a:lstStyle>
+            <a:lvl1pPr algn="ctr" defTabSz="914400" rtl="0" eaLnBrk="1" latinLnBrk="0" hangingPunct="1">
+              <a:spcBef>
+                <a:spcPct val="0"/>
+              </a:spcBef>
+              <a:buNone/>
+              <a:defRPr sz="4400" kern="1200">
+                <a:solidFill>
+                  <a:schemeClr val="tx1"/>
+                </a:solidFill>
+                <a:latin typeface="+mj-lt"/>
+                <a:ea typeface="+mj-ea"/>
+                <a:cs typeface="+mj-cs"/>
+              </a:defRPr>
+            </a:lvl1pPr>
+          </a:lstStyle>
+          <a:p>
+            <a:pPr algn="l"/>
+            <a:r>
+              <a:rPr lang="es-ES" sz="2000" dirty="0">
+                <a:solidFill>
+                  <a:srgbClr val="3F1900"/>
+                </a:solidFill>
+              </a:rPr>
+              <a:t>Transferencia de Folio Controlado.</a:t>
+            </a:r>
+            <a:endParaRPr lang="en-US" sz="2000" dirty="0">
+              <a:solidFill>
+                <a:srgbClr val="3F1900"/>
+              </a:solidFill>
+            </a:endParaRPr>
+          </a:p>
+        </p:txBody>
+      </p:sp>
+      <p:sp>
+        <p:nvSpPr>
+          <p:cNvPr id="4" name="Content Placeholder 3"/>
+          <p:cNvSpPr txBox="1">
+            <a:spLocks/>
+          </p:cNvSpPr>
+          <p:nvPr/>
+        </p:nvSpPr>
+        <p:spPr>
+          <a:xfrm>
+            <a:off x="1331640" y="1196753"/>
+            <a:ext cx="7488832" cy="5137780"/>
+          </a:xfrm>
+          <a:prstGeom prst="rect">
+            <a:avLst/>
+          </a:prstGeom>
+        </p:spPr>
+        <p:txBody>
+          <a:bodyPr>
+            <a:normAutofit/>
+          </a:bodyPr>
+          <a:lstStyle>
+            <a:lvl1pPr marL="342900" indent="-342900" algn="l" defTabSz="914400" rtl="0" eaLnBrk="1" latinLnBrk="0" hangingPunct="1">
+              <a:spcBef>
+                <a:spcPct val="20000"/>
+              </a:spcBef>
+              <a:buFont typeface="Arial" panose="020B0604020202020204" pitchFamily="34" charset="0"/>
+              <a:buChar char="•"/>
+              <a:defRPr sz="3200" kern="1200">
+                <a:solidFill>
+                  <a:schemeClr val="tx1"/>
+                </a:solidFill>
+                <a:latin typeface="+mn-lt"/>
+                <a:ea typeface="+mn-ea"/>
+                <a:cs typeface="+mn-cs"/>
+              </a:defRPr>
+            </a:lvl1pPr>
+            <a:lvl2pPr marL="742950" indent="-285750" algn="l" defTabSz="914400" rtl="0" eaLnBrk="1" latinLnBrk="0" hangingPunct="1">
+              <a:spcBef>
+                <a:spcPct val="20000"/>
+              </a:spcBef>
+              <a:buFont typeface="Arial" panose="020B0604020202020204" pitchFamily="34" charset="0"/>
+              <a:buChar char="–"/>
+              <a:defRPr sz="2800" kern="1200">
+                <a:solidFill>
+                  <a:schemeClr val="tx1"/>
+                </a:solidFill>
+                <a:latin typeface="+mn-lt"/>
+                <a:ea typeface="+mn-ea"/>
+                <a:cs typeface="+mn-cs"/>
+              </a:defRPr>
+            </a:lvl2pPr>
+            <a:lvl3pPr marL="1143000" indent="-228600" algn="l" defTabSz="914400" rtl="0" eaLnBrk="1" latinLnBrk="0" hangingPunct="1">
+              <a:spcBef>
+                <a:spcPct val="20000"/>
+              </a:spcBef>
+              <a:buFont typeface="Arial" panose="020B0604020202020204" pitchFamily="34" charset="0"/>
+              <a:buChar char="•"/>
+              <a:defRPr sz="2400" kern="1200">
+                <a:solidFill>
+                  <a:schemeClr val="tx1"/>
+                </a:solidFill>
+                <a:latin typeface="+mn-lt"/>
+                <a:ea typeface="+mn-ea"/>
+                <a:cs typeface="+mn-cs"/>
+              </a:defRPr>
+            </a:lvl3pPr>
+            <a:lvl4pPr marL="1600200" indent="-228600" algn="l" defTabSz="914400" rtl="0" eaLnBrk="1" latinLnBrk="0" hangingPunct="1">
+              <a:spcBef>
+                <a:spcPct val="20000"/>
+              </a:spcBef>
+              <a:buFont typeface="Arial" panose="020B0604020202020204" pitchFamily="34" charset="0"/>
+              <a:buChar char="–"/>
+              <a:defRPr sz="2000" kern="1200">
+                <a:solidFill>
+                  <a:schemeClr val="tx1"/>
+                </a:solidFill>
+                <a:latin typeface="+mn-lt"/>
+                <a:ea typeface="+mn-ea"/>
+                <a:cs typeface="+mn-cs"/>
+              </a:defRPr>
+            </a:lvl4pPr>
+            <a:lvl5pPr marL="2057400" indent="-228600" algn="l" defTabSz="914400" rtl="0" eaLnBrk="1" latinLnBrk="0" hangingPunct="1">
+              <a:spcBef>
+                <a:spcPct val="20000"/>
+              </a:spcBef>
+              <a:buFont typeface="Arial" panose="020B0604020202020204" pitchFamily="34" charset="0"/>
+              <a:buChar char="»"/>
+              <a:defRPr sz="2000" kern="1200">
+                <a:solidFill>
+                  <a:schemeClr val="tx1"/>
+                </a:solidFill>
+                <a:latin typeface="+mn-lt"/>
+                <a:ea typeface="+mn-ea"/>
+                <a:cs typeface="+mn-cs"/>
+              </a:defRPr>
+            </a:lvl5pPr>
+            <a:lvl6pPr marL="2514600" indent="-228600" algn="l" defTabSz="914400" rtl="0" eaLnBrk="1" latinLnBrk="0" hangingPunct="1">
+              <a:spcBef>
+                <a:spcPct val="20000"/>
+              </a:spcBef>
+              <a:buFont typeface="Arial" panose="020B0604020202020204" pitchFamily="34" charset="0"/>
+              <a:buChar char="•"/>
+              <a:defRPr sz="2000" kern="1200">
+                <a:solidFill>
+                  <a:schemeClr val="tx1"/>
+                </a:solidFill>
+                <a:latin typeface="+mn-lt"/>
+                <a:ea typeface="+mn-ea"/>
+                <a:cs typeface="+mn-cs"/>
+              </a:defRPr>
+            </a:lvl6pPr>
+            <a:lvl7pPr marL="2971800" indent="-228600" algn="l" defTabSz="914400" rtl="0" eaLnBrk="1" latinLnBrk="0" hangingPunct="1">
+              <a:spcBef>
+                <a:spcPct val="20000"/>
+              </a:spcBef>
+              <a:buFont typeface="Arial" panose="020B0604020202020204" pitchFamily="34" charset="0"/>
+              <a:buChar char="•"/>
+              <a:defRPr sz="2000" kern="1200">
+                <a:solidFill>
+                  <a:schemeClr val="tx1"/>
+                </a:solidFill>
+                <a:latin typeface="+mn-lt"/>
+                <a:ea typeface="+mn-ea"/>
+                <a:cs typeface="+mn-cs"/>
+              </a:defRPr>
+            </a:lvl7pPr>
+            <a:lvl8pPr marL="3429000" indent="-228600" algn="l" defTabSz="914400" rtl="0" eaLnBrk="1" latinLnBrk="0" hangingPunct="1">
+              <a:spcBef>
+                <a:spcPct val="20000"/>
+              </a:spcBef>
+              <a:buFont typeface="Arial" panose="020B0604020202020204" pitchFamily="34" charset="0"/>
+              <a:buChar char="•"/>
+              <a:defRPr sz="2000" kern="1200">
+                <a:solidFill>
+                  <a:schemeClr val="tx1"/>
+                </a:solidFill>
+                <a:latin typeface="+mn-lt"/>
+                <a:ea typeface="+mn-ea"/>
+                <a:cs typeface="+mn-cs"/>
+              </a:defRPr>
+            </a:lvl8pPr>
+            <a:lvl9pPr marL="3886200" indent="-228600" algn="l" defTabSz="914400" rtl="0" eaLnBrk="1" latinLnBrk="0" hangingPunct="1">
+              <a:spcBef>
+                <a:spcPct val="20000"/>
+              </a:spcBef>
+              <a:buFont typeface="Arial" panose="020B0604020202020204" pitchFamily="34" charset="0"/>
+              <a:buChar char="•"/>
+              <a:defRPr sz="2000" kern="1200">
+                <a:solidFill>
+                  <a:schemeClr val="tx1"/>
+                </a:solidFill>
+                <a:latin typeface="+mn-lt"/>
+                <a:ea typeface="+mn-ea"/>
+                <a:cs typeface="+mn-cs"/>
+              </a:defRPr>
+            </a:lvl9pPr>
+          </a:lstStyle>
+          <a:p>
+            <a:pPr marL="0" indent="0" algn="just">
+              <a:buFont typeface="Arial" panose="020B0604020202020204" pitchFamily="34" charset="0"/>
+              <a:buNone/>
+            </a:pPr>
+            <a:endParaRPr lang="en-US" sz="2000" i="1"/>
+          </a:p>
+        </p:txBody>
+      </p:sp>
+      <p:sp>
+        <p:nvSpPr>
+          <p:cNvPr id="10" name="Rectangle 9"/>
+          <p:cNvSpPr/>
+          <p:nvPr/>
+        </p:nvSpPr>
+        <p:spPr>
+          <a:xfrm>
+            <a:off x="1331640" y="980728"/>
+            <a:ext cx="7632848" cy="461665"/>
+          </a:xfrm>
+          <a:prstGeom prst="rect">
+            <a:avLst/>
+          </a:prstGeom>
+        </p:spPr>
+        <p:txBody>
+          <a:bodyPr wrap="square">
+            <a:spAutoFit/>
+          </a:bodyPr>
+          <a:lstStyle/>
+          <a:p>
+            <a:pPr>
+              <a:buFont typeface="Arial" panose="020B0604020202020204" pitchFamily="34" charset="0"/>
+              <a:buChar char="•"/>
+            </a:pPr>
+            <a:r>
+              <a:rPr lang="es-ES" sz="1200" b="0" i="0" dirty="0">
+                <a:solidFill>
+                  <a:srgbClr val="222222"/>
+                </a:solidFill>
+                <a:effectLst/>
+                <a:latin typeface="Segoe UI" panose="020B0502040204020203" pitchFamily="34" charset="0"/>
+              </a:rPr>
+              <a:t> </a:t>
+            </a:r>
+            <a:r>
+              <a:rPr lang="es-ES" sz="1200" dirty="0">
+                <a:solidFill>
+                  <a:srgbClr val="222222"/>
+                </a:solidFill>
+                <a:latin typeface="Segoe UI" panose="020B0502040204020203" pitchFamily="34" charset="0"/>
+              </a:rPr>
+              <a:t>Se </a:t>
+            </a:r>
+            <a:r>
+              <a:rPr lang="en-US" sz="1200" dirty="0" err="1">
+                <a:solidFill>
+                  <a:srgbClr val="222222"/>
+                </a:solidFill>
+                <a:latin typeface="Segoe UI" panose="020B0502040204020203" pitchFamily="34" charset="0"/>
+              </a:rPr>
+              <a:t>modico</a:t>
+            </a:r>
+            <a:r>
+              <a:rPr lang="en-US" sz="1200" dirty="0">
+                <a:solidFill>
+                  <a:srgbClr val="222222"/>
+                </a:solidFill>
+                <a:latin typeface="Segoe UI" panose="020B0502040204020203" pitchFamily="34" charset="0"/>
+              </a:rPr>
+              <a:t> </a:t>
+            </a:r>
+            <a:r>
+              <a:rPr lang="en-US" sz="1200" dirty="0" err="1">
+                <a:solidFill>
+                  <a:srgbClr val="222222"/>
+                </a:solidFill>
+                <a:latin typeface="Segoe UI" panose="020B0502040204020203" pitchFamily="34" charset="0"/>
+              </a:rPr>
+              <a:t>pantalla</a:t>
+            </a:r>
+            <a:r>
+              <a:rPr lang="en-US" sz="1200" dirty="0">
+                <a:solidFill>
+                  <a:srgbClr val="222222"/>
+                </a:solidFill>
+                <a:latin typeface="Segoe UI" panose="020B0502040204020203" pitchFamily="34" charset="0"/>
+              </a:rPr>
+              <a:t> de folios </a:t>
+            </a:r>
+            <a:r>
+              <a:rPr lang="en-US" sz="1200" dirty="0" err="1">
+                <a:solidFill>
+                  <a:srgbClr val="222222"/>
+                </a:solidFill>
+                <a:latin typeface="Segoe UI" panose="020B0502040204020203" pitchFamily="34" charset="0"/>
+              </a:rPr>
+              <a:t>controlados</a:t>
+            </a:r>
+            <a:r>
+              <a:rPr lang="en-US" sz="1200" dirty="0">
+                <a:solidFill>
+                  <a:srgbClr val="222222"/>
+                </a:solidFill>
+                <a:latin typeface="Segoe UI" panose="020B0502040204020203" pitchFamily="34" charset="0"/>
+              </a:rPr>
+              <a:t>, para que </a:t>
+            </a:r>
+            <a:r>
+              <a:rPr lang="en-US" sz="1200" dirty="0" err="1">
+                <a:solidFill>
+                  <a:srgbClr val="222222"/>
+                </a:solidFill>
+                <a:latin typeface="Segoe UI" panose="020B0502040204020203" pitchFamily="34" charset="0"/>
+              </a:rPr>
+              <a:t>cuando</a:t>
+            </a:r>
+            <a:r>
+              <a:rPr lang="en-US" sz="1200" dirty="0">
+                <a:solidFill>
+                  <a:srgbClr val="222222"/>
+                </a:solidFill>
+                <a:latin typeface="Segoe UI" panose="020B0502040204020203" pitchFamily="34" charset="0"/>
+              </a:rPr>
+              <a:t> se </a:t>
+            </a:r>
+            <a:r>
+              <a:rPr lang="en-US" sz="1200" dirty="0" err="1">
+                <a:solidFill>
+                  <a:srgbClr val="222222"/>
+                </a:solidFill>
+                <a:latin typeface="Segoe UI" panose="020B0502040204020203" pitchFamily="34" charset="0"/>
+              </a:rPr>
+              <a:t>transfieran</a:t>
+            </a:r>
+            <a:r>
+              <a:rPr lang="en-US" sz="1200" dirty="0">
+                <a:solidFill>
+                  <a:srgbClr val="222222"/>
+                </a:solidFill>
+                <a:latin typeface="Segoe UI" panose="020B0502040204020203" pitchFamily="34" charset="0"/>
+              </a:rPr>
+              <a:t> </a:t>
+            </a:r>
+            <a:r>
+              <a:rPr lang="en-US" sz="1200" dirty="0" err="1">
+                <a:solidFill>
+                  <a:srgbClr val="222222"/>
+                </a:solidFill>
+                <a:latin typeface="Segoe UI" panose="020B0502040204020203" pitchFamily="34" charset="0"/>
+              </a:rPr>
+              <a:t>pieles</a:t>
+            </a:r>
+            <a:r>
+              <a:rPr lang="en-US" sz="1200" dirty="0">
+                <a:solidFill>
+                  <a:srgbClr val="222222"/>
+                </a:solidFill>
+                <a:latin typeface="Segoe UI" panose="020B0502040204020203" pitchFamily="34" charset="0"/>
+              </a:rPr>
+              <a:t> a la </a:t>
+            </a:r>
+            <a:r>
+              <a:rPr lang="en-US" sz="1200" dirty="0" err="1">
+                <a:solidFill>
+                  <a:srgbClr val="222222"/>
+                </a:solidFill>
+                <a:latin typeface="Segoe UI" panose="020B0502040204020203" pitchFamily="34" charset="0"/>
+              </a:rPr>
+              <a:t>locación</a:t>
+            </a:r>
+            <a:r>
+              <a:rPr lang="en-US" sz="1200" dirty="0">
+                <a:solidFill>
+                  <a:srgbClr val="222222"/>
+                </a:solidFill>
+                <a:latin typeface="Segoe UI" panose="020B0502040204020203" pitchFamily="34" charset="0"/>
+              </a:rPr>
+              <a:t> de MQU se </a:t>
+            </a:r>
+            <a:r>
+              <a:rPr lang="en-US" sz="1200" dirty="0" err="1">
+                <a:solidFill>
+                  <a:srgbClr val="222222"/>
+                </a:solidFill>
+                <a:latin typeface="Segoe UI" panose="020B0502040204020203" pitchFamily="34" charset="0"/>
+              </a:rPr>
+              <a:t>solicite</a:t>
+            </a:r>
+            <a:r>
+              <a:rPr lang="en-US" sz="1200" dirty="0">
+                <a:solidFill>
+                  <a:srgbClr val="222222"/>
+                </a:solidFill>
+                <a:latin typeface="Segoe UI" panose="020B0502040204020203" pitchFamily="34" charset="0"/>
+              </a:rPr>
+              <a:t> por </a:t>
+            </a:r>
+            <a:r>
+              <a:rPr lang="en-US" sz="1200" dirty="0" err="1">
+                <a:solidFill>
+                  <a:srgbClr val="222222"/>
+                </a:solidFill>
+                <a:latin typeface="Segoe UI" panose="020B0502040204020203" pitchFamily="34" charset="0"/>
+              </a:rPr>
+              <a:t>cada</a:t>
+            </a:r>
+            <a:r>
+              <a:rPr lang="en-US" sz="1200" dirty="0">
+                <a:solidFill>
+                  <a:srgbClr val="222222"/>
+                </a:solidFill>
+                <a:latin typeface="Segoe UI" panose="020B0502040204020203" pitchFamily="34" charset="0"/>
+              </a:rPr>
+              <a:t> uno de los </a:t>
+            </a:r>
+            <a:r>
+              <a:rPr lang="en-US" sz="1200" dirty="0" err="1">
+                <a:solidFill>
+                  <a:srgbClr val="222222"/>
+                </a:solidFill>
+                <a:latin typeface="Segoe UI" panose="020B0502040204020203" pitchFamily="34" charset="0"/>
+              </a:rPr>
+              <a:t>diferentes</a:t>
+            </a:r>
+            <a:r>
+              <a:rPr lang="en-US" sz="1200" dirty="0">
+                <a:solidFill>
+                  <a:srgbClr val="222222"/>
+                </a:solidFill>
+                <a:latin typeface="Segoe UI" panose="020B0502040204020203" pitchFamily="34" charset="0"/>
+              </a:rPr>
+              <a:t> </a:t>
+            </a:r>
+            <a:r>
+              <a:rPr lang="en-US" sz="1200" dirty="0" err="1">
+                <a:solidFill>
+                  <a:srgbClr val="222222"/>
+                </a:solidFill>
+                <a:latin typeface="Segoe UI" panose="020B0502040204020203" pitchFamily="34" charset="0"/>
+              </a:rPr>
+              <a:t>lotes</a:t>
+            </a:r>
+            <a:r>
+              <a:rPr lang="en-US" sz="1200" dirty="0">
+                <a:solidFill>
+                  <a:srgbClr val="222222"/>
+                </a:solidFill>
+                <a:latin typeface="Segoe UI" panose="020B0502040204020203" pitchFamily="34" charset="0"/>
+              </a:rPr>
+              <a:t> </a:t>
+            </a:r>
+            <a:r>
+              <a:rPr lang="en-US" sz="1200" dirty="0" err="1">
+                <a:solidFill>
+                  <a:srgbClr val="222222"/>
+                </a:solidFill>
+                <a:latin typeface="Segoe UI" panose="020B0502040204020203" pitchFamily="34" charset="0"/>
+              </a:rPr>
+              <a:t>el</a:t>
+            </a:r>
+            <a:r>
+              <a:rPr lang="en-US" sz="1200" dirty="0">
+                <a:solidFill>
+                  <a:srgbClr val="222222"/>
+                </a:solidFill>
+                <a:latin typeface="Segoe UI" panose="020B0502040204020203" pitchFamily="34" charset="0"/>
+              </a:rPr>
+              <a:t> </a:t>
+            </a:r>
+            <a:r>
+              <a:rPr lang="en-US" sz="1200" dirty="0" err="1">
+                <a:solidFill>
+                  <a:srgbClr val="222222"/>
+                </a:solidFill>
+                <a:latin typeface="Segoe UI" panose="020B0502040204020203" pitchFamily="34" charset="0"/>
+              </a:rPr>
+              <a:t>codigo</a:t>
+            </a:r>
+            <a:r>
+              <a:rPr lang="en-US" sz="1200" dirty="0">
+                <a:solidFill>
+                  <a:srgbClr val="222222"/>
+                </a:solidFill>
+                <a:latin typeface="Segoe UI" panose="020B0502040204020203" pitchFamily="34" charset="0"/>
+              </a:rPr>
+              <a:t> de </a:t>
+            </a:r>
+            <a:r>
+              <a:rPr lang="en-US" sz="1200" dirty="0" err="1">
+                <a:solidFill>
+                  <a:srgbClr val="222222"/>
+                </a:solidFill>
+                <a:latin typeface="Segoe UI" panose="020B0502040204020203" pitchFamily="34" charset="0"/>
+              </a:rPr>
+              <a:t>defecto</a:t>
+            </a:r>
+            <a:r>
+              <a:rPr lang="en-US" sz="1200" dirty="0">
+                <a:solidFill>
+                  <a:srgbClr val="222222"/>
+                </a:solidFill>
+                <a:latin typeface="Segoe UI" panose="020B0502040204020203" pitchFamily="34" charset="0"/>
+              </a:rPr>
+              <a:t> por </a:t>
+            </a:r>
+            <a:r>
+              <a:rPr lang="en-US" sz="1200" dirty="0" err="1">
+                <a:solidFill>
+                  <a:srgbClr val="222222"/>
+                </a:solidFill>
+                <a:latin typeface="Segoe UI" panose="020B0502040204020203" pitchFamily="34" charset="0"/>
+              </a:rPr>
+              <a:t>el</a:t>
+            </a:r>
+            <a:r>
+              <a:rPr lang="en-US" sz="1200" dirty="0">
+                <a:solidFill>
+                  <a:srgbClr val="222222"/>
+                </a:solidFill>
+                <a:latin typeface="Segoe UI" panose="020B0502040204020203" pitchFamily="34" charset="0"/>
+              </a:rPr>
+              <a:t> </a:t>
+            </a:r>
+            <a:r>
+              <a:rPr lang="en-US" sz="1200" dirty="0" err="1">
+                <a:solidFill>
+                  <a:srgbClr val="222222"/>
+                </a:solidFill>
+                <a:latin typeface="Segoe UI" panose="020B0502040204020203" pitchFamily="34" charset="0"/>
+              </a:rPr>
+              <a:t>cual</a:t>
+            </a:r>
+            <a:r>
+              <a:rPr lang="en-US" sz="1200" dirty="0">
+                <a:solidFill>
+                  <a:srgbClr val="222222"/>
+                </a:solidFill>
+                <a:latin typeface="Segoe UI" panose="020B0502040204020203" pitchFamily="34" charset="0"/>
+              </a:rPr>
+              <a:t> se </a:t>
+            </a:r>
+            <a:r>
+              <a:rPr lang="en-US" sz="1200" dirty="0" err="1">
+                <a:solidFill>
+                  <a:srgbClr val="222222"/>
+                </a:solidFill>
+                <a:latin typeface="Segoe UI" panose="020B0502040204020203" pitchFamily="34" charset="0"/>
+              </a:rPr>
+              <a:t>esta</a:t>
+            </a:r>
+            <a:r>
+              <a:rPr lang="en-US" sz="1200" dirty="0">
+                <a:solidFill>
+                  <a:srgbClr val="222222"/>
+                </a:solidFill>
+                <a:latin typeface="Segoe UI" panose="020B0502040204020203" pitchFamily="34" charset="0"/>
+              </a:rPr>
+              <a:t> </a:t>
+            </a:r>
+            <a:r>
+              <a:rPr lang="en-US" sz="1200" dirty="0" err="1">
+                <a:solidFill>
+                  <a:srgbClr val="222222"/>
+                </a:solidFill>
+                <a:latin typeface="Segoe UI" panose="020B0502040204020203" pitchFamily="34" charset="0"/>
+              </a:rPr>
+              <a:t>enviando</a:t>
+            </a:r>
+            <a:r>
+              <a:rPr lang="en-US" sz="1200" dirty="0">
+                <a:solidFill>
+                  <a:srgbClr val="222222"/>
+                </a:solidFill>
+                <a:latin typeface="Segoe UI" panose="020B0502040204020203" pitchFamily="34" charset="0"/>
+              </a:rPr>
+              <a:t> las </a:t>
+            </a:r>
+            <a:r>
+              <a:rPr lang="en-US" sz="1200" dirty="0" err="1">
+                <a:solidFill>
+                  <a:srgbClr val="222222"/>
+                </a:solidFill>
+                <a:latin typeface="Segoe UI" panose="020B0502040204020203" pitchFamily="34" charset="0"/>
+              </a:rPr>
+              <a:t>pieles</a:t>
+            </a:r>
+            <a:r>
+              <a:rPr lang="en-US" sz="1200" dirty="0">
+                <a:solidFill>
+                  <a:srgbClr val="222222"/>
+                </a:solidFill>
+                <a:latin typeface="Segoe UI" panose="020B0502040204020203" pitchFamily="34" charset="0"/>
+              </a:rPr>
+              <a:t> a MQU</a:t>
+            </a:r>
+            <a:r>
+              <a:rPr lang="es-ES" sz="1200" b="0" i="0" dirty="0">
+                <a:solidFill>
+                  <a:srgbClr val="222222"/>
+                </a:solidFill>
+                <a:effectLst/>
+                <a:latin typeface="Segoe UI" panose="020B0502040204020203" pitchFamily="34" charset="0"/>
+              </a:rPr>
+              <a:t>.</a:t>
+            </a:r>
+          </a:p>
+        </p:txBody>
+      </p:sp>
+      <p:pic>
+        <p:nvPicPr>
+          <p:cNvPr id="5" name="Imagen 4">
+            <a:extLst>
+              <a:ext uri="{FF2B5EF4-FFF2-40B4-BE49-F238E27FC236}">
+                <a16:creationId xmlns:a16="http://schemas.microsoft.com/office/drawing/2014/main" id="{372F660D-BA02-4BED-8DA5-FCDDCFE99E2B}"/>
+              </a:ext>
+            </a:extLst>
+          </p:cNvPr>
+          <p:cNvPicPr>
+            <a:picLocks noChangeAspect="1"/>
+          </p:cNvPicPr>
+          <p:nvPr/>
+        </p:nvPicPr>
+        <p:blipFill>
+          <a:blip r:embed="rId2"/>
+          <a:stretch>
+            <a:fillRect/>
+          </a:stretch>
+        </p:blipFill>
+        <p:spPr>
+          <a:xfrm>
+            <a:off x="1159416" y="1412776"/>
+            <a:ext cx="7949088" cy="5400600"/>
+          </a:xfrm>
+          <a:prstGeom prst="rect">
+            <a:avLst/>
+          </a:prstGeom>
+        </p:spPr>
+      </p:pic>
+      <p:sp>
+        <p:nvSpPr>
+          <p:cNvPr id="6" name="Rectángulo 5">
+            <a:extLst>
+              <a:ext uri="{FF2B5EF4-FFF2-40B4-BE49-F238E27FC236}">
+                <a16:creationId xmlns:a16="http://schemas.microsoft.com/office/drawing/2014/main" id="{A053A35C-5E28-4CF1-A1EB-4F83DECE7BFC}"/>
+              </a:ext>
+            </a:extLst>
+          </p:cNvPr>
+          <p:cNvSpPr/>
+          <p:nvPr/>
+        </p:nvSpPr>
+        <p:spPr>
+          <a:xfrm>
+            <a:off x="6732240" y="1916832"/>
+            <a:ext cx="1252344" cy="4104456"/>
+          </a:xfrm>
+          <a:prstGeom prst="rect">
+            <a:avLst/>
+          </a:prstGeom>
+          <a:noFill/>
+          <a:ln>
+            <a:solidFill>
+              <a:srgbClr val="FF0000"/>
+            </a:solidFill>
+          </a:ln>
+        </p:spPr>
+        <p:style>
+          <a:lnRef idx="2">
+            <a:schemeClr val="accent1">
+              <a:shade val="50000"/>
+            </a:schemeClr>
+          </a:lnRef>
+          <a:fillRef idx="1">
+            <a:schemeClr val="accent1"/>
+          </a:fillRef>
+          <a:effectRef idx="0">
+            <a:schemeClr val="accent1"/>
+          </a:effectRef>
+          <a:fontRef idx="minor">
+            <a:schemeClr val="lt1"/>
+          </a:fontRef>
+        </p:style>
+        <p:txBody>
+          <a:bodyPr rtlCol="0" anchor="ctr"/>
+          <a:lstStyle/>
+          <a:p>
+            <a:pPr algn="ctr"/>
+            <a:endParaRPr lang="en-US"/>
+          </a:p>
+        </p:txBody>
+      </p:sp>
+    </p:spTree>
+    <p:extLst>
+      <p:ext uri="{BB962C8B-B14F-4D97-AF65-F5344CB8AC3E}">
+        <p14:creationId xmlns:p14="http://schemas.microsoft.com/office/powerpoint/2010/main" val="3683809633"/>
+      </p:ext>
+    </p:extLst>
+  </p:cSld>
+  <p:clrMapOvr>
+    <a:masterClrMapping/>
+  </p:clrMapOvr>
+</p:sld>
+</file>
+
+<file path=ppt/slides/slide20.xml><?xml version="1.0" encoding="utf-8"?>
+<p:sld xmlns:a="http://schemas.openxmlformats.org/drawingml/2006/main" xmlns:r="http://schemas.openxmlformats.org/officeDocument/2006/relationships" xmlns:p="http://schemas.openxmlformats.org/presentationml/2006/main">
+  <p:cSld>
+    <p:spTree>
+      <p:nvGrpSpPr>
+        <p:cNvPr id="1" name=""/>
+        <p:cNvGrpSpPr/>
+        <p:nvPr/>
+      </p:nvGrpSpPr>
+      <p:grpSpPr>
+        <a:xfrm>
+          <a:off x="0" y="0"/>
+          <a:ext cx="0" cy="0"/>
+          <a:chOff x="0" y="0"/>
+          <a:chExt cx="0" cy="0"/>
+        </a:xfrm>
+      </p:grpSpPr>
+      <p:sp>
+        <p:nvSpPr>
           <p:cNvPr id="5" name="Title 1"/>
           <p:cNvSpPr txBox="1">
             <a:spLocks/>
@@ -6621,7 +8068,7 @@
 </p:sld>
 </file>
 
-<file path=ppt/slides/slide19.xml><?xml version="1.0" encoding="utf-8"?>
+<file path=ppt/slides/slide21.xml><?xml version="1.0" encoding="utf-8"?>
 <p:sld xmlns:a="http://schemas.openxmlformats.org/drawingml/2006/main" xmlns:r="http://schemas.openxmlformats.org/officeDocument/2006/relationships" xmlns:p="http://schemas.openxmlformats.org/presentationml/2006/main">
   <p:cSld>
     <p:spTree>
@@ -7013,7 +8460,87 @@
 </p:sld>
 </file>
 
-<file path=ppt/slides/slide2.xml><?xml version="1.0" encoding="utf-8"?>
+<file path=ppt/slides/slide3.xml><?xml version="1.0" encoding="utf-8"?>
+<p:sld xmlns:a="http://schemas.openxmlformats.org/drawingml/2006/main" xmlns:r="http://schemas.openxmlformats.org/officeDocument/2006/relationships" xmlns:p="http://schemas.openxmlformats.org/presentationml/2006/main">
+  <p:cSld>
+    <p:spTree>
+      <p:nvGrpSpPr>
+        <p:cNvPr id="1" name=""/>
+        <p:cNvGrpSpPr/>
+        <p:nvPr/>
+      </p:nvGrpSpPr>
+      <p:grpSpPr>
+        <a:xfrm>
+          <a:off x="0" y="0"/>
+          <a:ext cx="0" cy="0"/>
+          <a:chOff x="0" y="0"/>
+          <a:chExt cx="0" cy="0"/>
+        </a:xfrm>
+      </p:grpSpPr>
+      <p:sp>
+        <p:nvSpPr>
+          <p:cNvPr id="5" name="Title 1"/>
+          <p:cNvSpPr txBox="1">
+            <a:spLocks/>
+          </p:cNvSpPr>
+          <p:nvPr/>
+        </p:nvSpPr>
+        <p:spPr>
+          <a:xfrm>
+            <a:off x="1187624" y="2564904"/>
+            <a:ext cx="7772400" cy="1470025"/>
+          </a:xfrm>
+          <a:prstGeom prst="rect">
+            <a:avLst/>
+          </a:prstGeom>
+        </p:spPr>
+        <p:txBody>
+          <a:bodyPr vert="horz" lIns="91440" tIns="45720" rIns="91440" bIns="45720" rtlCol="0" anchor="ctr">
+            <a:normAutofit/>
+          </a:bodyPr>
+          <a:lstStyle>
+            <a:lvl1pPr algn="ctr" defTabSz="914400" rtl="0" eaLnBrk="1" latinLnBrk="0" hangingPunct="1">
+              <a:spcBef>
+                <a:spcPct val="0"/>
+              </a:spcBef>
+              <a:buNone/>
+              <a:defRPr sz="4400" kern="1200">
+                <a:solidFill>
+                  <a:schemeClr val="tx1"/>
+                </a:solidFill>
+                <a:latin typeface="+mj-lt"/>
+                <a:ea typeface="+mj-ea"/>
+                <a:cs typeface="+mj-cs"/>
+              </a:defRPr>
+            </a:lvl1pPr>
+          </a:lstStyle>
+          <a:p>
+            <a:r>
+              <a:rPr lang="es-MX" b="1" dirty="0">
+                <a:latin typeface="Century Gothic" panose="020B0502020202020204" pitchFamily="34" charset="0"/>
+              </a:rPr>
+              <a:t>28/06/2021 – 05/07/2021</a:t>
+            </a:r>
+            <a:endParaRPr lang="es-MX" dirty="0">
+              <a:latin typeface="Century Gothic" panose="020B0502020202020204" pitchFamily="34" charset="0"/>
+            </a:endParaRPr>
+          </a:p>
+        </p:txBody>
+      </p:sp>
+    </p:spTree>
+    <p:extLst>
+      <p:ext uri="{BB962C8B-B14F-4D97-AF65-F5344CB8AC3E}">
+        <p14:creationId xmlns:p14="http://schemas.microsoft.com/office/powerpoint/2010/main" val="4037248661"/>
+      </p:ext>
+    </p:extLst>
+  </p:cSld>
+  <p:clrMapOvr>
+    <a:masterClrMapping/>
+  </p:clrMapOvr>
+</p:sld>
+</file>
+
+<file path=ppt/slides/slide4.xml><?xml version="1.0" encoding="utf-8"?>
 <p:sld xmlns:a="http://schemas.openxmlformats.org/drawingml/2006/main" xmlns:r="http://schemas.openxmlformats.org/officeDocument/2006/relationships" xmlns:p="http://schemas.openxmlformats.org/presentationml/2006/main">
   <p:cSld>
     <p:spTree>
@@ -7648,7 +9175,7 @@
 </p:sld>
 </file>
 
-<file path=ppt/slides/slide3.xml><?xml version="1.0" encoding="utf-8"?>
+<file path=ppt/slides/slide5.xml><?xml version="1.0" encoding="utf-8"?>
 <p:sld xmlns:a="http://schemas.openxmlformats.org/drawingml/2006/main" xmlns:r="http://schemas.openxmlformats.org/officeDocument/2006/relationships" xmlns:p="http://schemas.openxmlformats.org/presentationml/2006/main">
   <p:cSld>
     <p:spTree>
@@ -7996,7 +9523,7 @@
 </p:sld>
 </file>
 
-<file path=ppt/slides/slide4.xml><?xml version="1.0" encoding="utf-8"?>
+<file path=ppt/slides/slide6.xml><?xml version="1.0" encoding="utf-8"?>
 <p:sld xmlns:a="http://schemas.openxmlformats.org/drawingml/2006/main" xmlns:r="http://schemas.openxmlformats.org/officeDocument/2006/relationships" xmlns:p="http://schemas.openxmlformats.org/presentationml/2006/main">
   <p:cSld>
     <p:spTree>
@@ -8379,7 +9906,7 @@
 </p:sld>
 </file>
 
-<file path=ppt/slides/slide5.xml><?xml version="1.0" encoding="utf-8"?>
+<file path=ppt/slides/slide7.xml><?xml version="1.0" encoding="utf-8"?>
 <p:sld xmlns:a="http://schemas.openxmlformats.org/drawingml/2006/main" xmlns:r="http://schemas.openxmlformats.org/officeDocument/2006/relationships" xmlns:p="http://schemas.openxmlformats.org/presentationml/2006/main">
   <p:cSld>
     <p:spTree>
@@ -8781,7 +10308,7 @@
 </p:sld>
 </file>
 
-<file path=ppt/slides/slide6.xml><?xml version="1.0" encoding="utf-8"?>
+<file path=ppt/slides/slide8.xml><?xml version="1.0" encoding="utf-8"?>
 <p:sld xmlns:a="http://schemas.openxmlformats.org/drawingml/2006/main" xmlns:r="http://schemas.openxmlformats.org/officeDocument/2006/relationships" xmlns:p="http://schemas.openxmlformats.org/presentationml/2006/main">
   <p:cSld>
     <p:spTree>
@@ -8861,7 +10388,7 @@
 </p:sld>
 </file>
 
-<file path=ppt/slides/slide7.xml><?xml version="1.0" encoding="utf-8"?>
+<file path=ppt/slides/slide9.xml><?xml version="1.0" encoding="utf-8"?>
 <p:sld xmlns:a="http://schemas.openxmlformats.org/drawingml/2006/main" xmlns:r="http://schemas.openxmlformats.org/officeDocument/2006/relationships" xmlns:p="http://schemas.openxmlformats.org/presentationml/2006/main">
   <p:cSld>
     <p:spTree>
@@ -9433,720 +10960,6 @@
     <p:extLst>
       <p:ext uri="{BB962C8B-B14F-4D97-AF65-F5344CB8AC3E}">
         <p14:creationId xmlns:p14="http://schemas.microsoft.com/office/powerpoint/2010/main" val="1939695342"/>
-      </p:ext>
-    </p:extLst>
-  </p:cSld>
-  <p:clrMapOvr>
-    <a:masterClrMapping/>
-  </p:clrMapOvr>
-</p:sld>
-</file>
-
-<file path=ppt/slides/slide8.xml><?xml version="1.0" encoding="utf-8"?>
-<p:sld xmlns:a="http://schemas.openxmlformats.org/drawingml/2006/main" xmlns:r="http://schemas.openxmlformats.org/officeDocument/2006/relationships" xmlns:p="http://schemas.openxmlformats.org/presentationml/2006/main">
-  <p:cSld>
-    <p:spTree>
-      <p:nvGrpSpPr>
-        <p:cNvPr id="1" name=""/>
-        <p:cNvGrpSpPr/>
-        <p:nvPr/>
-      </p:nvGrpSpPr>
-      <p:grpSpPr>
-        <a:xfrm>
-          <a:off x="0" y="0"/>
-          <a:ext cx="0" cy="0"/>
-          <a:chOff x="0" y="0"/>
-          <a:chExt cx="0" cy="0"/>
-        </a:xfrm>
-      </p:grpSpPr>
-      <p:sp>
-        <p:nvSpPr>
-          <p:cNvPr id="8" name="Title 1"/>
-          <p:cNvSpPr txBox="1">
-            <a:spLocks/>
-          </p:cNvSpPr>
-          <p:nvPr/>
-        </p:nvSpPr>
-        <p:spPr>
-          <a:xfrm>
-            <a:off x="1087408" y="274638"/>
-            <a:ext cx="7229008" cy="634082"/>
-          </a:xfrm>
-          <a:prstGeom prst="rect">
-            <a:avLst/>
-          </a:prstGeom>
-        </p:spPr>
-        <p:txBody>
-          <a:bodyPr/>
-          <a:lstStyle>
-            <a:lvl1pPr algn="ctr" defTabSz="914400" rtl="0" eaLnBrk="1" latinLnBrk="0" hangingPunct="1">
-              <a:spcBef>
-                <a:spcPct val="0"/>
-              </a:spcBef>
-              <a:buNone/>
-              <a:defRPr sz="4400" kern="1200">
-                <a:solidFill>
-                  <a:schemeClr val="tx1"/>
-                </a:solidFill>
-                <a:latin typeface="+mj-lt"/>
-                <a:ea typeface="+mj-ea"/>
-                <a:cs typeface="+mj-cs"/>
-              </a:defRPr>
-            </a:lvl1pPr>
-          </a:lstStyle>
-          <a:p>
-            <a:pPr algn="l"/>
-            <a:r>
-              <a:rPr lang="es-ES" sz="2000" dirty="0">
-                <a:solidFill>
-                  <a:srgbClr val="3F1900"/>
-                </a:solidFill>
-              </a:rPr>
-              <a:t>Estación de Devolución de Pieles.</a:t>
-            </a:r>
-            <a:endParaRPr lang="en-US" sz="2000" dirty="0">
-              <a:solidFill>
-                <a:srgbClr val="3F1900"/>
-              </a:solidFill>
-            </a:endParaRPr>
-          </a:p>
-        </p:txBody>
-      </p:sp>
-      <p:sp>
-        <p:nvSpPr>
-          <p:cNvPr id="4" name="Content Placeholder 3"/>
-          <p:cNvSpPr txBox="1">
-            <a:spLocks/>
-          </p:cNvSpPr>
-          <p:nvPr/>
-        </p:nvSpPr>
-        <p:spPr>
-          <a:xfrm>
-            <a:off x="1331640" y="1196753"/>
-            <a:ext cx="7488832" cy="5137780"/>
-          </a:xfrm>
-          <a:prstGeom prst="rect">
-            <a:avLst/>
-          </a:prstGeom>
-        </p:spPr>
-        <p:txBody>
-          <a:bodyPr>
-            <a:normAutofit/>
-          </a:bodyPr>
-          <a:lstStyle>
-            <a:lvl1pPr marL="342900" indent="-342900" algn="l" defTabSz="914400" rtl="0" eaLnBrk="1" latinLnBrk="0" hangingPunct="1">
-              <a:spcBef>
-                <a:spcPct val="20000"/>
-              </a:spcBef>
-              <a:buFont typeface="Arial" panose="020B0604020202020204" pitchFamily="34" charset="0"/>
-              <a:buChar char="•"/>
-              <a:defRPr sz="3200" kern="1200">
-                <a:solidFill>
-                  <a:schemeClr val="tx1"/>
-                </a:solidFill>
-                <a:latin typeface="+mn-lt"/>
-                <a:ea typeface="+mn-ea"/>
-                <a:cs typeface="+mn-cs"/>
-              </a:defRPr>
-            </a:lvl1pPr>
-            <a:lvl2pPr marL="742950" indent="-285750" algn="l" defTabSz="914400" rtl="0" eaLnBrk="1" latinLnBrk="0" hangingPunct="1">
-              <a:spcBef>
-                <a:spcPct val="20000"/>
-              </a:spcBef>
-              <a:buFont typeface="Arial" panose="020B0604020202020204" pitchFamily="34" charset="0"/>
-              <a:buChar char="–"/>
-              <a:defRPr sz="2800" kern="1200">
-                <a:solidFill>
-                  <a:schemeClr val="tx1"/>
-                </a:solidFill>
-                <a:latin typeface="+mn-lt"/>
-                <a:ea typeface="+mn-ea"/>
-                <a:cs typeface="+mn-cs"/>
-              </a:defRPr>
-            </a:lvl2pPr>
-            <a:lvl3pPr marL="1143000" indent="-228600" algn="l" defTabSz="914400" rtl="0" eaLnBrk="1" latinLnBrk="0" hangingPunct="1">
-              <a:spcBef>
-                <a:spcPct val="20000"/>
-              </a:spcBef>
-              <a:buFont typeface="Arial" panose="020B0604020202020204" pitchFamily="34" charset="0"/>
-              <a:buChar char="•"/>
-              <a:defRPr sz="2400" kern="1200">
-                <a:solidFill>
-                  <a:schemeClr val="tx1"/>
-                </a:solidFill>
-                <a:latin typeface="+mn-lt"/>
-                <a:ea typeface="+mn-ea"/>
-                <a:cs typeface="+mn-cs"/>
-              </a:defRPr>
-            </a:lvl3pPr>
-            <a:lvl4pPr marL="1600200" indent="-228600" algn="l" defTabSz="914400" rtl="0" eaLnBrk="1" latinLnBrk="0" hangingPunct="1">
-              <a:spcBef>
-                <a:spcPct val="20000"/>
-              </a:spcBef>
-              <a:buFont typeface="Arial" panose="020B0604020202020204" pitchFamily="34" charset="0"/>
-              <a:buChar char="–"/>
-              <a:defRPr sz="2000" kern="1200">
-                <a:solidFill>
-                  <a:schemeClr val="tx1"/>
-                </a:solidFill>
-                <a:latin typeface="+mn-lt"/>
-                <a:ea typeface="+mn-ea"/>
-                <a:cs typeface="+mn-cs"/>
-              </a:defRPr>
-            </a:lvl4pPr>
-            <a:lvl5pPr marL="2057400" indent="-228600" algn="l" defTabSz="914400" rtl="0" eaLnBrk="1" latinLnBrk="0" hangingPunct="1">
-              <a:spcBef>
-                <a:spcPct val="20000"/>
-              </a:spcBef>
-              <a:buFont typeface="Arial" panose="020B0604020202020204" pitchFamily="34" charset="0"/>
-              <a:buChar char="»"/>
-              <a:defRPr sz="2000" kern="1200">
-                <a:solidFill>
-                  <a:schemeClr val="tx1"/>
-                </a:solidFill>
-                <a:latin typeface="+mn-lt"/>
-                <a:ea typeface="+mn-ea"/>
-                <a:cs typeface="+mn-cs"/>
-              </a:defRPr>
-            </a:lvl5pPr>
-            <a:lvl6pPr marL="2514600" indent="-228600" algn="l" defTabSz="914400" rtl="0" eaLnBrk="1" latinLnBrk="0" hangingPunct="1">
-              <a:spcBef>
-                <a:spcPct val="20000"/>
-              </a:spcBef>
-              <a:buFont typeface="Arial" panose="020B0604020202020204" pitchFamily="34" charset="0"/>
-              <a:buChar char="•"/>
-              <a:defRPr sz="2000" kern="1200">
-                <a:solidFill>
-                  <a:schemeClr val="tx1"/>
-                </a:solidFill>
-                <a:latin typeface="+mn-lt"/>
-                <a:ea typeface="+mn-ea"/>
-                <a:cs typeface="+mn-cs"/>
-              </a:defRPr>
-            </a:lvl6pPr>
-            <a:lvl7pPr marL="2971800" indent="-228600" algn="l" defTabSz="914400" rtl="0" eaLnBrk="1" latinLnBrk="0" hangingPunct="1">
-              <a:spcBef>
-                <a:spcPct val="20000"/>
-              </a:spcBef>
-              <a:buFont typeface="Arial" panose="020B0604020202020204" pitchFamily="34" charset="0"/>
-              <a:buChar char="•"/>
-              <a:defRPr sz="2000" kern="1200">
-                <a:solidFill>
-                  <a:schemeClr val="tx1"/>
-                </a:solidFill>
-                <a:latin typeface="+mn-lt"/>
-                <a:ea typeface="+mn-ea"/>
-                <a:cs typeface="+mn-cs"/>
-              </a:defRPr>
-            </a:lvl7pPr>
-            <a:lvl8pPr marL="3429000" indent="-228600" algn="l" defTabSz="914400" rtl="0" eaLnBrk="1" latinLnBrk="0" hangingPunct="1">
-              <a:spcBef>
-                <a:spcPct val="20000"/>
-              </a:spcBef>
-              <a:buFont typeface="Arial" panose="020B0604020202020204" pitchFamily="34" charset="0"/>
-              <a:buChar char="•"/>
-              <a:defRPr sz="2000" kern="1200">
-                <a:solidFill>
-                  <a:schemeClr val="tx1"/>
-                </a:solidFill>
-                <a:latin typeface="+mn-lt"/>
-                <a:ea typeface="+mn-ea"/>
-                <a:cs typeface="+mn-cs"/>
-              </a:defRPr>
-            </a:lvl8pPr>
-            <a:lvl9pPr marL="3886200" indent="-228600" algn="l" defTabSz="914400" rtl="0" eaLnBrk="1" latinLnBrk="0" hangingPunct="1">
-              <a:spcBef>
-                <a:spcPct val="20000"/>
-              </a:spcBef>
-              <a:buFont typeface="Arial" panose="020B0604020202020204" pitchFamily="34" charset="0"/>
-              <a:buChar char="•"/>
-              <a:defRPr sz="2000" kern="1200">
-                <a:solidFill>
-                  <a:schemeClr val="tx1"/>
-                </a:solidFill>
-                <a:latin typeface="+mn-lt"/>
-                <a:ea typeface="+mn-ea"/>
-                <a:cs typeface="+mn-cs"/>
-              </a:defRPr>
-            </a:lvl9pPr>
-          </a:lstStyle>
-          <a:p>
-            <a:pPr marL="0" indent="0" algn="just">
-              <a:buFont typeface="Arial" panose="020B0604020202020204" pitchFamily="34" charset="0"/>
-              <a:buNone/>
-            </a:pPr>
-            <a:endParaRPr lang="en-US" sz="2000" i="1"/>
-          </a:p>
-        </p:txBody>
-      </p:sp>
-      <p:sp>
-        <p:nvSpPr>
-          <p:cNvPr id="10" name="Rectangle 9"/>
-          <p:cNvSpPr/>
-          <p:nvPr/>
-        </p:nvSpPr>
-        <p:spPr>
-          <a:xfrm>
-            <a:off x="1159416" y="980728"/>
-            <a:ext cx="7949088" cy="461665"/>
-          </a:xfrm>
-          <a:prstGeom prst="rect">
-            <a:avLst/>
-          </a:prstGeom>
-        </p:spPr>
-        <p:txBody>
-          <a:bodyPr wrap="square">
-            <a:spAutoFit/>
-          </a:bodyPr>
-          <a:lstStyle/>
-          <a:p>
-            <a:pPr>
-              <a:buFont typeface="Arial" panose="020B0604020202020204" pitchFamily="34" charset="0"/>
-              <a:buChar char="•"/>
-            </a:pPr>
-            <a:r>
-              <a:rPr lang="es-ES" sz="1200" dirty="0">
-                <a:solidFill>
-                  <a:srgbClr val="222222"/>
-                </a:solidFill>
-                <a:latin typeface="Segoe UI" panose="020B0502040204020203" pitchFamily="34" charset="0"/>
-              </a:rPr>
-              <a:t> La pantalla </a:t>
-            </a:r>
-            <a:r>
-              <a:rPr lang="es-ES" sz="1200" b="1" dirty="0">
-                <a:solidFill>
-                  <a:srgbClr val="222222"/>
-                </a:solidFill>
-                <a:latin typeface="Segoe UI" panose="020B0502040204020203" pitchFamily="34" charset="0"/>
-              </a:rPr>
-              <a:t>Devolución de piel </a:t>
-            </a:r>
-            <a:r>
-              <a:rPr lang="es-ES" sz="1200" dirty="0">
-                <a:solidFill>
-                  <a:srgbClr val="222222"/>
-                </a:solidFill>
-                <a:latin typeface="Segoe UI" panose="020B0502040204020203" pitchFamily="34" charset="0"/>
-              </a:rPr>
-              <a:t>primero nos pedirá un Numero de Reloj y Contraseña que se les proporcionara a las personas autorizadas para realizar esta acción.</a:t>
-            </a:r>
-            <a:endParaRPr lang="es-ES" sz="1200" b="0" i="0" dirty="0">
-              <a:solidFill>
-                <a:srgbClr val="222222"/>
-              </a:solidFill>
-              <a:effectLst/>
-              <a:latin typeface="Segoe UI" panose="020B0502040204020203" pitchFamily="34" charset="0"/>
-            </a:endParaRPr>
-          </a:p>
-        </p:txBody>
-      </p:sp>
-      <p:pic>
-        <p:nvPicPr>
-          <p:cNvPr id="6" name="Imagen 5" descr="Interfaz de usuario gráfica, Aplicación&#10;&#10;Descripción generada automáticamente">
-            <a:extLst>
-              <a:ext uri="{FF2B5EF4-FFF2-40B4-BE49-F238E27FC236}">
-                <a16:creationId xmlns:a16="http://schemas.microsoft.com/office/drawing/2014/main" id="{F73ED8AB-5701-420D-9861-9BB0962D8063}"/>
-              </a:ext>
-            </a:extLst>
-          </p:cNvPr>
-          <p:cNvPicPr>
-            <a:picLocks noChangeAspect="1"/>
-          </p:cNvPicPr>
-          <p:nvPr/>
-        </p:nvPicPr>
-        <p:blipFill>
-          <a:blip r:embed="rId2">
-            <a:extLst>
-              <a:ext uri="{28A0092B-C50C-407E-A947-70E740481C1C}">
-                <a14:useLocalDpi xmlns:a14="http://schemas.microsoft.com/office/drawing/2010/main" val="0"/>
-              </a:ext>
-            </a:extLst>
-          </a:blip>
-          <a:stretch>
-            <a:fillRect/>
-          </a:stretch>
-        </p:blipFill>
-        <p:spPr>
-          <a:xfrm>
-            <a:off x="1159416" y="1627059"/>
-            <a:ext cx="7949088" cy="4707474"/>
-          </a:xfrm>
-          <a:prstGeom prst="rect">
-            <a:avLst/>
-          </a:prstGeom>
-        </p:spPr>
-      </p:pic>
-    </p:spTree>
-    <p:extLst>
-      <p:ext uri="{BB962C8B-B14F-4D97-AF65-F5344CB8AC3E}">
-        <p14:creationId xmlns:p14="http://schemas.microsoft.com/office/powerpoint/2010/main" val="1116123231"/>
-      </p:ext>
-    </p:extLst>
-  </p:cSld>
-  <p:clrMapOvr>
-    <a:masterClrMapping/>
-  </p:clrMapOvr>
-</p:sld>
-</file>
-
-<file path=ppt/slides/slide9.xml><?xml version="1.0" encoding="utf-8"?>
-<p:sld xmlns:a="http://schemas.openxmlformats.org/drawingml/2006/main" xmlns:r="http://schemas.openxmlformats.org/officeDocument/2006/relationships" xmlns:p="http://schemas.openxmlformats.org/presentationml/2006/main">
-  <p:cSld>
-    <p:spTree>
-      <p:nvGrpSpPr>
-        <p:cNvPr id="1" name=""/>
-        <p:cNvGrpSpPr/>
-        <p:nvPr/>
-      </p:nvGrpSpPr>
-      <p:grpSpPr>
-        <a:xfrm>
-          <a:off x="0" y="0"/>
-          <a:ext cx="0" cy="0"/>
-          <a:chOff x="0" y="0"/>
-          <a:chExt cx="0" cy="0"/>
-        </a:xfrm>
-      </p:grpSpPr>
-      <p:sp>
-        <p:nvSpPr>
-          <p:cNvPr id="8" name="Title 1"/>
-          <p:cNvSpPr txBox="1">
-            <a:spLocks/>
-          </p:cNvSpPr>
-          <p:nvPr/>
-        </p:nvSpPr>
-        <p:spPr>
-          <a:xfrm>
-            <a:off x="1087408" y="274638"/>
-            <a:ext cx="7229008" cy="634082"/>
-          </a:xfrm>
-          <a:prstGeom prst="rect">
-            <a:avLst/>
-          </a:prstGeom>
-        </p:spPr>
-        <p:txBody>
-          <a:bodyPr/>
-          <a:lstStyle>
-            <a:lvl1pPr algn="ctr" defTabSz="914400" rtl="0" eaLnBrk="1" latinLnBrk="0" hangingPunct="1">
-              <a:spcBef>
-                <a:spcPct val="0"/>
-              </a:spcBef>
-              <a:buNone/>
-              <a:defRPr sz="4400" kern="1200">
-                <a:solidFill>
-                  <a:schemeClr val="tx1"/>
-                </a:solidFill>
-                <a:latin typeface="+mj-lt"/>
-                <a:ea typeface="+mj-ea"/>
-                <a:cs typeface="+mj-cs"/>
-              </a:defRPr>
-            </a:lvl1pPr>
-          </a:lstStyle>
-          <a:p>
-            <a:pPr algn="l"/>
-            <a:r>
-              <a:rPr lang="es-ES" sz="2000" dirty="0">
-                <a:solidFill>
-                  <a:srgbClr val="3F1900"/>
-                </a:solidFill>
-              </a:rPr>
-              <a:t>Estación de Devolución de Pieles.</a:t>
-            </a:r>
-            <a:endParaRPr lang="en-US" sz="2000" dirty="0">
-              <a:solidFill>
-                <a:srgbClr val="3F1900"/>
-              </a:solidFill>
-            </a:endParaRPr>
-          </a:p>
-        </p:txBody>
-      </p:sp>
-      <p:sp>
-        <p:nvSpPr>
-          <p:cNvPr id="4" name="Content Placeholder 3"/>
-          <p:cNvSpPr txBox="1">
-            <a:spLocks/>
-          </p:cNvSpPr>
-          <p:nvPr/>
-        </p:nvSpPr>
-        <p:spPr>
-          <a:xfrm>
-            <a:off x="1331640" y="1196753"/>
-            <a:ext cx="7488832" cy="5137780"/>
-          </a:xfrm>
-          <a:prstGeom prst="rect">
-            <a:avLst/>
-          </a:prstGeom>
-        </p:spPr>
-        <p:txBody>
-          <a:bodyPr>
-            <a:normAutofit/>
-          </a:bodyPr>
-          <a:lstStyle>
-            <a:lvl1pPr marL="342900" indent="-342900" algn="l" defTabSz="914400" rtl="0" eaLnBrk="1" latinLnBrk="0" hangingPunct="1">
-              <a:spcBef>
-                <a:spcPct val="20000"/>
-              </a:spcBef>
-              <a:buFont typeface="Arial" panose="020B0604020202020204" pitchFamily="34" charset="0"/>
-              <a:buChar char="•"/>
-              <a:defRPr sz="3200" kern="1200">
-                <a:solidFill>
-                  <a:schemeClr val="tx1"/>
-                </a:solidFill>
-                <a:latin typeface="+mn-lt"/>
-                <a:ea typeface="+mn-ea"/>
-                <a:cs typeface="+mn-cs"/>
-              </a:defRPr>
-            </a:lvl1pPr>
-            <a:lvl2pPr marL="742950" indent="-285750" algn="l" defTabSz="914400" rtl="0" eaLnBrk="1" latinLnBrk="0" hangingPunct="1">
-              <a:spcBef>
-                <a:spcPct val="20000"/>
-              </a:spcBef>
-              <a:buFont typeface="Arial" panose="020B0604020202020204" pitchFamily="34" charset="0"/>
-              <a:buChar char="–"/>
-              <a:defRPr sz="2800" kern="1200">
-                <a:solidFill>
-                  <a:schemeClr val="tx1"/>
-                </a:solidFill>
-                <a:latin typeface="+mn-lt"/>
-                <a:ea typeface="+mn-ea"/>
-                <a:cs typeface="+mn-cs"/>
-              </a:defRPr>
-            </a:lvl2pPr>
-            <a:lvl3pPr marL="1143000" indent="-228600" algn="l" defTabSz="914400" rtl="0" eaLnBrk="1" latinLnBrk="0" hangingPunct="1">
-              <a:spcBef>
-                <a:spcPct val="20000"/>
-              </a:spcBef>
-              <a:buFont typeface="Arial" panose="020B0604020202020204" pitchFamily="34" charset="0"/>
-              <a:buChar char="•"/>
-              <a:defRPr sz="2400" kern="1200">
-                <a:solidFill>
-                  <a:schemeClr val="tx1"/>
-                </a:solidFill>
-                <a:latin typeface="+mn-lt"/>
-                <a:ea typeface="+mn-ea"/>
-                <a:cs typeface="+mn-cs"/>
-              </a:defRPr>
-            </a:lvl3pPr>
-            <a:lvl4pPr marL="1600200" indent="-228600" algn="l" defTabSz="914400" rtl="0" eaLnBrk="1" latinLnBrk="0" hangingPunct="1">
-              <a:spcBef>
-                <a:spcPct val="20000"/>
-              </a:spcBef>
-              <a:buFont typeface="Arial" panose="020B0604020202020204" pitchFamily="34" charset="0"/>
-              <a:buChar char="–"/>
-              <a:defRPr sz="2000" kern="1200">
-                <a:solidFill>
-                  <a:schemeClr val="tx1"/>
-                </a:solidFill>
-                <a:latin typeface="+mn-lt"/>
-                <a:ea typeface="+mn-ea"/>
-                <a:cs typeface="+mn-cs"/>
-              </a:defRPr>
-            </a:lvl4pPr>
-            <a:lvl5pPr marL="2057400" indent="-228600" algn="l" defTabSz="914400" rtl="0" eaLnBrk="1" latinLnBrk="0" hangingPunct="1">
-              <a:spcBef>
-                <a:spcPct val="20000"/>
-              </a:spcBef>
-              <a:buFont typeface="Arial" panose="020B0604020202020204" pitchFamily="34" charset="0"/>
-              <a:buChar char="»"/>
-              <a:defRPr sz="2000" kern="1200">
-                <a:solidFill>
-                  <a:schemeClr val="tx1"/>
-                </a:solidFill>
-                <a:latin typeface="+mn-lt"/>
-                <a:ea typeface="+mn-ea"/>
-                <a:cs typeface="+mn-cs"/>
-              </a:defRPr>
-            </a:lvl5pPr>
-            <a:lvl6pPr marL="2514600" indent="-228600" algn="l" defTabSz="914400" rtl="0" eaLnBrk="1" latinLnBrk="0" hangingPunct="1">
-              <a:spcBef>
-                <a:spcPct val="20000"/>
-              </a:spcBef>
-              <a:buFont typeface="Arial" panose="020B0604020202020204" pitchFamily="34" charset="0"/>
-              <a:buChar char="•"/>
-              <a:defRPr sz="2000" kern="1200">
-                <a:solidFill>
-                  <a:schemeClr val="tx1"/>
-                </a:solidFill>
-                <a:latin typeface="+mn-lt"/>
-                <a:ea typeface="+mn-ea"/>
-                <a:cs typeface="+mn-cs"/>
-              </a:defRPr>
-            </a:lvl6pPr>
-            <a:lvl7pPr marL="2971800" indent="-228600" algn="l" defTabSz="914400" rtl="0" eaLnBrk="1" latinLnBrk="0" hangingPunct="1">
-              <a:spcBef>
-                <a:spcPct val="20000"/>
-              </a:spcBef>
-              <a:buFont typeface="Arial" panose="020B0604020202020204" pitchFamily="34" charset="0"/>
-              <a:buChar char="•"/>
-              <a:defRPr sz="2000" kern="1200">
-                <a:solidFill>
-                  <a:schemeClr val="tx1"/>
-                </a:solidFill>
-                <a:latin typeface="+mn-lt"/>
-                <a:ea typeface="+mn-ea"/>
-                <a:cs typeface="+mn-cs"/>
-              </a:defRPr>
-            </a:lvl7pPr>
-            <a:lvl8pPr marL="3429000" indent="-228600" algn="l" defTabSz="914400" rtl="0" eaLnBrk="1" latinLnBrk="0" hangingPunct="1">
-              <a:spcBef>
-                <a:spcPct val="20000"/>
-              </a:spcBef>
-              <a:buFont typeface="Arial" panose="020B0604020202020204" pitchFamily="34" charset="0"/>
-              <a:buChar char="•"/>
-              <a:defRPr sz="2000" kern="1200">
-                <a:solidFill>
-                  <a:schemeClr val="tx1"/>
-                </a:solidFill>
-                <a:latin typeface="+mn-lt"/>
-                <a:ea typeface="+mn-ea"/>
-                <a:cs typeface="+mn-cs"/>
-              </a:defRPr>
-            </a:lvl8pPr>
-            <a:lvl9pPr marL="3886200" indent="-228600" algn="l" defTabSz="914400" rtl="0" eaLnBrk="1" latinLnBrk="0" hangingPunct="1">
-              <a:spcBef>
-                <a:spcPct val="20000"/>
-              </a:spcBef>
-              <a:buFont typeface="Arial" panose="020B0604020202020204" pitchFamily="34" charset="0"/>
-              <a:buChar char="•"/>
-              <a:defRPr sz="2000" kern="1200">
-                <a:solidFill>
-                  <a:schemeClr val="tx1"/>
-                </a:solidFill>
-                <a:latin typeface="+mn-lt"/>
-                <a:ea typeface="+mn-ea"/>
-                <a:cs typeface="+mn-cs"/>
-              </a:defRPr>
-            </a:lvl9pPr>
-          </a:lstStyle>
-          <a:p>
-            <a:pPr marL="0" indent="0" algn="just">
-              <a:buFont typeface="Arial" panose="020B0604020202020204" pitchFamily="34" charset="0"/>
-              <a:buNone/>
-            </a:pPr>
-            <a:endParaRPr lang="en-US" sz="2000" i="1"/>
-          </a:p>
-        </p:txBody>
-      </p:sp>
-      <p:sp>
-        <p:nvSpPr>
-          <p:cNvPr id="10" name="Rectangle 9"/>
-          <p:cNvSpPr/>
-          <p:nvPr/>
-        </p:nvSpPr>
-        <p:spPr>
-          <a:xfrm>
-            <a:off x="1159416" y="980728"/>
-            <a:ext cx="7949088" cy="646331"/>
-          </a:xfrm>
-          <a:prstGeom prst="rect">
-            <a:avLst/>
-          </a:prstGeom>
-        </p:spPr>
-        <p:txBody>
-          <a:bodyPr wrap="square">
-            <a:spAutoFit/>
-          </a:bodyPr>
-          <a:lstStyle/>
-          <a:p>
-            <a:pPr>
-              <a:buFont typeface="Arial" panose="020B0604020202020204" pitchFamily="34" charset="0"/>
-              <a:buChar char="•"/>
-            </a:pPr>
-            <a:r>
-              <a:rPr lang="es-ES" sz="1200" dirty="0">
-                <a:solidFill>
-                  <a:srgbClr val="222222"/>
-                </a:solidFill>
-                <a:latin typeface="Segoe UI" panose="020B0502040204020203" pitchFamily="34" charset="0"/>
-              </a:rPr>
-              <a:t> Si los datos capturados en la pantalla anterior son correctos se mostraran las pieles disponibles en el folio para devolución, nota: </a:t>
-            </a:r>
-            <a:r>
-              <a:rPr lang="es-ES" sz="1200" b="1" dirty="0">
-                <a:solidFill>
-                  <a:srgbClr val="222222"/>
-                </a:solidFill>
-                <a:latin typeface="Segoe UI" panose="020B0502040204020203" pitchFamily="34" charset="0"/>
-              </a:rPr>
-              <a:t>si las pieles ya están cortadas completas no estarán disponibles para devolución</a:t>
-            </a:r>
-            <a:r>
-              <a:rPr lang="es-ES" sz="1200" dirty="0">
-                <a:solidFill>
-                  <a:srgbClr val="222222"/>
-                </a:solidFill>
-                <a:latin typeface="Segoe UI" panose="020B0502040204020203" pitchFamily="34" charset="0"/>
-              </a:rPr>
-              <a:t>, para marcar la piel para devolución solo tiene que presionar la tecla (</a:t>
-            </a:r>
-            <a:r>
-              <a:rPr lang="es-ES" sz="1200" b="1" dirty="0">
-                <a:solidFill>
-                  <a:srgbClr val="222222"/>
-                </a:solidFill>
-                <a:latin typeface="Segoe UI" panose="020B0502040204020203" pitchFamily="34" charset="0"/>
-              </a:rPr>
-              <a:t>Espaciadora</a:t>
-            </a:r>
-            <a:r>
-              <a:rPr lang="es-ES" sz="1200" dirty="0">
-                <a:solidFill>
-                  <a:srgbClr val="222222"/>
-                </a:solidFill>
-                <a:latin typeface="Segoe UI" panose="020B0502040204020203" pitchFamily="34" charset="0"/>
-              </a:rPr>
-              <a:t>).</a:t>
-            </a:r>
-            <a:endParaRPr lang="es-ES" sz="1200" b="0" i="0" dirty="0">
-              <a:solidFill>
-                <a:srgbClr val="222222"/>
-              </a:solidFill>
-              <a:effectLst/>
-              <a:latin typeface="Segoe UI" panose="020B0502040204020203" pitchFamily="34" charset="0"/>
-            </a:endParaRPr>
-          </a:p>
-        </p:txBody>
-      </p:sp>
-      <p:pic>
-        <p:nvPicPr>
-          <p:cNvPr id="3" name="Imagen 2" descr="Interfaz de usuario gráfica, Aplicación, Word&#10;&#10;Descripción generada automáticamente">
-            <a:extLst>
-              <a:ext uri="{FF2B5EF4-FFF2-40B4-BE49-F238E27FC236}">
-                <a16:creationId xmlns:a16="http://schemas.microsoft.com/office/drawing/2014/main" id="{C81FC5EE-0741-41A7-A947-7DA92E9F3FD6}"/>
-              </a:ext>
-            </a:extLst>
-          </p:cNvPr>
-          <p:cNvPicPr>
-            <a:picLocks noChangeAspect="1"/>
-          </p:cNvPicPr>
-          <p:nvPr/>
-        </p:nvPicPr>
-        <p:blipFill>
-          <a:blip r:embed="rId2">
-            <a:extLst>
-              <a:ext uri="{28A0092B-C50C-407E-A947-70E740481C1C}">
-                <a14:useLocalDpi xmlns:a14="http://schemas.microsoft.com/office/drawing/2010/main" val="0"/>
-              </a:ext>
-            </a:extLst>
-          </a:blip>
-          <a:stretch>
-            <a:fillRect/>
-          </a:stretch>
-        </p:blipFill>
-        <p:spPr>
-          <a:xfrm>
-            <a:off x="1159416" y="1627058"/>
-            <a:ext cx="7949088" cy="5186317"/>
-          </a:xfrm>
-          <a:prstGeom prst="rect">
-            <a:avLst/>
-          </a:prstGeom>
-        </p:spPr>
-      </p:pic>
-    </p:spTree>
-    <p:extLst>
-      <p:ext uri="{BB962C8B-B14F-4D97-AF65-F5344CB8AC3E}">
-        <p14:creationId xmlns:p14="http://schemas.microsoft.com/office/powerpoint/2010/main" val="287871341"/>
       </p:ext>
     </p:extLst>
   </p:cSld>

</xml_diff>